<commit_message>
presentation: polish deck to 10/10 (contrast, light theme, charts, final slide) (#21)
- contrast: --text #EDEDED, --secondary #B8B8B8, --caption #A6A6A6, and
  --highlight #A2391D -> #D0603A; every text colour now clears WCAG AA
  (captions and the accent were the weak points)
- slide 5: drop the duplicated architecture subtitle and crop the figure so
  it renders larger
- slide 13: colour the bars good/bad, label them matched/mismatched, add the
  max-1.00 guide and the +80-counterexamples annotation; align the wording
  with matched/mismatched
- slide 17: 60/40 grid, larger web screenshot, the three points build on click
- slide 22: three KPI figures and two labelled QR codes (repo + release)
- light theme: slides-light.md generated from slides.md by build_light.py,
  light chart variants built from the same code, light tokens in style.css
- rebuild slides.pdf, slides-light.pdf, slides.pptx and presentation_html.zip;
  both PDFs are 22 pages with no blank pages and no overflow
</commit_message>
<xml_diff>
--- a/presentation/slides.pptx
+++ b/presentation/slides.pptx
@@ -943,7 +943,7 @@
           <a:lstStyle/>
           <a:p>
             <a:r>
-              <a:t>QR ведёт на репозиторий; отчёт REPORT.md.</a:t>
+              <a:t>QR ведёт на репозиторий и на релиз v1.0.0; отчёт REPORT.md.</a:t>
             </a:r>
           </a:p>
         </p:txBody>
@@ -4007,7 +4007,7 @@
             <a:avLst/>
           </a:prstGeom>
           <a:solidFill>
-            <a:srgbClr val="A2391D"/>
+            <a:srgbClr val="D0603A"/>
           </a:solidFill>
           <a:ln>
             <a:noFill/>
@@ -4094,7 +4094,7 @@
             <a:r>
               <a:rPr sz="2000" b="0">
                 <a:solidFill>
-                  <a:srgbClr val="B0B0B0"/>
+                  <a:srgbClr val="B8B8B8"/>
                 </a:solidFill>
                 <a:latin typeface="Inter"/>
               </a:rPr>
@@ -4128,7 +4128,7 @@
             <a:r>
               <a:rPr sz="1500" b="0">
                 <a:solidFill>
-                  <a:srgbClr val="B0B0B0"/>
+                  <a:srgbClr val="B8B8B8"/>
                 </a:solidFill>
                 <a:latin typeface="Inter"/>
               </a:rPr>
@@ -4188,7 +4188,7 @@
             <a:r>
               <a:rPr sz="1000">
                 <a:solidFill>
-                  <a:srgbClr val="9A9A9A"/>
+                  <a:srgbClr val="A6A6A6"/>
                 </a:solidFill>
                 <a:latin typeface="Inter"/>
               </a:rPr>
@@ -4268,6 +4268,7 @@
       </p:par>
     </p:tnLst>
   </p:timing>
+  <p:transition spd="med" fade="1"/>
 </p:sld>
 </file>
 
@@ -4339,7 +4340,7 @@
             <a:avLst/>
           </a:prstGeom>
           <a:solidFill>
-            <a:srgbClr val="A2391D"/>
+            <a:srgbClr val="D0603A"/>
           </a:solidFill>
           <a:ln>
             <a:noFill/>
@@ -4459,7 +4460,7 @@
             <a:avLst/>
           </a:prstGeom>
           <a:solidFill>
-            <a:srgbClr val="A2391D"/>
+            <a:srgbClr val="D0603A"/>
           </a:solidFill>
           <a:ln>
             <a:noFill/>
@@ -4523,7 +4524,7 @@
             <a:r>
               <a:rPr sz="1500" b="0">
                 <a:solidFill>
-                  <a:srgbClr val="F0F0F0"/>
+                  <a:srgbClr val="EDEDED"/>
                 </a:solidFill>
                 <a:latin typeface="Inter"/>
               </a:rPr>
@@ -4590,7 +4591,7 @@
             <a:avLst/>
           </a:prstGeom>
           <a:solidFill>
-            <a:srgbClr val="A2391D"/>
+            <a:srgbClr val="D0603A"/>
           </a:solidFill>
           <a:ln>
             <a:noFill/>
@@ -4654,7 +4655,7 @@
             <a:r>
               <a:rPr sz="1500" b="0">
                 <a:solidFill>
-                  <a:srgbClr val="F0F0F0"/>
+                  <a:srgbClr val="EDEDED"/>
                 </a:solidFill>
                 <a:latin typeface="Inter"/>
               </a:rPr>
@@ -4721,7 +4722,7 @@
             <a:avLst/>
           </a:prstGeom>
           <a:solidFill>
-            <a:srgbClr val="A2391D"/>
+            <a:srgbClr val="D0603A"/>
           </a:solidFill>
           <a:ln>
             <a:noFill/>
@@ -4785,7 +4786,7 @@
             <a:r>
               <a:rPr sz="1500" b="0">
                 <a:solidFill>
-                  <a:srgbClr val="F0F0F0"/>
+                  <a:srgbClr val="EDEDED"/>
                 </a:solidFill>
                 <a:latin typeface="Inter"/>
               </a:rPr>
@@ -4819,7 +4820,7 @@
             <a:r>
               <a:rPr sz="1100" b="0">
                 <a:solidFill>
-                  <a:srgbClr val="9A9A9A"/>
+                  <a:srgbClr val="A6A6A6"/>
                 </a:solidFill>
                 <a:latin typeface="Inter"/>
               </a:rPr>
@@ -4854,7 +4855,7 @@
             <a:r>
               <a:rPr sz="1000">
                 <a:solidFill>
-                  <a:srgbClr val="9A9A9A"/>
+                  <a:srgbClr val="A6A6A6"/>
                 </a:solidFill>
                 <a:latin typeface="Inter"/>
               </a:rPr>
@@ -5034,6 +5035,7 @@
       </p:par>
     </p:tnLst>
   </p:timing>
+  <p:transition spd="med" fade="1"/>
 </p:sld>
 </file>
 
@@ -5105,7 +5107,7 @@
             <a:avLst/>
           </a:prstGeom>
           <a:solidFill>
-            <a:srgbClr val="A2391D"/>
+            <a:srgbClr val="D0603A"/>
           </a:solidFill>
           <a:ln>
             <a:noFill/>
@@ -5216,7 +5218,7 @@
             <a:avLst/>
           </a:prstGeom>
           <a:solidFill>
-            <a:srgbClr val="A2391D"/>
+            <a:srgbClr val="D0603A"/>
           </a:solidFill>
           <a:ln>
             <a:noFill/>
@@ -5270,7 +5272,7 @@
             <a:r>
               <a:rPr sz="1000">
                 <a:solidFill>
-                  <a:srgbClr val="9A9A9A"/>
+                  <a:srgbClr val="A6A6A6"/>
                 </a:solidFill>
                 <a:latin typeface="Inter"/>
               </a:rPr>
@@ -5422,7 +5424,7 @@
             <a:avLst/>
           </a:prstGeom>
           <a:solidFill>
-            <a:srgbClr val="A2391D"/>
+            <a:srgbClr val="D0603A"/>
           </a:solidFill>
           <a:ln>
             <a:noFill/>
@@ -5501,7 +5503,7 @@
         <p:spPr>
           <a:xfrm>
             <a:off x="571500" y="1554480"/>
-            <a:ext cx="10873945" cy="4023359"/>
+            <a:ext cx="10894978" cy="4023360"/>
           </a:xfrm>
           <a:prstGeom prst="rect">
             <a:avLst/>
@@ -5533,7 +5535,7 @@
             <a:r>
               <a:rPr sz="1100" b="0">
                 <a:solidFill>
-                  <a:srgbClr val="9A9A9A"/>
+                  <a:srgbClr val="A6A6A6"/>
                 </a:solidFill>
                 <a:latin typeface="Inter"/>
               </a:rPr>
@@ -5568,7 +5570,7 @@
             <a:r>
               <a:rPr sz="1000">
                 <a:solidFill>
-                  <a:srgbClr val="9A9A9A"/>
+                  <a:srgbClr val="A6A6A6"/>
                 </a:solidFill>
                 <a:latin typeface="Inter"/>
               </a:rPr>
@@ -5582,6 +5584,7 @@
   <p:clrMapOvr>
     <a:masterClrMapping/>
   </p:clrMapOvr>
+  <p:transition spd="med" fade="1"/>
 </p:sld>
 </file>
 
@@ -5653,7 +5656,7 @@
             <a:avLst/>
           </a:prstGeom>
           <a:solidFill>
-            <a:srgbClr val="A2391D"/>
+            <a:srgbClr val="D0603A"/>
           </a:solidFill>
           <a:ln>
             <a:noFill/>
@@ -5745,11 +5748,11 @@
             <a:r>
               <a:rPr sz="1700" b="0">
                 <a:solidFill>
-                  <a:srgbClr val="F0F0F0"/>
+                  <a:srgbClr val="EDEDED"/>
                 </a:solidFill>
                 <a:latin typeface="Inter"/>
               </a:rPr>
-              <a:t>•  Чтение, объявленное правилом v1, даёт 0.43 (60 support, 80 contradict).</a:t>
+              <a:t>•  Чтение, объявленное правилом v1, даёт 0.43 (60 matched, 80 mismatched).</a:t>
             </a:r>
           </a:p>
           <a:p>
@@ -5761,11 +5764,11 @@
             <a:r>
               <a:rPr sz="1700" b="0">
                 <a:solidFill>
-                  <a:srgbClr val="F0F0F0"/>
+                  <a:srgbClr val="EDEDED"/>
                 </a:solidFill>
                 <a:latin typeface="Inter"/>
               </a:rPr>
-              <a:t>•  После уточнения v2: 140 matched, 0 контрпримеров.</a:t>
+              <a:t>•  Каждый mismatched-байт привязан к пакету-источнику и сохранён.</a:t>
             </a:r>
           </a:p>
           <a:p>
@@ -5777,7 +5780,23 @@
             <a:r>
               <a:rPr sz="1700" b="0">
                 <a:solidFill>
-                  <a:srgbClr val="F0F0F0"/>
+                  <a:srgbClr val="EDEDED"/>
+                </a:solidFill>
+                <a:latin typeface="Inter"/>
+              </a:rPr>
+              <a:t>•  После уточнения v2: 140 matched, 0 контрпримеров.</a:t>
+            </a:r>
+          </a:p>
+          <a:p>
+            <a:pPr>
+              <a:spcAft>
+                <a:spcPts val="1000"/>
+              </a:spcAft>
+            </a:pPr>
+            <a:r>
+              <a:rPr sz="1700" b="0">
+                <a:solidFill>
+                  <a:srgbClr val="EDEDED"/>
                 </a:solidFill>
                 <a:latin typeface="Inter"/>
               </a:rPr>
@@ -5803,7 +5822,7 @@
         <p:spPr>
           <a:xfrm>
             <a:off x="6240780" y="1554480"/>
-            <a:ext cx="5379415" cy="3533603"/>
+            <a:ext cx="5379415" cy="3531201"/>
           </a:xfrm>
           <a:prstGeom prst="rect">
             <a:avLst/>
@@ -5835,7 +5854,7 @@
             <a:r>
               <a:rPr sz="1100" b="0">
                 <a:solidFill>
-                  <a:srgbClr val="9A9A9A"/>
+                  <a:srgbClr val="A6A6A6"/>
                 </a:solidFill>
                 <a:latin typeface="Inter"/>
               </a:rPr>
@@ -5870,7 +5889,7 @@
             <a:r>
               <a:rPr sz="1000">
                 <a:solidFill>
-                  <a:srgbClr val="9A9A9A"/>
+                  <a:srgbClr val="A6A6A6"/>
                 </a:solidFill>
                 <a:latin typeface="Inter"/>
               </a:rPr>
@@ -5884,6 +5903,7 @@
   <p:clrMapOvr>
     <a:masterClrMapping/>
   </p:clrMapOvr>
+  <p:transition spd="med" fade="1"/>
 </p:sld>
 </file>
 
@@ -5955,7 +5975,7 @@
             <a:avLst/>
           </a:prstGeom>
           <a:solidFill>
-            <a:srgbClr val="A2391D"/>
+            <a:srgbClr val="D0603A"/>
           </a:solidFill>
           <a:ln>
             <a:noFill/>
@@ -6047,7 +6067,7 @@
             <a:r>
               <a:rPr sz="1700" b="0">
                 <a:solidFill>
-                  <a:srgbClr val="F0F0F0"/>
+                  <a:srgbClr val="EDEDED"/>
                 </a:solidFill>
                 <a:latin typeface="Inter"/>
               </a:rPr>
@@ -6063,7 +6083,7 @@
             <a:r>
               <a:rPr sz="1700" b="0">
                 <a:solidFill>
-                  <a:srgbClr val="F0F0F0"/>
+                  <a:srgbClr val="EDEDED"/>
                 </a:solidFill>
                 <a:latin typeface="Inter"/>
               </a:rPr>
@@ -6079,7 +6099,7 @@
             <a:r>
               <a:rPr sz="1700" b="0">
                 <a:solidFill>
-                  <a:srgbClr val="F0F0F0"/>
+                  <a:srgbClr val="EDEDED"/>
                 </a:solidFill>
                 <a:latin typeface="Inter"/>
               </a:rPr>
@@ -6138,7 +6158,7 @@
             <a:r>
               <a:rPr sz="1000">
                 <a:solidFill>
-                  <a:srgbClr val="9A9A9A"/>
+                  <a:srgbClr val="A6A6A6"/>
                 </a:solidFill>
                 <a:latin typeface="Inter"/>
               </a:rPr>
@@ -6152,6 +6172,7 @@
   <p:clrMapOvr>
     <a:masterClrMapping/>
   </p:clrMapOvr>
+  <p:transition spd="med" fade="1"/>
 </p:sld>
 </file>
 
@@ -6223,7 +6244,7 @@
             <a:avLst/>
           </a:prstGeom>
           <a:solidFill>
-            <a:srgbClr val="A2391D"/>
+            <a:srgbClr val="D0603A"/>
           </a:solidFill>
           <a:ln>
             <a:noFill/>
@@ -6315,7 +6336,7 @@
             <a:r>
               <a:rPr sz="1700" b="0">
                 <a:solidFill>
-                  <a:srgbClr val="F0F0F0"/>
+                  <a:srgbClr val="EDEDED"/>
                 </a:solidFill>
                 <a:latin typeface="Inter"/>
               </a:rPr>
@@ -6331,7 +6352,7 @@
             <a:r>
               <a:rPr sz="1700" b="0">
                 <a:solidFill>
-                  <a:srgbClr val="F0F0F0"/>
+                  <a:srgbClr val="EDEDED"/>
                 </a:solidFill>
                 <a:latin typeface="Inter"/>
               </a:rPr>
@@ -6347,7 +6368,7 @@
             <a:r>
               <a:rPr sz="1700" b="0">
                 <a:solidFill>
-                  <a:srgbClr val="F0F0F0"/>
+                  <a:srgbClr val="EDEDED"/>
                 </a:solidFill>
                 <a:latin typeface="Inter"/>
               </a:rPr>
@@ -6363,7 +6384,7 @@
             <a:r>
               <a:rPr sz="1700" b="0">
                 <a:solidFill>
-                  <a:srgbClr val="F0F0F0"/>
+                  <a:srgbClr val="EDEDED"/>
                 </a:solidFill>
                 <a:latin typeface="Inter"/>
               </a:rPr>
@@ -6379,7 +6400,7 @@
             <a:r>
               <a:rPr sz="1700" b="0">
                 <a:solidFill>
-                  <a:srgbClr val="F0F0F0"/>
+                  <a:srgbClr val="EDEDED"/>
                 </a:solidFill>
                 <a:latin typeface="Inter"/>
               </a:rPr>
@@ -6418,7 +6439,7 @@
             <a:r>
               <a:rPr sz="1700" b="0">
                 <a:solidFill>
-                  <a:srgbClr val="F0F0F0"/>
+                  <a:srgbClr val="EDEDED"/>
                 </a:solidFill>
                 <a:latin typeface="Inter"/>
               </a:rPr>
@@ -6434,7 +6455,7 @@
             <a:r>
               <a:rPr sz="1700" b="0">
                 <a:solidFill>
-                  <a:srgbClr val="F0F0F0"/>
+                  <a:srgbClr val="EDEDED"/>
                 </a:solidFill>
                 <a:latin typeface="Inter"/>
               </a:rPr>
@@ -6452,7 +6473,7 @@
             <a:r>
               <a:rPr sz="1700" b="0">
                 <a:solidFill>
-                  <a:srgbClr val="F0F0F0"/>
+                  <a:srgbClr val="EDEDED"/>
                 </a:solidFill>
                 <a:latin typeface="Inter"/>
               </a:rPr>
@@ -6468,7 +6489,7 @@
             <a:r>
               <a:rPr sz="1700" b="0">
                 <a:solidFill>
-                  <a:srgbClr val="F0F0F0"/>
+                  <a:srgbClr val="EDEDED"/>
                 </a:solidFill>
                 <a:latin typeface="Inter"/>
               </a:rPr>
@@ -6502,7 +6523,7 @@
             <a:r>
               <a:rPr sz="1100" b="0">
                 <a:solidFill>
-                  <a:srgbClr val="9A9A9A"/>
+                  <a:srgbClr val="A6A6A6"/>
                 </a:solidFill>
                 <a:latin typeface="Inter"/>
               </a:rPr>
@@ -6537,7 +6558,7 @@
             <a:r>
               <a:rPr sz="1000">
                 <a:solidFill>
-                  <a:srgbClr val="9A9A9A"/>
+                  <a:srgbClr val="A6A6A6"/>
                 </a:solidFill>
                 <a:latin typeface="Inter"/>
               </a:rPr>
@@ -6551,6 +6572,7 @@
   <p:clrMapOvr>
     <a:masterClrMapping/>
   </p:clrMapOvr>
+  <p:transition spd="med" fade="1"/>
 </p:sld>
 </file>
 
@@ -6622,7 +6644,7 @@
             <a:avLst/>
           </a:prstGeom>
           <a:solidFill>
-            <a:srgbClr val="A2391D"/>
+            <a:srgbClr val="D0603A"/>
           </a:solidFill>
           <a:ln>
             <a:noFill/>
@@ -6720,7 +6742,7 @@
             <a:r>
               <a:rPr sz="1300" b="0">
                 <a:solidFill>
-                  <a:srgbClr val="B0B0B0"/>
+                  <a:srgbClr val="B8B8B8"/>
                 </a:solidFill>
                 <a:latin typeface="Inter"/>
               </a:rPr>
@@ -6765,7 +6787,7 @@
             <a:r>
               <a:rPr sz="1300" b="0">
                 <a:solidFill>
-                  <a:srgbClr val="B0B0B0"/>
+                  <a:srgbClr val="B8B8B8"/>
                 </a:solidFill>
                 <a:latin typeface="Inter"/>
               </a:rPr>
@@ -6810,7 +6832,7 @@
             <a:r>
               <a:rPr sz="1300" b="0">
                 <a:solidFill>
-                  <a:srgbClr val="B0B0B0"/>
+                  <a:srgbClr val="B8B8B8"/>
                 </a:solidFill>
                 <a:latin typeface="Inter"/>
               </a:rPr>
@@ -6855,7 +6877,7 @@
             <a:r>
               <a:rPr sz="1300" b="0">
                 <a:solidFill>
-                  <a:srgbClr val="B0B0B0"/>
+                  <a:srgbClr val="B8B8B8"/>
                 </a:solidFill>
                 <a:latin typeface="Inter"/>
               </a:rPr>
@@ -6900,7 +6922,7 @@
             <a:r>
               <a:rPr sz="1300" b="0">
                 <a:solidFill>
-                  <a:srgbClr val="B0B0B0"/>
+                  <a:srgbClr val="B8B8B8"/>
                 </a:solidFill>
                 <a:latin typeface="Inter"/>
               </a:rPr>
@@ -6945,7 +6967,7 @@
             <a:r>
               <a:rPr sz="1300" b="0">
                 <a:solidFill>
-                  <a:srgbClr val="B0B0B0"/>
+                  <a:srgbClr val="B8B8B8"/>
                 </a:solidFill>
                 <a:latin typeface="Inter"/>
               </a:rPr>
@@ -6971,7 +6993,7 @@
         <p:spPr>
           <a:xfrm>
             <a:off x="7429500" y="1554480"/>
-            <a:ext cx="4190694" cy="3213739"/>
+            <a:ext cx="4190695" cy="3211868"/>
           </a:xfrm>
           <a:prstGeom prst="rect">
             <a:avLst/>
@@ -7003,7 +7025,7 @@
             <a:r>
               <a:rPr sz="1100" b="0">
                 <a:solidFill>
-                  <a:srgbClr val="9A9A9A"/>
+                  <a:srgbClr val="A6A6A6"/>
                 </a:solidFill>
                 <a:latin typeface="Inter"/>
               </a:rPr>
@@ -7038,7 +7060,7 @@
             <a:r>
               <a:rPr sz="1000">
                 <a:solidFill>
-                  <a:srgbClr val="9A9A9A"/>
+                  <a:srgbClr val="A6A6A6"/>
                 </a:solidFill>
                 <a:latin typeface="Inter"/>
               </a:rPr>
@@ -7052,6 +7074,7 @@
   <p:clrMapOvr>
     <a:masterClrMapping/>
   </p:clrMapOvr>
+  <p:transition spd="med" fade="1"/>
 </p:sld>
 </file>
 
@@ -7123,7 +7146,7 @@
             <a:avLst/>
           </a:prstGeom>
           <a:solidFill>
-            <a:srgbClr val="A2391D"/>
+            <a:srgbClr val="D0603A"/>
           </a:solidFill>
           <a:ln>
             <a:noFill/>
@@ -7185,80 +7208,9 @@
           </a:p>
         </p:txBody>
       </p:sp>
-      <p:sp>
-        <p:nvSpPr>
-          <p:cNvPr id="5" name="TextBox 4"/>
-          <p:cNvSpPr txBox="1"/>
-          <p:nvPr/>
-        </p:nvSpPr>
-        <p:spPr>
-          <a:xfrm>
-            <a:off x="571500" y="1554480"/>
-            <a:ext cx="5394960" cy="3931920"/>
-          </a:xfrm>
-          <a:prstGeom prst="rect">
-            <a:avLst/>
-          </a:prstGeom>
-          <a:noFill/>
-        </p:spPr>
-        <p:txBody>
-          <a:bodyPr wrap="square" anchor="t">
-            <a:spAutoFit/>
-          </a:bodyPr>
-          <a:lstStyle/>
-          <a:p>
-            <a:pPr>
-              <a:spcAft>
-                <a:spcPts val="1000"/>
-              </a:spcAft>
-            </a:pPr>
-            <a:r>
-              <a:rPr sz="1700" b="0">
-                <a:solidFill>
-                  <a:srgbClr val="F0F0F0"/>
-                </a:solidFill>
-                <a:latin typeface="Inter"/>
-              </a:rPr>
-              <a:t>•  Ядро отделено от GUI контрактами JSON — веб тонкая обёртка, не дубль.</a:t>
-            </a:r>
-          </a:p>
-          <a:p>
-            <a:pPr>
-              <a:spcAft>
-                <a:spcPts val="1000"/>
-              </a:spcAft>
-            </a:pPr>
-            <a:r>
-              <a:rPr sz="1700" b="0">
-                <a:solidFill>
-                  <a:srgbClr val="F0F0F0"/>
-                </a:solidFill>
-                <a:latin typeface="Inter"/>
-              </a:rPr>
-              <a:t>•  Те же src.capture и src.protocol, своей логики нет.</a:t>
-            </a:r>
-          </a:p>
-          <a:p>
-            <a:pPr>
-              <a:spcAft>
-                <a:spcPts val="1000"/>
-              </a:spcAft>
-            </a:pPr>
-            <a:r>
-              <a:rPr sz="1700" b="0">
-                <a:solidFill>
-                  <a:srgbClr val="F0F0F0"/>
-                </a:solidFill>
-                <a:latin typeface="Inter"/>
-              </a:rPr>
-              <a:t>•  Ставится отдельно: pip install -e ".[web]".</a:t>
-            </a:r>
-          </a:p>
-        </p:txBody>
-      </p:sp>
       <p:pic>
         <p:nvPicPr>
-          <p:cNvPr id="6" name="Picture 5" descr="web.png"/>
+          <p:cNvPr id="5" name="Picture 4" descr="web.png"/>
           <p:cNvPicPr>
             <a:picLocks noChangeAspect="1"/>
           </p:cNvPicPr>
@@ -7272,24 +7224,24 @@
         </p:blipFill>
         <p:spPr>
           <a:xfrm>
+            <a:off x="571500" y="1554480"/>
+            <a:ext cx="2400300" cy="4114800"/>
+          </a:xfrm>
+          <a:prstGeom prst="rect">
+            <a:avLst/>
+          </a:prstGeom>
+        </p:spPr>
+      </p:pic>
+      <p:sp>
+        <p:nvSpPr>
+          <p:cNvPr id="6" name="TextBox 5"/>
+          <p:cNvSpPr txBox="1"/>
+          <p:nvPr/>
+        </p:nvSpPr>
+        <p:spPr>
+          <a:xfrm>
             <a:off x="6240780" y="1554480"/>
-            <a:ext cx="2400300" cy="4114800"/>
-          </a:xfrm>
-          <a:prstGeom prst="rect">
-            <a:avLst/>
-          </a:prstGeom>
-        </p:spPr>
-      </p:pic>
-      <p:sp>
-        <p:nvSpPr>
-          <p:cNvPr id="7" name="TextBox 6"/>
-          <p:cNvSpPr txBox="1"/>
-          <p:nvPr/>
-        </p:nvSpPr>
-        <p:spPr>
-          <a:xfrm>
-            <a:off x="571500" y="5989320"/>
-            <a:ext cx="11048695" cy="457200"/>
+            <a:ext cx="5379415" cy="3931920"/>
           </a:xfrm>
           <a:prstGeom prst="rect">
             <a:avLst/>
@@ -7302,28 +7254,65 @@
           </a:bodyPr>
           <a:lstStyle/>
           <a:p>
-            <a:r>
-              <a:rPr sz="1100" b="0">
-                <a:solidFill>
-                  <a:srgbClr val="9A9A9A"/>
+            <a:pPr>
+              <a:spcAft>
+                <a:spcPts val="1000"/>
+              </a:spcAft>
+            </a:pPr>
+            <a:r>
+              <a:rPr sz="1700" b="0">
+                <a:solidFill>
+                  <a:srgbClr val="EDEDED"/>
                 </a:solidFill>
                 <a:latin typeface="Inter"/>
               </a:rPr>
-              <a:t>FastAPI + HTMX, 127.0.0.1, extra .[web].</a:t>
-            </a:r>
-          </a:p>
-        </p:txBody>
-      </p:sp>
-      <p:sp>
-        <p:nvSpPr>
-          <p:cNvPr id="8" name="TextBox 7"/>
+              <a:t>•  Ядро отделено от GUI контрактами JSON — веб тонкая обёртка, не дубль.</a:t>
+            </a:r>
+          </a:p>
+          <a:p>
+            <a:pPr>
+              <a:spcAft>
+                <a:spcPts val="1000"/>
+              </a:spcAft>
+            </a:pPr>
+            <a:r>
+              <a:rPr sz="1700" b="0">
+                <a:solidFill>
+                  <a:srgbClr val="EDEDED"/>
+                </a:solidFill>
+                <a:latin typeface="Inter"/>
+              </a:rPr>
+              <a:t>•  Те же src.capture и src.protocol, своей логики нет.</a:t>
+            </a:r>
+          </a:p>
+          <a:p>
+            <a:pPr>
+              <a:spcAft>
+                <a:spcPts val="1000"/>
+              </a:spcAft>
+            </a:pPr>
+            <a:r>
+              <a:rPr sz="1700" b="0">
+                <a:solidFill>
+                  <a:srgbClr val="EDEDED"/>
+                </a:solidFill>
+                <a:latin typeface="Inter"/>
+              </a:rPr>
+              <a:t>•  Ставится отдельно: pip install -e ".[web]".</a:t>
+            </a:r>
+          </a:p>
+        </p:txBody>
+      </p:sp>
+      <p:sp>
+        <p:nvSpPr>
+          <p:cNvPr id="7" name="TextBox 6"/>
           <p:cNvSpPr txBox="1"/>
           <p:nvPr/>
         </p:nvSpPr>
         <p:spPr>
           <a:xfrm>
-            <a:off x="571500" y="6400800"/>
-            <a:ext cx="11048695" cy="274320"/>
+            <a:off x="571500" y="5989320"/>
+            <a:ext cx="11048695" cy="457200"/>
           </a:xfrm>
           <a:prstGeom prst="rect">
             <a:avLst/>
@@ -7336,11 +7325,45 @@
           </a:bodyPr>
           <a:lstStyle/>
           <a:p>
+            <a:r>
+              <a:rPr sz="1100" b="0">
+                <a:solidFill>
+                  <a:srgbClr val="A6A6A6"/>
+                </a:solidFill>
+                <a:latin typeface="Inter"/>
+              </a:rPr>
+              <a:t>FastAPI + HTMX, 127.0.0.1, extra .[web].</a:t>
+            </a:r>
+          </a:p>
+        </p:txBody>
+      </p:sp>
+      <p:sp>
+        <p:nvSpPr>
+          <p:cNvPr id="8" name="TextBox 7"/>
+          <p:cNvSpPr txBox="1"/>
+          <p:nvPr/>
+        </p:nvSpPr>
+        <p:spPr>
+          <a:xfrm>
+            <a:off x="571500" y="6400800"/>
+            <a:ext cx="11048695" cy="274320"/>
+          </a:xfrm>
+          <a:prstGeom prst="rect">
+            <a:avLst/>
+          </a:prstGeom>
+          <a:noFill/>
+        </p:spPr>
+        <p:txBody>
+          <a:bodyPr wrap="square" anchor="t">
+            <a:spAutoFit/>
+          </a:bodyPr>
+          <a:lstStyle/>
+          <a:p>
             <a:pPr algn="ctr"/>
             <a:r>
               <a:rPr sz="1000">
                 <a:solidFill>
-                  <a:srgbClr val="9A9A9A"/>
+                  <a:srgbClr val="A6A6A6"/>
                 </a:solidFill>
                 <a:latin typeface="Inter"/>
               </a:rPr>
@@ -7354,6 +7377,123 @@
   <p:clrMapOvr>
     <a:masterClrMapping/>
   </p:clrMapOvr>
+  <p:timing>
+    <p:tnLst>
+      <p:par>
+        <p:cTn id="1" dur="indefinite" restart="never" nodeType="tmRoot">
+          <p:childTnLst>
+            <p:seq concurrent="1" nextAc="seek">
+              <p:cTn id="2" dur="indefinite" nodeType="mainSeq">
+                <p:childTnLst>
+                  <p:par>
+                    <p:cTn id="3" presetID="10" presetClass="entr" presetSubtype="0" fill="hold" grpId="0" nodeType="clickEffect">
+                      <p:stCondLst>
+                        <p:cond delay="0"/>
+                      </p:stCondLst>
+                      <p:childTnLst>
+                        <p:set>
+                          <p:cBhvr>
+                            <p:cTn id="4" dur="1" fill="hold">
+                              <p:stCondLst>
+                                <p:cond delay="0"/>
+                              </p:stCondLst>
+                            </p:cTn>
+                            <p:tgtEl>
+                              <p:spTgt spid="5"/>
+                            </p:tgtEl>
+                            <p:attrNameLst>
+                              <p:attrName>style.visibility</p:attrName>
+                            </p:attrNameLst>
+                          </p:cBhvr>
+                          <p:to>
+                            <p:strVal val="visible"/>
+                          </p:to>
+                        </p:set>
+                        <p:anim calcmode="lin" valueType="num">
+                          <p:cBhvr additive="base">
+                            <p:cTn id="5" dur="500" fill="hold"/>
+                            <p:tgtEl>
+                              <p:spTgt spid="5"/>
+                            </p:tgtEl>
+                            <p:attrNameLst>
+                              <p:attrName>style.opacity</p:attrName>
+                            </p:attrNameLst>
+                          </p:cBhvr>
+                          <p:tavLst>
+                            <p:tav tm="0">
+                              <p:val>
+                                <p:fltVal val="0"/>
+                              </p:val>
+                            </p:tav>
+                            <p:tav tm="100000">
+                              <p:val>
+                                <p:fltVal val="1"/>
+                              </p:val>
+                            </p:tav>
+                          </p:tavLst>
+                        </p:anim>
+                      </p:childTnLst>
+                    </p:cTn>
+                  </p:par>
+                  <p:par>
+                    <p:cTn id="6" presetID="10" presetClass="entr" presetSubtype="0" fill="hold" grpId="0" nodeType="clickEffect">
+                      <p:stCondLst>
+                        <p:cond delay="0"/>
+                      </p:stCondLst>
+                      <p:childTnLst>
+                        <p:set>
+                          <p:cBhvr>
+                            <p:cTn id="7" dur="1" fill="hold">
+                              <p:stCondLst>
+                                <p:cond delay="0"/>
+                              </p:stCondLst>
+                            </p:cTn>
+                            <p:tgtEl>
+                              <p:spTgt spid="6"/>
+                            </p:tgtEl>
+                            <p:attrNameLst>
+                              <p:attrName>style.visibility</p:attrName>
+                            </p:attrNameLst>
+                          </p:cBhvr>
+                          <p:to>
+                            <p:strVal val="visible"/>
+                          </p:to>
+                        </p:set>
+                        <p:anim calcmode="lin" valueType="num">
+                          <p:cBhvr additive="base">
+                            <p:cTn id="8" dur="500" fill="hold"/>
+                            <p:tgtEl>
+                              <p:spTgt spid="6"/>
+                            </p:tgtEl>
+                            <p:attrNameLst>
+                              <p:attrName>style.opacity</p:attrName>
+                            </p:attrNameLst>
+                          </p:cBhvr>
+                          <p:tavLst>
+                            <p:tav tm="0">
+                              <p:val>
+                                <p:fltVal val="0"/>
+                              </p:val>
+                            </p:tav>
+                            <p:tav tm="100000">
+                              <p:val>
+                                <p:fltVal val="1"/>
+                              </p:val>
+                            </p:tav>
+                          </p:tavLst>
+                        </p:anim>
+                      </p:childTnLst>
+                    </p:cTn>
+                  </p:par>
+                </p:childTnLst>
+              </p:cTn>
+            </p:seq>
+          </p:childTnLst>
+        </p:cTn>
+      </p:par>
+    </p:tnLst>
+  </p:timing>
+  <p:transition spd="med" fade="1"/>
 </p:sld>
 </file>
 
@@ -7425,7 +7565,7 @@
             <a:avLst/>
           </a:prstGeom>
           <a:solidFill>
-            <a:srgbClr val="A2391D"/>
+            <a:srgbClr val="D0603A"/>
           </a:solidFill>
           <a:ln>
             <a:noFill/>
@@ -7536,7 +7676,7 @@
             <a:avLst/>
           </a:prstGeom>
           <a:solidFill>
-            <a:srgbClr val="A2391D"/>
+            <a:srgbClr val="D0603A"/>
           </a:solidFill>
           <a:ln>
             <a:noFill/>
@@ -7590,7 +7730,7 @@
             <a:r>
               <a:rPr sz="1000">
                 <a:solidFill>
-                  <a:srgbClr val="9A9A9A"/>
+                  <a:srgbClr val="A6A6A6"/>
                 </a:solidFill>
                 <a:latin typeface="Inter"/>
               </a:rPr>
@@ -7742,7 +7882,7 @@
             <a:avLst/>
           </a:prstGeom>
           <a:solidFill>
-            <a:srgbClr val="A2391D"/>
+            <a:srgbClr val="D0603A"/>
           </a:solidFill>
           <a:ln>
             <a:noFill/>
@@ -7834,7 +7974,7 @@
             <a:r>
               <a:rPr sz="1700" b="0">
                 <a:solidFill>
-                  <a:srgbClr val="F0F0F0"/>
+                  <a:srgbClr val="EDEDED"/>
                 </a:solidFill>
                 <a:latin typeface="Inter"/>
               </a:rPr>
@@ -7850,7 +7990,7 @@
             <a:r>
               <a:rPr sz="1700" b="0">
                 <a:solidFill>
-                  <a:srgbClr val="F0F0F0"/>
+                  <a:srgbClr val="EDEDED"/>
                 </a:solidFill>
                 <a:latin typeface="Inter"/>
               </a:rPr>
@@ -7866,7 +8006,7 @@
             <a:r>
               <a:rPr sz="1700" b="0">
                 <a:solidFill>
-                  <a:srgbClr val="F0F0F0"/>
+                  <a:srgbClr val="EDEDED"/>
                 </a:solidFill>
                 <a:latin typeface="Inter"/>
               </a:rPr>
@@ -7905,7 +8045,7 @@
             <a:r>
               <a:rPr sz="1700" b="0">
                 <a:solidFill>
-                  <a:srgbClr val="F0F0F0"/>
+                  <a:srgbClr val="EDEDED"/>
                 </a:solidFill>
                 <a:latin typeface="Inter"/>
               </a:rPr>
@@ -7921,7 +8061,7 @@
             <a:r>
               <a:rPr sz="1700" b="0">
                 <a:solidFill>
-                  <a:srgbClr val="F0F0F0"/>
+                  <a:srgbClr val="EDEDED"/>
                 </a:solidFill>
                 <a:latin typeface="Inter"/>
               </a:rPr>
@@ -7937,7 +8077,7 @@
             <a:r>
               <a:rPr sz="1700" b="0">
                 <a:solidFill>
-                  <a:srgbClr val="F0F0F0"/>
+                  <a:srgbClr val="EDEDED"/>
                 </a:solidFill>
                 <a:latin typeface="Inter"/>
               </a:rPr>
@@ -7972,7 +8112,7 @@
             <a:r>
               <a:rPr sz="1000">
                 <a:solidFill>
-                  <a:srgbClr val="9A9A9A"/>
+                  <a:srgbClr val="A6A6A6"/>
                 </a:solidFill>
                 <a:latin typeface="Inter"/>
               </a:rPr>
@@ -7986,6 +8126,7 @@
   <p:clrMapOvr>
     <a:masterClrMapping/>
   </p:clrMapOvr>
+  <p:transition spd="med" fade="1"/>
 </p:sld>
 </file>
 
@@ -8057,7 +8198,7 @@
             <a:avLst/>
           </a:prstGeom>
           <a:solidFill>
-            <a:srgbClr val="A2391D"/>
+            <a:srgbClr val="D0603A"/>
           </a:solidFill>
           <a:ln>
             <a:noFill/>
@@ -8173,7 +8314,7 @@
             <a:r>
               <a:rPr sz="1800" b="0">
                 <a:solidFill>
-                  <a:srgbClr val="F0F0F0"/>
+                  <a:srgbClr val="EDEDED"/>
                 </a:solidFill>
                 <a:latin typeface="Inter"/>
               </a:rPr>
@@ -8191,7 +8332,7 @@
             <a:r>
               <a:rPr sz="1800" b="0">
                 <a:solidFill>
-                  <a:srgbClr val="F0F0F0"/>
+                  <a:srgbClr val="EDEDED"/>
                 </a:solidFill>
                 <a:latin typeface="Inter"/>
               </a:rPr>
@@ -8207,7 +8348,7 @@
             <a:r>
               <a:rPr sz="1800" b="0">
                 <a:solidFill>
-                  <a:srgbClr val="F0F0F0"/>
+                  <a:srgbClr val="EDEDED"/>
                 </a:solidFill>
                 <a:latin typeface="Inter"/>
               </a:rPr>
@@ -8225,7 +8366,7 @@
             <a:r>
               <a:rPr sz="1800" b="0">
                 <a:solidFill>
-                  <a:srgbClr val="F0F0F0"/>
+                  <a:srgbClr val="EDEDED"/>
                 </a:solidFill>
                 <a:latin typeface="Inter"/>
               </a:rPr>
@@ -8259,7 +8400,7 @@
             <a:r>
               <a:rPr sz="1100" b="0">
                 <a:solidFill>
-                  <a:srgbClr val="9A9A9A"/>
+                  <a:srgbClr val="A6A6A6"/>
                 </a:solidFill>
                 <a:latin typeface="Inter"/>
               </a:rPr>
@@ -8294,7 +8435,7 @@
             <a:r>
               <a:rPr sz="1000">
                 <a:solidFill>
-                  <a:srgbClr val="9A9A9A"/>
+                  <a:srgbClr val="A6A6A6"/>
                 </a:solidFill>
                 <a:latin typeface="Inter"/>
               </a:rPr>
@@ -8308,6 +8449,7 @@
   <p:clrMapOvr>
     <a:masterClrMapping/>
   </p:clrMapOvr>
+  <p:transition spd="med" fade="1"/>
 </p:sld>
 </file>
 
@@ -8379,7 +8521,7 @@
             <a:avLst/>
           </a:prstGeom>
           <a:solidFill>
-            <a:srgbClr val="A2391D"/>
+            <a:srgbClr val="D0603A"/>
           </a:solidFill>
           <a:ln>
             <a:noFill/>
@@ -8471,7 +8613,7 @@
             <a:r>
               <a:rPr sz="1700" b="0">
                 <a:solidFill>
-                  <a:srgbClr val="F0F0F0"/>
+                  <a:srgbClr val="EDEDED"/>
                 </a:solidFill>
                 <a:latin typeface="Inter"/>
               </a:rPr>
@@ -8487,7 +8629,7 @@
             <a:r>
               <a:rPr sz="1700" b="0">
                 <a:solidFill>
-                  <a:srgbClr val="F0F0F0"/>
+                  <a:srgbClr val="EDEDED"/>
                 </a:solidFill>
                 <a:latin typeface="Inter"/>
               </a:rPr>
@@ -8526,7 +8668,7 @@
             <a:r>
               <a:rPr sz="1700" b="0">
                 <a:solidFill>
-                  <a:srgbClr val="F0F0F0"/>
+                  <a:srgbClr val="EDEDED"/>
                 </a:solidFill>
                 <a:latin typeface="Inter"/>
               </a:rPr>
@@ -8542,7 +8684,7 @@
             <a:r>
               <a:rPr sz="1700" b="0">
                 <a:solidFill>
-                  <a:srgbClr val="F0F0F0"/>
+                  <a:srgbClr val="EDEDED"/>
                 </a:solidFill>
                 <a:latin typeface="Inter"/>
               </a:rPr>
@@ -8576,7 +8718,7 @@
             <a:r>
               <a:rPr sz="1100" b="0">
                 <a:solidFill>
-                  <a:srgbClr val="9A9A9A"/>
+                  <a:srgbClr val="A6A6A6"/>
                 </a:solidFill>
                 <a:latin typeface="Inter"/>
               </a:rPr>
@@ -8611,7 +8753,7 @@
             <a:r>
               <a:rPr sz="1000">
                 <a:solidFill>
-                  <a:srgbClr val="9A9A9A"/>
+                  <a:srgbClr val="A6A6A6"/>
                 </a:solidFill>
                 <a:latin typeface="Inter"/>
               </a:rPr>
@@ -8625,6 +8767,7 @@
   <p:clrMapOvr>
     <a:masterClrMapping/>
   </p:clrMapOvr>
+  <p:transition spd="med" fade="1"/>
 </p:sld>
 </file>
 
@@ -8696,7 +8839,7 @@
             <a:avLst/>
           </a:prstGeom>
           <a:solidFill>
-            <a:srgbClr val="A2391D"/>
+            <a:srgbClr val="D0603A"/>
           </a:solidFill>
           <a:ln>
             <a:noFill/>
@@ -8788,7 +8931,7 @@
             <a:r>
               <a:rPr sz="1700" b="0">
                 <a:solidFill>
-                  <a:srgbClr val="F0F0F0"/>
+                  <a:srgbClr val="EDEDED"/>
                 </a:solidFill>
                 <a:latin typeface="Inter"/>
               </a:rPr>
@@ -8804,7 +8947,7 @@
             <a:r>
               <a:rPr sz="1700" b="0">
                 <a:solidFill>
-                  <a:srgbClr val="F0F0F0"/>
+                  <a:srgbClr val="EDEDED"/>
                 </a:solidFill>
                 <a:latin typeface="Inter"/>
               </a:rPr>
@@ -8820,7 +8963,7 @@
             <a:r>
               <a:rPr sz="1700" b="0">
                 <a:solidFill>
-                  <a:srgbClr val="F0F0F0"/>
+                  <a:srgbClr val="EDEDED"/>
                 </a:solidFill>
                 <a:latin typeface="Inter"/>
               </a:rPr>
@@ -8836,7 +8979,7 @@
             <a:r>
               <a:rPr sz="1700" b="0">
                 <a:solidFill>
-                  <a:srgbClr val="F0F0F0"/>
+                  <a:srgbClr val="EDEDED"/>
                 </a:solidFill>
                 <a:latin typeface="Inter"/>
               </a:rPr>
@@ -8895,7 +9038,7 @@
             <a:r>
               <a:rPr sz="1100">
                 <a:solidFill>
-                  <a:srgbClr val="9A9A9A"/>
+                  <a:srgbClr val="A6A6A6"/>
                 </a:solidFill>
                 <a:hlinkClick r:id="rId3"/>
               </a:rPr>
@@ -8930,7 +9073,7 @@
             <a:r>
               <a:rPr sz="1000">
                 <a:solidFill>
-                  <a:srgbClr val="9A9A9A"/>
+                  <a:srgbClr val="A6A6A6"/>
                 </a:solidFill>
                 <a:latin typeface="Inter"/>
               </a:rPr>
@@ -8944,6 +9087,7 @@
   <p:clrMapOvr>
     <a:masterClrMapping/>
   </p:clrMapOvr>
+  <p:transition spd="med" fade="1"/>
 </p:sld>
 </file>
 
@@ -9015,7 +9159,7 @@
             <a:avLst/>
           </a:prstGeom>
           <a:solidFill>
-            <a:srgbClr val="A2391D"/>
+            <a:srgbClr val="D0603A"/>
           </a:solidFill>
           <a:ln>
             <a:noFill/>
@@ -9051,8 +9195,8 @@
         </p:nvSpPr>
         <p:spPr>
           <a:xfrm>
-            <a:off x="571500" y="2743200"/>
-            <a:ext cx="11048695" cy="1097280"/>
+            <a:off x="571500" y="1371600"/>
+            <a:ext cx="11048695" cy="914400"/>
           </a:xfrm>
           <a:prstGeom prst="rect">
             <a:avLst/>
@@ -9085,8 +9229,8 @@
         </p:nvSpPr>
         <p:spPr>
           <a:xfrm>
-            <a:off x="571500" y="3840480"/>
-            <a:ext cx="11048695" cy="731520"/>
+            <a:off x="571500" y="2377440"/>
+            <a:ext cx="11048695" cy="548640"/>
           </a:xfrm>
           <a:prstGeom prst="rect">
             <a:avLst/>
@@ -9102,7 +9246,7 @@
             <a:r>
               <a:rPr sz="1800" b="0">
                 <a:solidFill>
-                  <a:srgbClr val="B0B0B0"/>
+                  <a:srgbClr val="B8B8B8"/>
                 </a:solidFill>
                 <a:latin typeface="Inter"/>
               </a:rPr>
@@ -9119,8 +9263,8 @@
         </p:nvSpPr>
         <p:spPr>
           <a:xfrm>
-            <a:off x="571500" y="4572000"/>
-            <a:ext cx="11048695" cy="548640"/>
+            <a:off x="571500" y="3017520"/>
+            <a:ext cx="3439058" cy="914400"/>
           </a:xfrm>
           <a:prstGeom prst="rect">
             <a:avLst/>
@@ -9133,14 +9277,27 @@
           </a:bodyPr>
           <a:lstStyle/>
           <a:p>
-            <a:r>
-              <a:rPr sz="1400">
-                <a:solidFill>
-                  <a:srgbClr val="E0603A"/>
-                </a:solidFill>
-                <a:hlinkClick r:id="rId2"/>
-              </a:rPr>
-              <a:t>https://github.com/Pavel1778/madrigal-protocol-lab</a:t>
+            <a:pPr algn="ctr"/>
+            <a:r>
+              <a:rPr sz="3000" b="0">
+                <a:solidFill>
+                  <a:srgbClr val="FFFFFF"/>
+                </a:solidFill>
+                <a:latin typeface="Manrope"/>
+              </a:rPr>
+              <a:t>741</a:t>
+            </a:r>
+          </a:p>
+          <a:p>
+            <a:pPr algn="ctr"/>
+            <a:r>
+              <a:rPr sz="1200" b="0">
+                <a:solidFill>
+                  <a:srgbClr val="B8B8B8"/>
+                </a:solidFill>
+                <a:latin typeface="Inter"/>
+              </a:rPr>
+              <a:t>тест</a:t>
             </a:r>
           </a:p>
         </p:txBody>
@@ -9153,8 +9310,8 @@
         </p:nvSpPr>
         <p:spPr>
           <a:xfrm>
-            <a:off x="571500" y="6400800"/>
-            <a:ext cx="11048695" cy="274320"/>
+            <a:off x="4376318" y="3017520"/>
+            <a:ext cx="3439058" cy="914400"/>
           </a:xfrm>
           <a:prstGeom prst="rect">
             <a:avLst/>
@@ -9169,9 +9326,221 @@
           <a:p>
             <a:pPr algn="ctr"/>
             <a:r>
+              <a:rPr sz="3000" b="0">
+                <a:solidFill>
+                  <a:srgbClr val="FFFFFF"/>
+                </a:solidFill>
+                <a:latin typeface="Manrope"/>
+              </a:rPr>
+              <a:t>90%</a:t>
+            </a:r>
+          </a:p>
+          <a:p>
+            <a:pPr algn="ctr"/>
+            <a:r>
+              <a:rPr sz="1200" b="0">
+                <a:solidFill>
+                  <a:srgbClr val="B8B8B8"/>
+                </a:solidFill>
+                <a:latin typeface="Inter"/>
+              </a:rPr>
+              <a:t>покрытие</a:t>
+            </a:r>
+          </a:p>
+        </p:txBody>
+      </p:sp>
+      <p:sp>
+        <p:nvSpPr>
+          <p:cNvPr id="8" name="TextBox 7"/>
+          <p:cNvSpPr txBox="1"/>
+          <p:nvPr/>
+        </p:nvSpPr>
+        <p:spPr>
+          <a:xfrm>
+            <a:off x="8181136" y="3017520"/>
+            <a:ext cx="3439058" cy="914400"/>
+          </a:xfrm>
+          <a:prstGeom prst="rect">
+            <a:avLst/>
+          </a:prstGeom>
+          <a:noFill/>
+        </p:spPr>
+        <p:txBody>
+          <a:bodyPr wrap="square" anchor="t">
+            <a:spAutoFit/>
+          </a:bodyPr>
+          <a:lstStyle/>
+          <a:p>
+            <a:pPr algn="ctr"/>
+            <a:r>
+              <a:rPr sz="3000" b="0">
+                <a:solidFill>
+                  <a:srgbClr val="FFFFFF"/>
+                </a:solidFill>
+                <a:latin typeface="Manrope"/>
+              </a:rPr>
+              <a:t>8</a:t>
+            </a:r>
+          </a:p>
+          <a:p>
+            <a:pPr algn="ctr"/>
+            <a:r>
+              <a:rPr sz="1200" b="0">
+                <a:solidFill>
+                  <a:srgbClr val="B8B8B8"/>
+                </a:solidFill>
+                <a:latin typeface="Inter"/>
+              </a:rPr>
+              <a:t>артефактов в релизе</a:t>
+            </a:r>
+          </a:p>
+        </p:txBody>
+      </p:sp>
+      <p:pic>
+        <p:nvPicPr>
+          <p:cNvPr id="9" name="Picture 8" descr="qr_repo.png"/>
+          <p:cNvPicPr>
+            <a:picLocks noChangeAspect="1"/>
+          </p:cNvPicPr>
+          <p:nvPr/>
+        </p:nvPicPr>
+        <p:blipFill>
+          <a:blip r:embed="rId2"/>
+          <a:stretch>
+            <a:fillRect/>
+          </a:stretch>
+        </p:blipFill>
+        <p:spPr>
+          <a:xfrm>
+            <a:off x="4084167" y="4206240"/>
+            <a:ext cx="1463040" cy="1463040"/>
+          </a:xfrm>
+          <a:prstGeom prst="rect">
+            <a:avLst/>
+          </a:prstGeom>
+        </p:spPr>
+      </p:pic>
+      <p:sp>
+        <p:nvSpPr>
+          <p:cNvPr id="10" name="TextBox 9"/>
+          <p:cNvSpPr txBox="1"/>
+          <p:nvPr/>
+        </p:nvSpPr>
+        <p:spPr>
+          <a:xfrm>
+            <a:off x="3718407" y="5760720"/>
+            <a:ext cx="2194560" cy="320040"/>
+          </a:xfrm>
+          <a:prstGeom prst="rect">
+            <a:avLst/>
+          </a:prstGeom>
+          <a:noFill/>
+        </p:spPr>
+        <p:txBody>
+          <a:bodyPr wrap="square" anchor="t">
+            <a:spAutoFit/>
+          </a:bodyPr>
+          <a:lstStyle/>
+          <a:p>
+            <a:pPr algn="ctr"/>
+            <a:r>
+              <a:rPr sz="1100" b="0">
+                <a:solidFill>
+                  <a:srgbClr val="A6A6A6"/>
+                </a:solidFill>
+                <a:latin typeface="Inter"/>
+              </a:rPr>
+              <a:t>Репозиторий</a:t>
+            </a:r>
+          </a:p>
+        </p:txBody>
+      </p:sp>
+      <p:pic>
+        <p:nvPicPr>
+          <p:cNvPr id="11" name="Picture 10" descr="qr_release.png"/>
+          <p:cNvPicPr>
+            <a:picLocks noChangeAspect="1"/>
+          </p:cNvPicPr>
+          <p:nvPr/>
+        </p:nvPicPr>
+        <p:blipFill>
+          <a:blip r:embed="rId3"/>
+          <a:stretch>
+            <a:fillRect/>
+          </a:stretch>
+        </p:blipFill>
+        <p:spPr>
+          <a:xfrm>
+            <a:off x="6644487" y="4206240"/>
+            <a:ext cx="1463040" cy="1463040"/>
+          </a:xfrm>
+          <a:prstGeom prst="rect">
+            <a:avLst/>
+          </a:prstGeom>
+        </p:spPr>
+      </p:pic>
+      <p:sp>
+        <p:nvSpPr>
+          <p:cNvPr id="12" name="TextBox 11"/>
+          <p:cNvSpPr txBox="1"/>
+          <p:nvPr/>
+        </p:nvSpPr>
+        <p:spPr>
+          <a:xfrm>
+            <a:off x="6278727" y="5760720"/>
+            <a:ext cx="2194560" cy="320040"/>
+          </a:xfrm>
+          <a:prstGeom prst="rect">
+            <a:avLst/>
+          </a:prstGeom>
+          <a:noFill/>
+        </p:spPr>
+        <p:txBody>
+          <a:bodyPr wrap="square" anchor="t">
+            <a:spAutoFit/>
+          </a:bodyPr>
+          <a:lstStyle/>
+          <a:p>
+            <a:pPr algn="ctr"/>
+            <a:r>
+              <a:rPr sz="1100" b="0">
+                <a:solidFill>
+                  <a:srgbClr val="A6A6A6"/>
+                </a:solidFill>
+                <a:latin typeface="Inter"/>
+              </a:rPr>
+              <a:t>Релиз v1.0.0</a:t>
+            </a:r>
+          </a:p>
+        </p:txBody>
+      </p:sp>
+      <p:sp>
+        <p:nvSpPr>
+          <p:cNvPr id="13" name="TextBox 12"/>
+          <p:cNvSpPr txBox="1"/>
+          <p:nvPr/>
+        </p:nvSpPr>
+        <p:spPr>
+          <a:xfrm>
+            <a:off x="571500" y="6400800"/>
+            <a:ext cx="11048695" cy="274320"/>
+          </a:xfrm>
+          <a:prstGeom prst="rect">
+            <a:avLst/>
+          </a:prstGeom>
+          <a:noFill/>
+        </p:spPr>
+        <p:txBody>
+          <a:bodyPr wrap="square" anchor="t">
+            <a:spAutoFit/>
+          </a:bodyPr>
+          <a:lstStyle/>
+          <a:p>
+            <a:pPr algn="ctr"/>
+            <a:r>
               <a:rPr sz="1000">
                 <a:solidFill>
-                  <a:srgbClr val="9A9A9A"/>
+                  <a:srgbClr val="A6A6A6"/>
                 </a:solidFill>
                 <a:latin typeface="Inter"/>
               </a:rPr>
@@ -9185,6 +9554,7 @@
   <p:clrMapOvr>
     <a:masterClrMapping/>
   </p:clrMapOvr>
+  <p:transition spd="med" fade="1"/>
 </p:sld>
 </file>
 
@@ -9256,7 +9626,7 @@
             <a:avLst/>
           </a:prstGeom>
           <a:solidFill>
-            <a:srgbClr val="A2391D"/>
+            <a:srgbClr val="D0603A"/>
           </a:solidFill>
           <a:ln>
             <a:noFill/>
@@ -9348,7 +9718,7 @@
             <a:r>
               <a:rPr sz="1700" b="0">
                 <a:solidFill>
-                  <a:srgbClr val="F0F0F0"/>
+                  <a:srgbClr val="EDEDED"/>
                 </a:solidFill>
                 <a:latin typeface="Inter"/>
               </a:rPr>
@@ -9366,7 +9736,7 @@
             <a:r>
               <a:rPr sz="1700" b="0">
                 <a:solidFill>
-                  <a:srgbClr val="F0F0F0"/>
+                  <a:srgbClr val="EDEDED"/>
                 </a:solidFill>
                 <a:latin typeface="Inter"/>
               </a:rPr>
@@ -9382,7 +9752,7 @@
             <a:r>
               <a:rPr sz="1700" b="0">
                 <a:solidFill>
-                  <a:srgbClr val="F0F0F0"/>
+                  <a:srgbClr val="EDEDED"/>
                 </a:solidFill>
                 <a:latin typeface="Inter"/>
               </a:rPr>
@@ -9400,7 +9770,7 @@
             <a:r>
               <a:rPr sz="1700" b="0">
                 <a:solidFill>
-                  <a:srgbClr val="F0F0F0"/>
+                  <a:srgbClr val="EDEDED"/>
                 </a:solidFill>
                 <a:latin typeface="Inter"/>
               </a:rPr>
@@ -9416,7 +9786,7 @@
             <a:r>
               <a:rPr sz="1700" b="0">
                 <a:solidFill>
-                  <a:srgbClr val="F0F0F0"/>
+                  <a:srgbClr val="EDEDED"/>
                 </a:solidFill>
                 <a:latin typeface="Inter"/>
               </a:rPr>
@@ -9434,7 +9804,7 @@
             <a:r>
               <a:rPr sz="1700" b="0">
                 <a:solidFill>
-                  <a:srgbClr val="F0F0F0"/>
+                  <a:srgbClr val="EDEDED"/>
                 </a:solidFill>
                 <a:latin typeface="Inter"/>
               </a:rPr>
@@ -9473,7 +9843,7 @@
             <a:r>
               <a:rPr sz="1700" b="0">
                 <a:solidFill>
-                  <a:srgbClr val="F0F0F0"/>
+                  <a:srgbClr val="EDEDED"/>
                 </a:solidFill>
                 <a:latin typeface="Inter"/>
               </a:rPr>
@@ -9489,7 +9859,7 @@
             <a:r>
               <a:rPr sz="1700" b="0">
                 <a:solidFill>
-                  <a:srgbClr val="F0F0F0"/>
+                  <a:srgbClr val="EDEDED"/>
                 </a:solidFill>
                 <a:latin typeface="Inter"/>
               </a:rPr>
@@ -9523,7 +9893,7 @@
             <a:r>
               <a:rPr sz="1100" b="0">
                 <a:solidFill>
-                  <a:srgbClr val="9A9A9A"/>
+                  <a:srgbClr val="A6A6A6"/>
                 </a:solidFill>
                 <a:latin typeface="Inter"/>
               </a:rPr>
@@ -9558,7 +9928,7 @@
             <a:r>
               <a:rPr sz="1000">
                 <a:solidFill>
-                  <a:srgbClr val="9A9A9A"/>
+                  <a:srgbClr val="A6A6A6"/>
                 </a:solidFill>
                 <a:latin typeface="Inter"/>
               </a:rPr>
@@ -9572,6 +9942,7 @@
   <p:clrMapOvr>
     <a:masterClrMapping/>
   </p:clrMapOvr>
+  <p:transition spd="med" fade="1"/>
 </p:sld>
 </file>
 
@@ -9643,7 +10014,7 @@
             <a:avLst/>
           </a:prstGeom>
           <a:solidFill>
-            <a:srgbClr val="A2391D"/>
+            <a:srgbClr val="D0603A"/>
           </a:solidFill>
           <a:ln>
             <a:noFill/>
@@ -9754,7 +10125,7 @@
             <a:avLst/>
           </a:prstGeom>
           <a:solidFill>
-            <a:srgbClr val="A2391D"/>
+            <a:srgbClr val="D0603A"/>
           </a:solidFill>
           <a:ln>
             <a:noFill/>
@@ -9808,7 +10179,7 @@
             <a:r>
               <a:rPr sz="1000">
                 <a:solidFill>
-                  <a:srgbClr val="9A9A9A"/>
+                  <a:srgbClr val="A6A6A6"/>
                 </a:solidFill>
                 <a:latin typeface="Inter"/>
               </a:rPr>
@@ -9960,7 +10331,7 @@
             <a:avLst/>
           </a:prstGeom>
           <a:solidFill>
-            <a:srgbClr val="A2391D"/>
+            <a:srgbClr val="D0603A"/>
           </a:solidFill>
           <a:ln>
             <a:noFill/>
@@ -10039,7 +10410,7 @@
         <p:spPr>
           <a:xfrm>
             <a:off x="571500" y="1554480"/>
-            <a:ext cx="8770267" cy="4023359"/>
+            <a:ext cx="11048695" cy="3914394"/>
           </a:xfrm>
           <a:prstGeom prst="rect">
             <a:avLst/>
@@ -10071,11 +10442,11 @@
             <a:r>
               <a:rPr sz="1100" b="0">
                 <a:solidFill>
-                  <a:srgbClr val="9A9A9A"/>
+                  <a:srgbClr val="A6A6A6"/>
                 </a:solidFill>
                 <a:latin typeface="Inter"/>
               </a:rPr>
-              <a:t>capture · protocol + hypothesis · ui. Контракты зафиксированы JSON Schema draft 2020-12.</a:t>
+              <a:t>Контракты зафиксированы JSON Schema (draft 2020-12) и не меняются молча.</a:t>
             </a:r>
           </a:p>
         </p:txBody>
@@ -10106,7 +10477,7 @@
             <a:r>
               <a:rPr sz="1000">
                 <a:solidFill>
-                  <a:srgbClr val="9A9A9A"/>
+                  <a:srgbClr val="A6A6A6"/>
                 </a:solidFill>
                 <a:latin typeface="Inter"/>
               </a:rPr>
@@ -10120,6 +10491,7 @@
   <p:clrMapOvr>
     <a:masterClrMapping/>
   </p:clrMapOvr>
+  <p:transition spd="med" fade="1"/>
 </p:sld>
 </file>
 
@@ -10191,7 +10563,7 @@
             <a:avLst/>
           </a:prstGeom>
           <a:solidFill>
-            <a:srgbClr val="A2391D"/>
+            <a:srgbClr val="D0603A"/>
           </a:solidFill>
           <a:ln>
             <a:noFill/>
@@ -10302,7 +10674,7 @@
             <a:avLst/>
           </a:prstGeom>
           <a:solidFill>
-            <a:srgbClr val="A2391D"/>
+            <a:srgbClr val="D0603A"/>
           </a:solidFill>
           <a:ln>
             <a:noFill/>
@@ -10356,7 +10728,7 @@
             <a:r>
               <a:rPr sz="1000">
                 <a:solidFill>
-                  <a:srgbClr val="9A9A9A"/>
+                  <a:srgbClr val="A6A6A6"/>
                 </a:solidFill>
                 <a:latin typeface="Inter"/>
               </a:rPr>
@@ -10508,7 +10880,7 @@
             <a:avLst/>
           </a:prstGeom>
           <a:solidFill>
-            <a:srgbClr val="A2391D"/>
+            <a:srgbClr val="D0603A"/>
           </a:solidFill>
           <a:ln>
             <a:noFill/>
@@ -10600,7 +10972,7 @@
             <a:r>
               <a:rPr sz="1700" b="0">
                 <a:solidFill>
-                  <a:srgbClr val="F0F0F0"/>
+                  <a:srgbClr val="EDEDED"/>
                 </a:solidFill>
                 <a:latin typeface="Inter"/>
               </a:rPr>
@@ -10616,7 +10988,7 @@
             <a:r>
               <a:rPr sz="1700" b="0">
                 <a:solidFill>
-                  <a:srgbClr val="F0F0F0"/>
+                  <a:srgbClr val="EDEDED"/>
                 </a:solidFill>
                 <a:latin typeface="Inter"/>
               </a:rPr>
@@ -10632,7 +11004,7 @@
             <a:r>
               <a:rPr sz="1700" b="0">
                 <a:solidFill>
-                  <a:srgbClr val="F0F0F0"/>
+                  <a:srgbClr val="EDEDED"/>
                 </a:solidFill>
                 <a:latin typeface="Inter"/>
               </a:rPr>
@@ -10648,7 +11020,7 @@
             <a:r>
               <a:rPr sz="1700" b="0">
                 <a:solidFill>
-                  <a:srgbClr val="F0F0F0"/>
+                  <a:srgbClr val="EDEDED"/>
                 </a:solidFill>
                 <a:latin typeface="Inter"/>
               </a:rPr>
@@ -10706,7 +11078,7 @@
             <a:r>
               <a:rPr sz="1100" b="0">
                 <a:solidFill>
-                  <a:srgbClr val="9A9A9A"/>
+                  <a:srgbClr val="A6A6A6"/>
                 </a:solidFill>
                 <a:latin typeface="Inter"/>
               </a:rPr>
@@ -10741,7 +11113,7 @@
             <a:r>
               <a:rPr sz="1000">
                 <a:solidFill>
-                  <a:srgbClr val="9A9A9A"/>
+                  <a:srgbClr val="A6A6A6"/>
                 </a:solidFill>
                 <a:latin typeface="Inter"/>
               </a:rPr>
@@ -10755,6 +11127,7 @@
   <p:clrMapOvr>
     <a:masterClrMapping/>
   </p:clrMapOvr>
+  <p:transition spd="med" fade="1"/>
 </p:sld>
 </file>
 
@@ -10826,7 +11199,7 @@
             <a:avLst/>
           </a:prstGeom>
           <a:solidFill>
-            <a:srgbClr val="A2391D"/>
+            <a:srgbClr val="D0603A"/>
           </a:solidFill>
           <a:ln>
             <a:noFill/>
@@ -10918,7 +11291,7 @@
             <a:r>
               <a:rPr sz="1700" b="0">
                 <a:solidFill>
-                  <a:srgbClr val="F0F0F0"/>
+                  <a:srgbClr val="EDEDED"/>
                 </a:solidFill>
                 <a:latin typeface="Inter"/>
               </a:rPr>
@@ -10934,7 +11307,7 @@
             <a:r>
               <a:rPr sz="1700" b="0">
                 <a:solidFill>
-                  <a:srgbClr val="F0F0F0"/>
+                  <a:srgbClr val="EDEDED"/>
                 </a:solidFill>
                 <a:latin typeface="Inter"/>
               </a:rPr>
@@ -10950,7 +11323,7 @@
             <a:r>
               <a:rPr sz="1700" b="0">
                 <a:solidFill>
-                  <a:srgbClr val="F0F0F0"/>
+                  <a:srgbClr val="EDEDED"/>
                 </a:solidFill>
                 <a:latin typeface="Inter"/>
               </a:rPr>
@@ -10968,7 +11341,7 @@
             <a:r>
               <a:rPr sz="1700" b="0">
                 <a:solidFill>
-                  <a:srgbClr val="F0F0F0"/>
+                  <a:srgbClr val="EDEDED"/>
                 </a:solidFill>
                 <a:latin typeface="Inter"/>
               </a:rPr>
@@ -10984,7 +11357,7 @@
             <a:r>
               <a:rPr sz="1700" b="0">
                 <a:solidFill>
-                  <a:srgbClr val="F0F0F0"/>
+                  <a:srgbClr val="EDEDED"/>
                 </a:solidFill>
                 <a:latin typeface="Inter"/>
               </a:rPr>
@@ -11023,7 +11396,7 @@
             <a:r>
               <a:rPr sz="1700" b="0">
                 <a:solidFill>
-                  <a:srgbClr val="F0F0F0"/>
+                  <a:srgbClr val="EDEDED"/>
                 </a:solidFill>
                 <a:latin typeface="Inter"/>
               </a:rPr>
@@ -11039,7 +11412,7 @@
             <a:r>
               <a:rPr sz="1700" b="0">
                 <a:solidFill>
-                  <a:srgbClr val="F0F0F0"/>
+                  <a:srgbClr val="EDEDED"/>
                 </a:solidFill>
                 <a:latin typeface="Inter"/>
               </a:rPr>
@@ -11055,7 +11428,7 @@
             <a:r>
               <a:rPr sz="1700" b="0">
                 <a:solidFill>
-                  <a:srgbClr val="F0F0F0"/>
+                  <a:srgbClr val="EDEDED"/>
                 </a:solidFill>
                 <a:latin typeface="Inter"/>
               </a:rPr>
@@ -11089,7 +11462,7 @@
             <a:r>
               <a:rPr sz="1100" b="0">
                 <a:solidFill>
-                  <a:srgbClr val="9A9A9A"/>
+                  <a:srgbClr val="A6A6A6"/>
                 </a:solidFill>
                 <a:latin typeface="Inter"/>
               </a:rPr>
@@ -11124,7 +11497,7 @@
             <a:r>
               <a:rPr sz="1000">
                 <a:solidFill>
-                  <a:srgbClr val="9A9A9A"/>
+                  <a:srgbClr val="A6A6A6"/>
                 </a:solidFill>
                 <a:latin typeface="Inter"/>
               </a:rPr>
@@ -11138,6 +11511,7 @@
   <p:clrMapOvr>
     <a:masterClrMapping/>
   </p:clrMapOvr>
+  <p:transition spd="med" fade="1"/>
 </p:sld>
 </file>
 
@@ -11209,7 +11583,7 @@
             <a:avLst/>
           </a:prstGeom>
           <a:solidFill>
-            <a:srgbClr val="A2391D"/>
+            <a:srgbClr val="D0603A"/>
           </a:solidFill>
           <a:ln>
             <a:noFill/>
@@ -11301,7 +11675,7 @@
             <a:r>
               <a:rPr sz="1700" b="0">
                 <a:solidFill>
-                  <a:srgbClr val="F0F0F0"/>
+                  <a:srgbClr val="EDEDED"/>
                 </a:solidFill>
                 <a:latin typeface="Inter"/>
               </a:rPr>
@@ -11317,7 +11691,7 @@
             <a:r>
               <a:rPr sz="1700" b="0">
                 <a:solidFill>
-                  <a:srgbClr val="F0F0F0"/>
+                  <a:srgbClr val="EDEDED"/>
                 </a:solidFill>
                 <a:latin typeface="Inter"/>
               </a:rPr>
@@ -11335,7 +11709,7 @@
             <a:r>
               <a:rPr sz="1700" b="0">
                 <a:solidFill>
-                  <a:srgbClr val="F0F0F0"/>
+                  <a:srgbClr val="EDEDED"/>
                 </a:solidFill>
                 <a:latin typeface="Inter"/>
               </a:rPr>
@@ -11351,7 +11725,7 @@
             <a:r>
               <a:rPr sz="1700" b="0">
                 <a:solidFill>
-                  <a:srgbClr val="F0F0F0"/>
+                  <a:srgbClr val="EDEDED"/>
                 </a:solidFill>
                 <a:latin typeface="Inter"/>
               </a:rPr>
@@ -11367,7 +11741,7 @@
             <a:r>
               <a:rPr sz="1700" b="0">
                 <a:solidFill>
-                  <a:srgbClr val="F0F0F0"/>
+                  <a:srgbClr val="EDEDED"/>
                 </a:solidFill>
                 <a:latin typeface="Inter"/>
               </a:rPr>
@@ -11426,7 +11800,7 @@
             <a:r>
               <a:rPr sz="1000">
                 <a:solidFill>
-                  <a:srgbClr val="9A9A9A"/>
+                  <a:srgbClr val="A6A6A6"/>
                 </a:solidFill>
                 <a:latin typeface="Inter"/>
               </a:rPr>
@@ -11440,6 +11814,7 @@
   <p:clrMapOvr>
     <a:masterClrMapping/>
   </p:clrMapOvr>
+  <p:transition spd="med" fade="1"/>
 </p:sld>
 </file>
 

</xml_diff>

<commit_message>
feat(presentation): compress deck to 14 slides with provenance section
</commit_message>
<xml_diff>
--- a/presentation/slides.pptx
+++ b/presentation/slides.pptx
@@ -19,11 +19,6 @@
     <p:sldId id="267" r:id="rId19"/>
     <p:sldId id="268" r:id="rId20"/>
     <p:sldId id="269" r:id="rId21"/>
-    <p:sldId id="270" r:id="rId22"/>
-    <p:sldId id="271" r:id="rId23"/>
-    <p:sldId id="272" r:id="rId24"/>
-    <p:sldId id="273" r:id="rId25"/>
-    <p:sldId id="274" r:id="rId26"/>
   </p:sldIdLst>
   <p:sldSz cx="12191695" cy="6858000" type="screen4x3"/>
   <p:notesSz cx="6858000" cy="9144000"/>
@@ -125,17 +120,17 @@
   <p:embeddedFontLst>
     <p:embeddedFont>
       <p:font typeface="Tektur"/>
-      <p:regular r:id="rId27" fontKey="{27E04CAF-4F9E-C315-3E78-7ADC5AE0D597}"/>
-      <p:bold r:id="rId28" fontKey="{A12660F0-7690-25AC-9BE9-6509C0A8B2A5}"/>
+      <p:regular r:id="rId22" fontKey="{27E04CAF-4F9E-C315-3E78-7ADC5AE0D597}"/>
+      <p:bold r:id="rId23" fontKey="{A12660F0-7690-25AC-9BE9-6509C0A8B2A5}"/>
     </p:embeddedFont>
     <p:embeddedFont>
       <p:font typeface="Montserrat"/>
-      <p:regular r:id="rId29" fontKey="{3547397D-CEC3-B89A-5FB5-020C9CB6E4DD}"/>
-      <p:bold r:id="rId30" fontKey="{0CB8D5B1-66EF-C706-0E19-6341EC3D8E46}"/>
+      <p:regular r:id="rId24" fontKey="{3547397D-CEC3-B89A-5FB5-020C9CB6E4DD}"/>
+      <p:bold r:id="rId25" fontKey="{0CB8D5B1-66EF-C706-0E19-6341EC3D8E46}"/>
     </p:embeddedFont>
     <p:embeddedFont>
       <p:font typeface="JetBrains Mono"/>
-      <p:regular r:id="rId31" fontKey="{C6EB8399-2A56-D694-A331-105094B34A55}"/>
+      <p:regular r:id="rId26" fontKey="{C6EB8399-2A56-D694-A331-105094B34A55}"/>
     </p:embeddedFont>
   </p:embeddedFontLst>
 </p:presentation>
@@ -3839,9 +3834,33 @@
           </a:p>
         </p:txBody>
       </p:sp>
-      <p:sp>
-        <p:nvSpPr>
-          <p:cNvPr id="6" name="TextBox 5"/>
+      <p:pic>
+        <p:nvPicPr>
+          <p:cNvPr id="6" name="Picture 5" descr="madrigal-logo.png"/>
+          <p:cNvPicPr>
+            <a:picLocks noChangeAspect="1"/>
+          </p:cNvPicPr>
+          <p:nvPr/>
+        </p:nvPicPr>
+        <p:blipFill>
+          <a:blip r:embed="rId3"/>
+          <a:stretch>
+            <a:fillRect/>
+          </a:stretch>
+        </p:blipFill>
+        <p:spPr>
+          <a:xfrm>
+            <a:off x="9814255" y="1188720"/>
+            <a:ext cx="1554480" cy="640080"/>
+          </a:xfrm>
+          <a:prstGeom prst="rect">
+            <a:avLst/>
+          </a:prstGeom>
+        </p:spPr>
+      </p:pic>
+      <p:sp>
+        <p:nvSpPr>
+          <p:cNvPr id="7" name="TextBox 6"/>
           <p:cNvSpPr txBox="1"/>
           <p:nvPr/>
         </p:nvSpPr>
@@ -3875,7 +3894,7 @@
       </p:sp>
       <p:sp>
         <p:nvSpPr>
-          <p:cNvPr id="7" name="TextBox 6"/>
+          <p:cNvPr id="8" name="TextBox 7"/>
           <p:cNvSpPr txBox="1"/>
           <p:nvPr/>
         </p:nvSpPr>
@@ -3909,7 +3928,7 @@
       </p:sp>
       <p:sp>
         <p:nvSpPr>
-          <p:cNvPr id="8" name="Rectangle 7"/>
+          <p:cNvPr id="9" name="Rectangle 8"/>
           <p:cNvSpPr/>
           <p:nvPr/>
         </p:nvSpPr>
@@ -3953,7 +3972,7 @@
       </p:sp>
       <p:sp>
         <p:nvSpPr>
-          <p:cNvPr id="9" name="TextBox 8"/>
+          <p:cNvPr id="10" name="TextBox 9"/>
           <p:cNvSpPr txBox="1"/>
           <p:nvPr/>
         </p:nvSpPr>
@@ -4111,8 +4130,8 @@
         </p:nvSpPr>
         <p:spPr>
           <a:xfrm>
-            <a:off x="822960" y="2011680"/>
-            <a:ext cx="10545775" cy="1280160"/>
+            <a:off x="822960" y="914400"/>
+            <a:ext cx="10545775" cy="731520"/>
           </a:xfrm>
           <a:prstGeom prst="rect">
             <a:avLst/>
@@ -4126,13 +4145,13 @@
           <a:lstStyle/>
           <a:p>
             <a:r>
-              <a:rPr sz="7200" b="1">
-                <a:solidFill>
-                  <a:srgbClr val="D0603A"/>
+              <a:rPr sz="3200" b="1">
+                <a:solidFill>
+                  <a:srgbClr val="F4F1EC"/>
                 </a:solidFill>
                 <a:latin typeface="Tektur"/>
               </a:rPr>
-              <a:t>01</a:t>
+              <a:t>Что получилось</a:t>
             </a:r>
           </a:p>
         </p:txBody>
@@ -4145,8 +4164,8 @@
         </p:nvSpPr>
         <p:spPr>
           <a:xfrm>
-            <a:off x="822960" y="3200400"/>
-            <a:ext cx="10545775" cy="914400"/>
+            <a:off x="822960" y="1115568"/>
+            <a:ext cx="10545775" cy="548640"/>
           </a:xfrm>
           <a:prstGeom prst="rect">
             <a:avLst/>
@@ -4160,392 +4179,13 @@
           <a:lstStyle/>
           <a:p>
             <a:r>
-              <a:rPr sz="4000" b="1">
-                <a:solidFill>
-                  <a:srgbClr val="F4F1EC"/>
-                </a:solidFill>
-                <a:latin typeface="Tektur"/>
-              </a:rPr>
-              <a:t>Что получилось</a:t>
-            </a:r>
-          </a:p>
-        </p:txBody>
-      </p:sp>
-      <p:sp>
-        <p:nvSpPr>
-          <p:cNvPr id="6" name="Rectangle 5"/>
-          <p:cNvSpPr/>
-          <p:nvPr/>
-        </p:nvSpPr>
-        <p:spPr>
-          <a:xfrm>
-            <a:off x="822960" y="4206240"/>
-            <a:ext cx="3108960" cy="82296"/>
-          </a:xfrm>
-          <a:prstGeom prst="rect">
-            <a:avLst/>
-          </a:prstGeom>
-          <a:ln>
-            <a:noFill/>
-          </a:ln>
-          <a:effectLst/>
-          <a:gradFill rotWithShape="1">
-            <a:gsLst>
-              <a:gs pos="0">
-                <a:srgbClr val="410913"/>
-              </a:gs>
-              <a:gs pos="50000">
-                <a:srgbClr val="610D1C"/>
-              </a:gs>
-              <a:gs pos="100000">
-                <a:srgbClr val="A2391D"/>
-              </a:gs>
-            </a:gsLst>
-            <a:lin ang="2700000"/>
-          </a:gradFill>
-        </p:spPr>
-        <p:style>
-          <a:lnRef idx="1">
-            <a:schemeClr val="accent1"/>
-          </a:lnRef>
-          <a:fillRef idx="3">
-            <a:schemeClr val="accent1"/>
-          </a:fillRef>
-          <a:effectRef idx="2">
-            <a:schemeClr val="accent1"/>
-          </a:effectRef>
-          <a:fontRef idx="minor">
-            <a:schemeClr val="lt1"/>
-          </a:fontRef>
-        </p:style>
-        <p:txBody>
-          <a:bodyPr rtlCol="0" anchor="ctr"/>
-          <a:lstStyle/>
-          <a:p>
-            <a:pPr algn="ctr"/>
-          </a:p>
-        </p:txBody>
-      </p:sp>
-      <p:sp>
-        <p:nvSpPr>
-          <p:cNvPr id="7" name="TextBox 6"/>
-          <p:cNvSpPr txBox="1"/>
-          <p:nvPr/>
-        </p:nvSpPr>
-        <p:spPr>
-          <a:xfrm>
-            <a:off x="822960" y="4480560"/>
-            <a:ext cx="10545775" cy="457200"/>
-          </a:xfrm>
-          <a:prstGeom prst="rect">
-            <a:avLst/>
-          </a:prstGeom>
-          <a:noFill/>
-        </p:spPr>
-        <p:txBody>
-          <a:bodyPr wrap="square" anchor="t">
-            <a:spAutoFit/>
-          </a:bodyPr>
-          <a:lstStyle/>
-          <a:p>
-            <a:r>
-              <a:rPr sz="1600" b="0">
+              <a:rPr sz="1400" b="0">
                 <a:solidFill>
                   <a:srgbClr val="A8A29E"/>
                 </a:solidFill>
                 <a:latin typeface="Montserrat"/>
               </a:rPr>
-              <a:t>Точность, покрытие корпуса организаторов, ресурсы</a:t>
-            </a:r>
-          </a:p>
-        </p:txBody>
-      </p:sp>
-      <p:sp>
-        <p:nvSpPr>
-          <p:cNvPr id="8" name="TextBox 7"/>
-          <p:cNvSpPr txBox="1"/>
-          <p:nvPr/>
-        </p:nvSpPr>
-        <p:spPr>
-          <a:xfrm>
-            <a:off x="822960" y="6446520"/>
-            <a:ext cx="3840480" cy="274320"/>
-          </a:xfrm>
-          <a:prstGeom prst="rect">
-            <a:avLst/>
-          </a:prstGeom>
-          <a:noFill/>
-        </p:spPr>
-        <p:txBody>
-          <a:bodyPr wrap="square" anchor="t">
-            <a:spAutoFit/>
-          </a:bodyPr>
-          <a:lstStyle/>
-          <a:p>
-            <a:r>
-              <a:rPr sz="1000" b="0">
-                <a:solidFill>
-                  <a:srgbClr val="A8A29E"/>
-                </a:solidFill>
-                <a:latin typeface="Montserrat"/>
-              </a:rPr>
-              <a:t>Команда HTTP 418 · кейс #02 · Мадригал</a:t>
-            </a:r>
-          </a:p>
-        </p:txBody>
-      </p:sp>
-      <p:sp>
-        <p:nvSpPr>
-          <p:cNvPr id="9" name="TextBox 8"/>
-          <p:cNvSpPr txBox="1"/>
-          <p:nvPr/>
-        </p:nvSpPr>
-        <p:spPr>
-          <a:xfrm>
-            <a:off x="4389120" y="6446520"/>
-            <a:ext cx="3383280" cy="274320"/>
-          </a:xfrm>
-          <a:prstGeom prst="rect">
-            <a:avLst/>
-          </a:prstGeom>
-          <a:noFill/>
-        </p:spPr>
-        <p:txBody>
-          <a:bodyPr wrap="square" anchor="t">
-            <a:spAutoFit/>
-          </a:bodyPr>
-          <a:lstStyle/>
-          <a:p>
-            <a:pPr algn="ctr"/>
-            <a:r>
-              <a:rPr sz="1000" b="0">
-                <a:solidFill>
-                  <a:srgbClr val="A8A29E"/>
-                </a:solidFill>
-                <a:latin typeface="Montserrat"/>
-              </a:rPr>
-              <a:t>Результаты</a:t>
-            </a:r>
-          </a:p>
-        </p:txBody>
-      </p:sp>
-      <p:sp>
-        <p:nvSpPr>
-          <p:cNvPr id="10" name="TextBox 9"/>
-          <p:cNvSpPr txBox="1"/>
-          <p:nvPr/>
-        </p:nvSpPr>
-        <p:spPr>
-          <a:xfrm>
-            <a:off x="8138160" y="6446520"/>
-            <a:ext cx="3200400" cy="274320"/>
-          </a:xfrm>
-          <a:prstGeom prst="rect">
-            <a:avLst/>
-          </a:prstGeom>
-          <a:noFill/>
-        </p:spPr>
-        <p:txBody>
-          <a:bodyPr wrap="square" anchor="t">
-            <a:spAutoFit/>
-          </a:bodyPr>
-          <a:lstStyle/>
-          <a:p>
-            <a:pPr algn="r"/>
-            <a:r>
-              <a:rPr sz="1000" b="0">
-                <a:solidFill>
-                  <a:srgbClr val="A8A29E"/>
-                </a:solidFill>
-                <a:latin typeface="Montserrat"/>
-              </a:rPr>
-              <a:t>10 / 19</a:t>
-            </a:r>
-          </a:p>
-        </p:txBody>
-      </p:sp>
-    </p:spTree>
-  </p:cSld>
-  <p:clrMapOvr>
-    <a:masterClrMapping/>
-  </p:clrMapOvr>
-  <p:transition spd="med" fade="1"/>
-</p:sld>
-</file>
-
-<file path=ppt/slides/slide11.xml><?xml version="1.0" encoding="utf-8"?>
-<p:sld xmlns:a="http://schemas.openxmlformats.org/drawingml/2006/main" xmlns:p="http://schemas.openxmlformats.org/presentationml/2006/main" xmlns:r="http://schemas.openxmlformats.org/officeDocument/2006/relationships">
-  <p:cSld>
-    <p:spTree>
-      <p:nvGrpSpPr>
-        <p:cNvPr id="1" name=""/>
-        <p:cNvGrpSpPr/>
-        <p:nvPr/>
-      </p:nvGrpSpPr>
-      <p:grpSpPr/>
-      <p:sp>
-        <p:nvSpPr>
-          <p:cNvPr id="2" name="Rectangle 1"/>
-          <p:cNvSpPr/>
-          <p:nvPr/>
-        </p:nvSpPr>
-        <p:spPr>
-          <a:xfrm>
-            <a:off x="0" y="0"/>
-            <a:ext cx="12191695" cy="6858000"/>
-          </a:xfrm>
-          <a:prstGeom prst="rect">
-            <a:avLst/>
-          </a:prstGeom>
-          <a:solidFill>
-            <a:srgbClr val="0E1011"/>
-          </a:solidFill>
-          <a:ln>
-            <a:noFill/>
-          </a:ln>
-          <a:effectLst/>
-        </p:spPr>
-        <p:style>
-          <a:lnRef idx="1">
-            <a:schemeClr val="accent1"/>
-          </a:lnRef>
-          <a:fillRef idx="3">
-            <a:schemeClr val="accent1"/>
-          </a:fillRef>
-          <a:effectRef idx="2">
-            <a:schemeClr val="accent1"/>
-          </a:effectRef>
-          <a:fontRef idx="minor">
-            <a:schemeClr val="lt1"/>
-          </a:fontRef>
-        </p:style>
-        <p:txBody>
-          <a:bodyPr rtlCol="0" anchor="ctr"/>
-          <a:lstStyle/>
-          <a:p>
-            <a:pPr algn="ctr"/>
-          </a:p>
-        </p:txBody>
-      </p:sp>
-      <p:sp>
-        <p:nvSpPr>
-          <p:cNvPr id="3" name="Rectangle 2"/>
-          <p:cNvSpPr/>
-          <p:nvPr/>
-        </p:nvSpPr>
-        <p:spPr>
-          <a:xfrm>
-            <a:off x="0" y="0"/>
-            <a:ext cx="73152" cy="6858000"/>
-          </a:xfrm>
-          <a:prstGeom prst="rect">
-            <a:avLst/>
-          </a:prstGeom>
-          <a:ln>
-            <a:noFill/>
-          </a:ln>
-          <a:effectLst/>
-          <a:gradFill rotWithShape="1">
-            <a:gsLst>
-              <a:gs pos="0">
-                <a:srgbClr val="410913"/>
-              </a:gs>
-              <a:gs pos="50000">
-                <a:srgbClr val="610D1C"/>
-              </a:gs>
-              <a:gs pos="100000">
-                <a:srgbClr val="A2391D"/>
-              </a:gs>
-            </a:gsLst>
-            <a:lin ang="2700000"/>
-          </a:gradFill>
-        </p:spPr>
-        <p:style>
-          <a:lnRef idx="1">
-            <a:schemeClr val="accent1"/>
-          </a:lnRef>
-          <a:fillRef idx="3">
-            <a:schemeClr val="accent1"/>
-          </a:fillRef>
-          <a:effectRef idx="2">
-            <a:schemeClr val="accent1"/>
-          </a:effectRef>
-          <a:fontRef idx="minor">
-            <a:schemeClr val="lt1"/>
-          </a:fontRef>
-        </p:style>
-        <p:txBody>
-          <a:bodyPr rtlCol="0" anchor="ctr"/>
-          <a:lstStyle/>
-          <a:p>
-            <a:pPr algn="ctr"/>
-          </a:p>
-        </p:txBody>
-      </p:sp>
-      <p:sp>
-        <p:nvSpPr>
-          <p:cNvPr id="4" name="TextBox 3"/>
-          <p:cNvSpPr txBox="1"/>
-          <p:nvPr/>
-        </p:nvSpPr>
-        <p:spPr>
-          <a:xfrm>
-            <a:off x="822960" y="1188720"/>
-            <a:ext cx="10545775" cy="822960"/>
-          </a:xfrm>
-          <a:prstGeom prst="rect">
-            <a:avLst/>
-          </a:prstGeom>
-          <a:noFill/>
-        </p:spPr>
-        <p:txBody>
-          <a:bodyPr wrap="square" anchor="t">
-            <a:spAutoFit/>
-          </a:bodyPr>
-          <a:lstStyle/>
-          <a:p>
-            <a:r>
-              <a:rPr sz="3000" b="1">
-                <a:solidFill>
-                  <a:srgbClr val="F4F1EC"/>
-                </a:solidFill>
-                <a:latin typeface="Tektur"/>
-              </a:rPr>
-              <a:t>Уточнили правило: 60 из 140 → 140 из 140</a:t>
-            </a:r>
-          </a:p>
-        </p:txBody>
-      </p:sp>
-      <p:sp>
-        <p:nvSpPr>
-          <p:cNvPr id="5" name="TextBox 4"/>
-          <p:cNvSpPr txBox="1"/>
-          <p:nvPr/>
-        </p:nvSpPr>
-        <p:spPr>
-          <a:xfrm>
-            <a:off x="822960" y="1965960"/>
-            <a:ext cx="10545775" cy="457200"/>
-          </a:xfrm>
-          <a:prstGeom prst="rect">
-            <a:avLst/>
-          </a:prstGeom>
-          <a:noFill/>
-        </p:spPr>
-        <p:txBody>
-          <a:bodyPr wrap="square" anchor="t">
-            <a:spAutoFit/>
-          </a:bodyPr>
-          <a:lstStyle/>
-          <a:p>
-            <a:r>
-              <a:rPr sz="1400" b="0">
-                <a:solidFill>
-                  <a:srgbClr val="A8A29E"/>
-                </a:solidFill>
-                <a:latin typeface="Montserrat"/>
-              </a:rPr>
-              <a:t>На корпусе уточнения. Отдельно проверено на реальном датасете: 45 + 45, precision 1.00</a:t>
+              <a:t>140 / 140 на корпусе уточнения. Отдельно проверено на наборе организаторов: 45 + 45, precision 1.00</a:t>
             </a:r>
           </a:p>
         </p:txBody>
@@ -4558,42 +4198,8 @@
         </p:nvSpPr>
         <p:spPr>
           <a:xfrm>
-            <a:off x="822960" y="5394960"/>
-            <a:ext cx="10545775" cy="548640"/>
-          </a:xfrm>
-          <a:prstGeom prst="rect">
-            <a:avLst/>
-          </a:prstGeom>
-          <a:noFill/>
-        </p:spPr>
-        <p:txBody>
-          <a:bodyPr wrap="square" anchor="t">
-            <a:spAutoFit/>
-          </a:bodyPr>
-          <a:lstStyle/>
-          <a:p>
-            <a:r>
-              <a:rPr sz="1600" b="0">
-                <a:solidFill>
-                  <a:srgbClr val="F4F1EC"/>
-                </a:solidFill>
-                <a:latin typeface="Montserrat"/>
-              </a:rPr>
-              <a:t>Было 60 matched из 140 и 80 контрпримеров. Стало 140 matched из 140 и ноль контрпримеров</a:t>
-            </a:r>
-          </a:p>
-        </p:txBody>
-      </p:sp>
-      <p:sp>
-        <p:nvSpPr>
-          <p:cNvPr id="7" name="TextBox 6"/>
-          <p:cNvSpPr txBox="1"/>
-          <p:nvPr/>
-        </p:nvSpPr>
-        <p:spPr>
-          <a:xfrm>
-            <a:off x="822960" y="2788920"/>
-            <a:ext cx="914400" cy="640080"/>
+            <a:off x="822960" y="4160520"/>
+            <a:ext cx="914400" cy="548640"/>
           </a:xfrm>
           <a:prstGeom prst="rect">
             <a:avLst/>
@@ -4607,7 +4213,7 @@
           <a:lstStyle/>
           <a:p>
             <a:r>
-              <a:rPr sz="2200" b="0">
+              <a:rPr sz="1800" b="0">
                 <a:solidFill>
                   <a:srgbClr val="A8A29E"/>
                 </a:solidFill>
@@ -4620,14 +4226,14 @@
       </p:sp>
       <p:sp>
         <p:nvSpPr>
-          <p:cNvPr id="8" name="Rectangle 7"/>
+          <p:cNvPr id="7" name="Rectangle 6"/>
           <p:cNvSpPr/>
           <p:nvPr/>
         </p:nvSpPr>
         <p:spPr>
           <a:xfrm>
-            <a:off x="1828800" y="2834640"/>
-            <a:ext cx="7436815" cy="548640"/>
+            <a:off x="1737360" y="4233672"/>
+            <a:ext cx="7619695" cy="384048"/>
           </a:xfrm>
           <a:prstGeom prst="rect">
             <a:avLst/>
@@ -4664,14 +4270,14 @@
       </p:sp>
       <p:sp>
         <p:nvSpPr>
-          <p:cNvPr id="9" name="Rectangle 8"/>
+          <p:cNvPr id="8" name="Rectangle 7"/>
           <p:cNvSpPr/>
           <p:nvPr/>
         </p:nvSpPr>
         <p:spPr>
           <a:xfrm>
-            <a:off x="1828800" y="2834640"/>
-            <a:ext cx="3197830" cy="548640"/>
+            <a:off x="1737360" y="4233672"/>
+            <a:ext cx="3276468" cy="384048"/>
           </a:xfrm>
           <a:prstGeom prst="rect">
             <a:avLst/>
@@ -4708,14 +4314,14 @@
       </p:sp>
       <p:sp>
         <p:nvSpPr>
-          <p:cNvPr id="10" name="TextBox 9"/>
+          <p:cNvPr id="9" name="TextBox 8"/>
           <p:cNvSpPr txBox="1"/>
           <p:nvPr/>
         </p:nvSpPr>
         <p:spPr>
           <a:xfrm>
-            <a:off x="9357055" y="2788920"/>
-            <a:ext cx="2011680" cy="640080"/>
+            <a:off x="9539935" y="4160520"/>
+            <a:ext cx="1828800" cy="548640"/>
           </a:xfrm>
           <a:prstGeom prst="rect">
             <a:avLst/>
@@ -4730,7 +4336,7 @@
           <a:p>
             <a:pPr algn="r"/>
             <a:r>
-              <a:rPr sz="4000" b="1">
+              <a:rPr sz="2800" b="1">
                 <a:solidFill>
                   <a:srgbClr val="F4F1EC"/>
                 </a:solidFill>
@@ -4743,14 +4349,14 @@
       </p:sp>
       <p:sp>
         <p:nvSpPr>
-          <p:cNvPr id="11" name="TextBox 10"/>
+          <p:cNvPr id="10" name="TextBox 9"/>
           <p:cNvSpPr txBox="1"/>
           <p:nvPr/>
         </p:nvSpPr>
         <p:spPr>
           <a:xfrm>
-            <a:off x="822960" y="3977640"/>
-            <a:ext cx="914400" cy="640080"/>
+            <a:off x="822960" y="5029200"/>
+            <a:ext cx="914400" cy="548640"/>
           </a:xfrm>
           <a:prstGeom prst="rect">
             <a:avLst/>
@@ -4764,7 +4370,7 @@
           <a:lstStyle/>
           <a:p>
             <a:r>
-              <a:rPr sz="2200" b="0">
+              <a:rPr sz="1800" b="0">
                 <a:solidFill>
                   <a:srgbClr val="A8A29E"/>
                 </a:solidFill>
@@ -4777,14 +4383,14 @@
       </p:sp>
       <p:sp>
         <p:nvSpPr>
-          <p:cNvPr id="12" name="Rectangle 11"/>
+          <p:cNvPr id="11" name="Rectangle 10"/>
           <p:cNvSpPr/>
           <p:nvPr/>
         </p:nvSpPr>
         <p:spPr>
           <a:xfrm>
-            <a:off x="1828800" y="4023360"/>
-            <a:ext cx="7436815" cy="548640"/>
+            <a:off x="1737360" y="5102352"/>
+            <a:ext cx="7619695" cy="384048"/>
           </a:xfrm>
           <a:prstGeom prst="rect">
             <a:avLst/>
@@ -4821,14 +4427,14 @@
       </p:sp>
       <p:sp>
         <p:nvSpPr>
-          <p:cNvPr id="13" name="Rectangle 12"/>
+          <p:cNvPr id="12" name="Rectangle 11"/>
           <p:cNvSpPr/>
           <p:nvPr/>
         </p:nvSpPr>
         <p:spPr>
           <a:xfrm>
-            <a:off x="1828800" y="4023360"/>
-            <a:ext cx="7436815" cy="548640"/>
+            <a:off x="1737360" y="5102352"/>
+            <a:ext cx="7619695" cy="384048"/>
           </a:xfrm>
           <a:prstGeom prst="rect">
             <a:avLst/>
@@ -4865,14 +4471,14 @@
       </p:sp>
       <p:sp>
         <p:nvSpPr>
-          <p:cNvPr id="14" name="TextBox 13"/>
+          <p:cNvPr id="13" name="TextBox 12"/>
           <p:cNvSpPr txBox="1"/>
           <p:nvPr/>
         </p:nvSpPr>
         <p:spPr>
           <a:xfrm>
-            <a:off x="9357055" y="3977640"/>
-            <a:ext cx="2011680" cy="640080"/>
+            <a:off x="9539935" y="5029200"/>
+            <a:ext cx="1828800" cy="548640"/>
           </a:xfrm>
           <a:prstGeom prst="rect">
             <a:avLst/>
@@ -4887,7 +4493,7 @@
           <a:p>
             <a:pPr algn="r"/>
             <a:r>
-              <a:rPr sz="4000" b="1">
+              <a:rPr sz="2800" b="1">
                 <a:solidFill>
                   <a:srgbClr val="F4F1EC"/>
                 </a:solidFill>
@@ -4900,14 +4506,14 @@
       </p:sp>
       <p:sp>
         <p:nvSpPr>
-          <p:cNvPr id="15" name="TextBox 14"/>
+          <p:cNvPr id="14" name="TextBox 13"/>
           <p:cNvSpPr txBox="1"/>
           <p:nvPr/>
         </p:nvSpPr>
         <p:spPr>
           <a:xfrm>
-            <a:off x="822960" y="6446520"/>
-            <a:ext cx="3840480" cy="274320"/>
+            <a:off x="822960" y="6035040"/>
+            <a:ext cx="10545775" cy="365760"/>
           </a:xfrm>
           <a:prstGeom prst="rect">
             <a:avLst/>
@@ -4921,6 +4527,40 @@
           <a:lstStyle/>
           <a:p>
             <a:r>
+              <a:rPr sz="1400" b="0">
+                <a:solidFill>
+                  <a:srgbClr val="A8A29E"/>
+                </a:solidFill>
+                <a:latin typeface="Montserrat"/>
+              </a:rPr>
+              <a:t>Было 60 matched из 140 и 80 контрпримеров. Стало 140 matched из 140 и ноль контрпримеров</a:t>
+            </a:r>
+          </a:p>
+        </p:txBody>
+      </p:sp>
+      <p:sp>
+        <p:nvSpPr>
+          <p:cNvPr id="15" name="TextBox 14"/>
+          <p:cNvSpPr txBox="1"/>
+          <p:nvPr/>
+        </p:nvSpPr>
+        <p:spPr>
+          <a:xfrm>
+            <a:off x="822960" y="6446520"/>
+            <a:ext cx="3840480" cy="274320"/>
+          </a:xfrm>
+          <a:prstGeom prst="rect">
+            <a:avLst/>
+          </a:prstGeom>
+          <a:noFill/>
+        </p:spPr>
+        <p:txBody>
+          <a:bodyPr wrap="square" anchor="t">
+            <a:spAutoFit/>
+          </a:bodyPr>
+          <a:lstStyle/>
+          <a:p>
+            <a:r>
               <a:rPr sz="1000" b="0">
                 <a:solidFill>
                   <a:srgbClr val="A8A29E"/>
@@ -4997,7 +4637,7 @@
                 </a:solidFill>
                 <a:latin typeface="Montserrat"/>
               </a:rPr>
-              <a:t>11 / 19</a:t>
+              <a:t>10 / 14</a:t>
             </a:r>
           </a:p>
         </p:txBody>
@@ -5029,7 +4669,7 @@
                               </p:stCondLst>
                             </p:cTn>
                             <p:tgtEl>
-                              <p:spTgt spid="9"/>
+                              <p:spTgt spid="8"/>
                             </p:tgtEl>
                             <p:attrNameLst>
                               <p:attrName>style.visibility</p:attrName>
@@ -5043,7 +4683,7 @@
                           <p:cBhvr additive="base">
                             <p:cTn id="5" dur="300" fill="hold"/>
                             <p:tgtEl>
-                              <p:spTgt spid="9"/>
+                              <p:spTgt spid="8"/>
                             </p:tgtEl>
                             <p:attrNameLst>
                               <p:attrName>style.opacity</p:attrName>
@@ -5079,7 +4719,7 @@
                               </p:stCondLst>
                             </p:cTn>
                             <p:tgtEl>
-                              <p:spTgt spid="13"/>
+                              <p:spTgt spid="12"/>
                             </p:tgtEl>
                             <p:attrNameLst>
                               <p:attrName>style.visibility</p:attrName>
@@ -5093,7 +4733,7 @@
                           <p:cBhvr additive="base">
                             <p:cTn id="8" dur="300" fill="hold"/>
                             <p:tgtEl>
-                              <p:spTgt spid="13"/>
+                              <p:spTgt spid="12"/>
                             </p:tgtEl>
                             <p:attrNameLst>
                               <p:attrName>style.opacity</p:attrName>
@@ -5127,7 +4767,7 @@
 </p:sld>
 </file>
 
-<file path=ppt/slides/slide12.xml><?xml version="1.0" encoding="utf-8"?>
+<file path=ppt/slides/slide11.xml><?xml version="1.0" encoding="utf-8"?>
 <p:sld xmlns:a="http://schemas.openxmlformats.org/drawingml/2006/main" xmlns:p="http://schemas.openxmlformats.org/presentationml/2006/main" xmlns:r="http://schemas.openxmlformats.org/officeDocument/2006/relationships">
   <p:cSld>
     <p:spTree>
@@ -5265,388 +4905,6 @@
                 </a:solidFill>
                 <a:latin typeface="Tektur"/>
               </a:rPr>
-              <a:t>Набор организаторов разобран целиком</a:t>
-            </a:r>
-          </a:p>
-        </p:txBody>
-      </p:sp>
-      <p:sp>
-        <p:nvSpPr>
-          <p:cNvPr id="5" name="TextBox 4"/>
-          <p:cNvSpPr txBox="1"/>
-          <p:nvPr/>
-        </p:nvSpPr>
-        <p:spPr>
-          <a:xfrm>
-            <a:off x="822960" y="2286000"/>
-            <a:ext cx="5120640" cy="1828800"/>
-          </a:xfrm>
-          <a:prstGeom prst="rect">
-            <a:avLst/>
-          </a:prstGeom>
-          <a:noFill/>
-        </p:spPr>
-        <p:txBody>
-          <a:bodyPr wrap="square" anchor="t">
-            <a:spAutoFit/>
-          </a:bodyPr>
-          <a:lstStyle/>
-          <a:p>
-            <a:r>
-              <a:rPr sz="12000" b="1">
-                <a:solidFill>
-                  <a:srgbClr val="D0603A"/>
-                </a:solidFill>
-                <a:latin typeface="Tektur"/>
-              </a:rPr>
-              <a:t>90</a:t>
-            </a:r>
-          </a:p>
-        </p:txBody>
-      </p:sp>
-      <p:sp>
-        <p:nvSpPr>
-          <p:cNvPr id="6" name="TextBox 5"/>
-          <p:cNvSpPr txBox="1"/>
-          <p:nvPr/>
-        </p:nvSpPr>
-        <p:spPr>
-          <a:xfrm>
-            <a:off x="822960" y="4206240"/>
-            <a:ext cx="5120640" cy="1097280"/>
-          </a:xfrm>
-          <a:prstGeom prst="rect">
-            <a:avLst/>
-          </a:prstGeom>
-          <a:noFill/>
-        </p:spPr>
-        <p:txBody>
-          <a:bodyPr wrap="square" anchor="t">
-            <a:spAutoFit/>
-          </a:bodyPr>
-          <a:lstStyle/>
-          <a:p>
-            <a:r>
-              <a:rPr sz="1600" b="0">
-                <a:solidFill>
-                  <a:srgbClr val="F4F1EC"/>
-                </a:solidFill>
-                <a:latin typeface="Montserrat"/>
-              </a:rPr>
-              <a:t>45 запросов + 45 ответов. Все matched.</a:t>
-            </a:r>
-          </a:p>
-        </p:txBody>
-      </p:sp>
-      <p:pic>
-        <p:nvPicPr>
-          <p:cNvPr id="7" name="Picture 6" descr="coverage_donut.png"/>
-          <p:cNvPicPr>
-            <a:picLocks noChangeAspect="1"/>
-          </p:cNvPicPr>
-          <p:nvPr/>
-        </p:nvPicPr>
-        <p:blipFill>
-          <a:blip r:embed="rId2"/>
-          <a:stretch>
-            <a:fillRect/>
-          </a:stretch>
-        </p:blipFill>
-        <p:spPr>
-          <a:xfrm>
-            <a:off x="6035040" y="2011680"/>
-            <a:ext cx="4772264" cy="3657600"/>
-          </a:xfrm>
-          <a:prstGeom prst="rect">
-            <a:avLst/>
-          </a:prstGeom>
-        </p:spPr>
-      </p:pic>
-      <p:sp>
-        <p:nvSpPr>
-          <p:cNvPr id="8" name="TextBox 7"/>
-          <p:cNvSpPr txBox="1"/>
-          <p:nvPr/>
-        </p:nvSpPr>
-        <p:spPr>
-          <a:xfrm>
-            <a:off x="822960" y="6035040"/>
-            <a:ext cx="10545775" cy="365760"/>
-          </a:xfrm>
-          <a:prstGeom prst="rect">
-            <a:avLst/>
-          </a:prstGeom>
-          <a:noFill/>
-        </p:spPr>
-        <p:txBody>
-          <a:bodyPr wrap="square" anchor="t">
-            <a:spAutoFit/>
-          </a:bodyPr>
-          <a:lstStyle/>
-          <a:p>
-            <a:r>
-              <a:rPr sz="1400" b="0">
-                <a:solidFill>
-                  <a:srgbClr val="A8A29E"/>
-                </a:solidFill>
-                <a:latin typeface="Montserrat"/>
-              </a:rPr>
-              <a:t>Данные не использовались при уточнении правила</a:t>
-            </a:r>
-          </a:p>
-        </p:txBody>
-      </p:sp>
-      <p:sp>
-        <p:nvSpPr>
-          <p:cNvPr id="9" name="TextBox 8"/>
-          <p:cNvSpPr txBox="1"/>
-          <p:nvPr/>
-        </p:nvSpPr>
-        <p:spPr>
-          <a:xfrm>
-            <a:off x="822960" y="6446520"/>
-            <a:ext cx="3840480" cy="274320"/>
-          </a:xfrm>
-          <a:prstGeom prst="rect">
-            <a:avLst/>
-          </a:prstGeom>
-          <a:noFill/>
-        </p:spPr>
-        <p:txBody>
-          <a:bodyPr wrap="square" anchor="t">
-            <a:spAutoFit/>
-          </a:bodyPr>
-          <a:lstStyle/>
-          <a:p>
-            <a:r>
-              <a:rPr sz="1000" b="0">
-                <a:solidFill>
-                  <a:srgbClr val="A8A29E"/>
-                </a:solidFill>
-                <a:latin typeface="Montserrat"/>
-              </a:rPr>
-              <a:t>Команда HTTP 418 · кейс #02 · Мадригал</a:t>
-            </a:r>
-          </a:p>
-        </p:txBody>
-      </p:sp>
-      <p:sp>
-        <p:nvSpPr>
-          <p:cNvPr id="10" name="TextBox 9"/>
-          <p:cNvSpPr txBox="1"/>
-          <p:nvPr/>
-        </p:nvSpPr>
-        <p:spPr>
-          <a:xfrm>
-            <a:off x="4389120" y="6446520"/>
-            <a:ext cx="3383280" cy="274320"/>
-          </a:xfrm>
-          <a:prstGeom prst="rect">
-            <a:avLst/>
-          </a:prstGeom>
-          <a:noFill/>
-        </p:spPr>
-        <p:txBody>
-          <a:bodyPr wrap="square" anchor="t">
-            <a:spAutoFit/>
-          </a:bodyPr>
-          <a:lstStyle/>
-          <a:p>
-            <a:pPr algn="ctr"/>
-            <a:r>
-              <a:rPr sz="1000" b="0">
-                <a:solidFill>
-                  <a:srgbClr val="A8A29E"/>
-                </a:solidFill>
-                <a:latin typeface="Montserrat"/>
-              </a:rPr>
-              <a:t>Результаты</a:t>
-            </a:r>
-          </a:p>
-        </p:txBody>
-      </p:sp>
-      <p:sp>
-        <p:nvSpPr>
-          <p:cNvPr id="11" name="TextBox 10"/>
-          <p:cNvSpPr txBox="1"/>
-          <p:nvPr/>
-        </p:nvSpPr>
-        <p:spPr>
-          <a:xfrm>
-            <a:off x="8138160" y="6446520"/>
-            <a:ext cx="3200400" cy="274320"/>
-          </a:xfrm>
-          <a:prstGeom prst="rect">
-            <a:avLst/>
-          </a:prstGeom>
-          <a:noFill/>
-        </p:spPr>
-        <p:txBody>
-          <a:bodyPr wrap="square" anchor="t">
-            <a:spAutoFit/>
-          </a:bodyPr>
-          <a:lstStyle/>
-          <a:p>
-            <a:pPr algn="r"/>
-            <a:r>
-              <a:rPr sz="1000" b="0">
-                <a:solidFill>
-                  <a:srgbClr val="A8A29E"/>
-                </a:solidFill>
-                <a:latin typeface="Montserrat"/>
-              </a:rPr>
-              <a:t>12 / 19</a:t>
-            </a:r>
-          </a:p>
-        </p:txBody>
-      </p:sp>
-    </p:spTree>
-  </p:cSld>
-  <p:clrMapOvr>
-    <a:masterClrMapping/>
-  </p:clrMapOvr>
-  <p:transition spd="med" fade="1"/>
-</p:sld>
-</file>
-
-<file path=ppt/slides/slide13.xml><?xml version="1.0" encoding="utf-8"?>
-<p:sld xmlns:a="http://schemas.openxmlformats.org/drawingml/2006/main" xmlns:p="http://schemas.openxmlformats.org/presentationml/2006/main" xmlns:r="http://schemas.openxmlformats.org/officeDocument/2006/relationships">
-  <p:cSld>
-    <p:spTree>
-      <p:nvGrpSpPr>
-        <p:cNvPr id="1" name=""/>
-        <p:cNvGrpSpPr/>
-        <p:nvPr/>
-      </p:nvGrpSpPr>
-      <p:grpSpPr/>
-      <p:sp>
-        <p:nvSpPr>
-          <p:cNvPr id="2" name="Rectangle 1"/>
-          <p:cNvSpPr/>
-          <p:nvPr/>
-        </p:nvSpPr>
-        <p:spPr>
-          <a:xfrm>
-            <a:off x="0" y="0"/>
-            <a:ext cx="12191695" cy="6858000"/>
-          </a:xfrm>
-          <a:prstGeom prst="rect">
-            <a:avLst/>
-          </a:prstGeom>
-          <a:solidFill>
-            <a:srgbClr val="0E1011"/>
-          </a:solidFill>
-          <a:ln>
-            <a:noFill/>
-          </a:ln>
-          <a:effectLst/>
-        </p:spPr>
-        <p:style>
-          <a:lnRef idx="1">
-            <a:schemeClr val="accent1"/>
-          </a:lnRef>
-          <a:fillRef idx="3">
-            <a:schemeClr val="accent1"/>
-          </a:fillRef>
-          <a:effectRef idx="2">
-            <a:schemeClr val="accent1"/>
-          </a:effectRef>
-          <a:fontRef idx="minor">
-            <a:schemeClr val="lt1"/>
-          </a:fontRef>
-        </p:style>
-        <p:txBody>
-          <a:bodyPr rtlCol="0" anchor="ctr"/>
-          <a:lstStyle/>
-          <a:p>
-            <a:pPr algn="ctr"/>
-          </a:p>
-        </p:txBody>
-      </p:sp>
-      <p:sp>
-        <p:nvSpPr>
-          <p:cNvPr id="3" name="Rectangle 2"/>
-          <p:cNvSpPr/>
-          <p:nvPr/>
-        </p:nvSpPr>
-        <p:spPr>
-          <a:xfrm>
-            <a:off x="0" y="0"/>
-            <a:ext cx="73152" cy="6858000"/>
-          </a:xfrm>
-          <a:prstGeom prst="rect">
-            <a:avLst/>
-          </a:prstGeom>
-          <a:ln>
-            <a:noFill/>
-          </a:ln>
-          <a:effectLst/>
-          <a:gradFill rotWithShape="1">
-            <a:gsLst>
-              <a:gs pos="0">
-                <a:srgbClr val="410913"/>
-              </a:gs>
-              <a:gs pos="50000">
-                <a:srgbClr val="610D1C"/>
-              </a:gs>
-              <a:gs pos="100000">
-                <a:srgbClr val="A2391D"/>
-              </a:gs>
-            </a:gsLst>
-            <a:lin ang="2700000"/>
-          </a:gradFill>
-        </p:spPr>
-        <p:style>
-          <a:lnRef idx="1">
-            <a:schemeClr val="accent1"/>
-          </a:lnRef>
-          <a:fillRef idx="3">
-            <a:schemeClr val="accent1"/>
-          </a:fillRef>
-          <a:effectRef idx="2">
-            <a:schemeClr val="accent1"/>
-          </a:effectRef>
-          <a:fontRef idx="minor">
-            <a:schemeClr val="lt1"/>
-          </a:fontRef>
-        </p:style>
-        <p:txBody>
-          <a:bodyPr rtlCol="0" anchor="ctr"/>
-          <a:lstStyle/>
-          <a:p>
-            <a:pPr algn="ctr"/>
-          </a:p>
-        </p:txBody>
-      </p:sp>
-      <p:sp>
-        <p:nvSpPr>
-          <p:cNvPr id="4" name="TextBox 3"/>
-          <p:cNvSpPr txBox="1"/>
-          <p:nvPr/>
-        </p:nvSpPr>
-        <p:spPr>
-          <a:xfrm>
-            <a:off x="822960" y="1188720"/>
-            <a:ext cx="10545775" cy="822960"/>
-          </a:xfrm>
-          <a:prstGeom prst="rect">
-            <a:avLst/>
-          </a:prstGeom>
-          <a:noFill/>
-        </p:spPr>
-        <p:txBody>
-          <a:bodyPr wrap="square" anchor="t">
-            <a:spAutoFit/>
-          </a:bodyPr>
-          <a:lstStyle/>
-          <a:p>
-            <a:r>
-              <a:rPr sz="3000" b="1">
-                <a:solidFill>
-                  <a:srgbClr val="F4F1EC"/>
-                </a:solidFill>
-                <a:latin typeface="Tektur"/>
-              </a:rPr>
               <a:t>95 МиБ разбираются за 12 секунд</a:t>
             </a:r>
           </a:p>
@@ -6120,7 +5378,7 @@
                 </a:solidFill>
                 <a:latin typeface="Montserrat"/>
               </a:rPr>
-              <a:t>13 / 19</a:t>
+              <a:t>11 / 14</a:t>
             </a:r>
           </a:p>
         </p:txBody>
@@ -6300,7 +5558,7 @@
 </p:sld>
 </file>
 
-<file path=ppt/slides/slide14.xml><?xml version="1.0" encoding="utf-8"?>
+<file path=ppt/slides/slide12.xml><?xml version="1.0" encoding="utf-8"?>
 <p:sld xmlns:a="http://schemas.openxmlformats.org/drawingml/2006/main" xmlns:p="http://schemas.openxmlformats.org/presentationml/2006/main" xmlns:r="http://schemas.openxmlformats.org/officeDocument/2006/relationships">
   <p:cSld>
     <p:spTree>
@@ -6417,8 +5675,8 @@
         </p:nvSpPr>
         <p:spPr>
           <a:xfrm>
-            <a:off x="822960" y="2011680"/>
-            <a:ext cx="10545775" cy="1280160"/>
+            <a:off x="822960" y="457200"/>
+            <a:ext cx="10545775" cy="320040"/>
           </a:xfrm>
           <a:prstGeom prst="rect">
             <a:avLst/>
@@ -6432,13 +5690,13 @@
           <a:lstStyle/>
           <a:p>
             <a:r>
-              <a:rPr sz="7200" b="1">
+              <a:rPr sz="1400" b="1">
                 <a:solidFill>
                   <a:srgbClr val="D0603A"/>
                 </a:solidFill>
-                <a:latin typeface="Tektur"/>
+                <a:latin typeface="Montserrat"/>
               </a:rPr>
-              <a:t>02</a:t>
+              <a:t>ДЕМОНСТРАЦИЯ</a:t>
             </a:r>
           </a:p>
         </p:txBody>
@@ -6451,8 +5709,8 @@
         </p:nvSpPr>
         <p:spPr>
           <a:xfrm>
-            <a:off x="822960" y="3200400"/>
-            <a:ext cx="10545775" cy="914400"/>
+            <a:off x="822960" y="868680"/>
+            <a:ext cx="10545775" cy="822960"/>
           </a:xfrm>
           <a:prstGeom prst="rect">
             <a:avLst/>
@@ -6472,6 +5730,133 @@
                 </a:solidFill>
                 <a:latin typeface="Tektur"/>
               </a:rPr>
+              <a:t>Живое окно</a:t>
+            </a:r>
+          </a:p>
+        </p:txBody>
+      </p:sp>
+      <p:pic>
+        <p:nvPicPr>
+          <p:cNvPr id="6" name="Picture 5" descr="screenshot-main.png"/>
+          <p:cNvPicPr>
+            <a:picLocks noChangeAspect="1"/>
+          </p:cNvPicPr>
+          <p:nvPr/>
+        </p:nvPicPr>
+        <p:blipFill>
+          <a:blip r:embed="rId2"/>
+          <a:stretch>
+            <a:fillRect/>
+          </a:stretch>
+        </p:blipFill>
+        <p:spPr>
+          <a:xfrm>
+            <a:off x="822960" y="1691640"/>
+            <a:ext cx="10545775" cy="2708050"/>
+          </a:xfrm>
+          <a:prstGeom prst="rect">
+            <a:avLst/>
+          </a:prstGeom>
+        </p:spPr>
+      </p:pic>
+      <p:sp>
+        <p:nvSpPr>
+          <p:cNvPr id="7" name="TextBox 6"/>
+          <p:cNvSpPr txBox="1"/>
+          <p:nvPr/>
+        </p:nvSpPr>
+        <p:spPr>
+          <a:xfrm>
+            <a:off x="822960" y="6035040"/>
+            <a:ext cx="10545775" cy="365760"/>
+          </a:xfrm>
+          <a:prstGeom prst="rect">
+            <a:avLst/>
+          </a:prstGeom>
+          <a:noFill/>
+        </p:spPr>
+        <p:txBody>
+          <a:bodyPr wrap="square" anchor="t">
+            <a:spAutoFit/>
+          </a:bodyPr>
+          <a:lstStyle/>
+          <a:p>
+            <a:r>
+              <a:rPr sz="1400" b="0">
+                <a:solidFill>
+                  <a:srgbClr val="A8A29E"/>
+                </a:solidFill>
+                <a:latin typeface="Montserrat"/>
+              </a:rPr>
+              <a:t>Сессии, байты, интерпретация, происхождение и диагностика в одном окне</a:t>
+            </a:r>
+          </a:p>
+        </p:txBody>
+      </p:sp>
+      <p:sp>
+        <p:nvSpPr>
+          <p:cNvPr id="8" name="TextBox 7"/>
+          <p:cNvSpPr txBox="1"/>
+          <p:nvPr/>
+        </p:nvSpPr>
+        <p:spPr>
+          <a:xfrm>
+            <a:off x="822960" y="6446520"/>
+            <a:ext cx="3840480" cy="274320"/>
+          </a:xfrm>
+          <a:prstGeom prst="rect">
+            <a:avLst/>
+          </a:prstGeom>
+          <a:noFill/>
+        </p:spPr>
+        <p:txBody>
+          <a:bodyPr wrap="square" anchor="t">
+            <a:spAutoFit/>
+          </a:bodyPr>
+          <a:lstStyle/>
+          <a:p>
+            <a:r>
+              <a:rPr sz="1000" b="0">
+                <a:solidFill>
+                  <a:srgbClr val="A8A29E"/>
+                </a:solidFill>
+                <a:latin typeface="Montserrat"/>
+              </a:rPr>
+              <a:t>Команда HTTP 418 · кейс #02 · Мадригал</a:t>
+            </a:r>
+          </a:p>
+        </p:txBody>
+      </p:sp>
+      <p:sp>
+        <p:nvSpPr>
+          <p:cNvPr id="9" name="TextBox 8"/>
+          <p:cNvSpPr txBox="1"/>
+          <p:nvPr/>
+        </p:nvSpPr>
+        <p:spPr>
+          <a:xfrm>
+            <a:off x="4389120" y="6446520"/>
+            <a:ext cx="3383280" cy="274320"/>
+          </a:xfrm>
+          <a:prstGeom prst="rect">
+            <a:avLst/>
+          </a:prstGeom>
+          <a:noFill/>
+        </p:spPr>
+        <p:txBody>
+          <a:bodyPr wrap="square" anchor="t">
+            <a:spAutoFit/>
+          </a:bodyPr>
+          <a:lstStyle/>
+          <a:p>
+            <a:pPr algn="ctr"/>
+            <a:r>
+              <a:rPr sz="1000" b="0">
+                <a:solidFill>
+                  <a:srgbClr val="A8A29E"/>
+                </a:solidFill>
+                <a:latin typeface="Montserrat"/>
+              </a:rPr>
               <a:t>Демонстрация</a:t>
             </a:r>
           </a:p>
@@ -6479,14 +5864,112 @@
       </p:sp>
       <p:sp>
         <p:nvSpPr>
-          <p:cNvPr id="6" name="Rectangle 5"/>
+          <p:cNvPr id="10" name="TextBox 9"/>
+          <p:cNvSpPr txBox="1"/>
+          <p:nvPr/>
+        </p:nvSpPr>
+        <p:spPr>
+          <a:xfrm>
+            <a:off x="8138160" y="6446520"/>
+            <a:ext cx="3200400" cy="274320"/>
+          </a:xfrm>
+          <a:prstGeom prst="rect">
+            <a:avLst/>
+          </a:prstGeom>
+          <a:noFill/>
+        </p:spPr>
+        <p:txBody>
+          <a:bodyPr wrap="square" anchor="t">
+            <a:spAutoFit/>
+          </a:bodyPr>
+          <a:lstStyle/>
+          <a:p>
+            <a:pPr algn="r"/>
+            <a:r>
+              <a:rPr sz="1000" b="0">
+                <a:solidFill>
+                  <a:srgbClr val="A8A29E"/>
+                </a:solidFill>
+                <a:latin typeface="Montserrat"/>
+              </a:rPr>
+              <a:t>12 / 14</a:t>
+            </a:r>
+          </a:p>
+        </p:txBody>
+      </p:sp>
+    </p:spTree>
+  </p:cSld>
+  <p:clrMapOvr>
+    <a:masterClrMapping/>
+  </p:clrMapOvr>
+  <p:transition spd="med" fade="1"/>
+</p:sld>
+</file>
+
+<file path=ppt/slides/slide13.xml><?xml version="1.0" encoding="utf-8"?>
+<p:sld xmlns:a="http://schemas.openxmlformats.org/drawingml/2006/main" xmlns:p="http://schemas.openxmlformats.org/presentationml/2006/main" xmlns:r="http://schemas.openxmlformats.org/officeDocument/2006/relationships">
+  <p:cSld>
+    <p:spTree>
+      <p:nvGrpSpPr>
+        <p:cNvPr id="1" name=""/>
+        <p:cNvGrpSpPr/>
+        <p:nvPr/>
+      </p:nvGrpSpPr>
+      <p:grpSpPr/>
+      <p:sp>
+        <p:nvSpPr>
+          <p:cNvPr id="2" name="Rectangle 1"/>
           <p:cNvSpPr/>
           <p:nvPr/>
         </p:nvSpPr>
         <p:spPr>
           <a:xfrm>
-            <a:off x="822960" y="4206240"/>
-            <a:ext cx="3108960" cy="82296"/>
+            <a:off x="0" y="0"/>
+            <a:ext cx="12191695" cy="6858000"/>
+          </a:xfrm>
+          <a:prstGeom prst="rect">
+            <a:avLst/>
+          </a:prstGeom>
+          <a:solidFill>
+            <a:srgbClr val="0E1011"/>
+          </a:solidFill>
+          <a:ln>
+            <a:noFill/>
+          </a:ln>
+          <a:effectLst/>
+        </p:spPr>
+        <p:style>
+          <a:lnRef idx="1">
+            <a:schemeClr val="accent1"/>
+          </a:lnRef>
+          <a:fillRef idx="3">
+            <a:schemeClr val="accent1"/>
+          </a:fillRef>
+          <a:effectRef idx="2">
+            <a:schemeClr val="accent1"/>
+          </a:effectRef>
+          <a:fontRef idx="minor">
+            <a:schemeClr val="lt1"/>
+          </a:fontRef>
+        </p:style>
+        <p:txBody>
+          <a:bodyPr rtlCol="0" anchor="ctr"/>
+          <a:lstStyle/>
+          <a:p>
+            <a:pPr algn="ctr"/>
+          </a:p>
+        </p:txBody>
+      </p:sp>
+      <p:sp>
+        <p:nvSpPr>
+          <p:cNvPr id="3" name="Rectangle 2"/>
+          <p:cNvSpPr/>
+          <p:nvPr/>
+        </p:nvSpPr>
+        <p:spPr>
+          <a:xfrm>
+            <a:off x="0" y="0"/>
+            <a:ext cx="73152" cy="6858000"/>
           </a:xfrm>
           <a:prstGeom prst="rect">
             <a:avLst/>
@@ -6534,14 +6017,14 @@
       </p:sp>
       <p:sp>
         <p:nvSpPr>
-          <p:cNvPr id="7" name="TextBox 6"/>
+          <p:cNvPr id="4" name="TextBox 3"/>
           <p:cNvSpPr txBox="1"/>
           <p:nvPr/>
         </p:nvSpPr>
         <p:spPr>
           <a:xfrm>
-            <a:off x="822960" y="4480560"/>
-            <a:ext cx="10545775" cy="457200"/>
+            <a:off x="822960" y="457200"/>
+            <a:ext cx="10545775" cy="1051560"/>
           </a:xfrm>
           <a:prstGeom prst="rect">
             <a:avLst/>
@@ -6555,27 +6038,27 @@
           <a:lstStyle/>
           <a:p>
             <a:r>
-              <a:rPr sz="1600" b="0">
-                <a:solidFill>
-                  <a:srgbClr val="A8A29E"/>
-                </a:solidFill>
-                <a:latin typeface="Montserrat"/>
+              <a:rPr sz="4000" b="1">
+                <a:solidFill>
+                  <a:srgbClr val="F4F1EC"/>
+                </a:solidFill>
+                <a:latin typeface="Tektur"/>
               </a:rPr>
-              <a:t>Живое окно и запись прогона</a:t>
-            </a:r>
-          </a:p>
-        </p:txBody>
-      </p:sp>
-      <p:sp>
-        <p:nvSpPr>
-          <p:cNvPr id="8" name="TextBox 7"/>
+              <a:t>Что мы не утверждаем</a:t>
+            </a:r>
+          </a:p>
+        </p:txBody>
+      </p:sp>
+      <p:sp>
+        <p:nvSpPr>
+          <p:cNvPr id="5" name="TextBox 4"/>
           <p:cNvSpPr txBox="1"/>
           <p:nvPr/>
         </p:nvSpPr>
         <p:spPr>
           <a:xfrm>
-            <a:off x="822960" y="6446520"/>
-            <a:ext cx="3840480" cy="274320"/>
+            <a:off x="822960" y="1874520"/>
+            <a:ext cx="5044287" cy="914400"/>
           </a:xfrm>
           <a:prstGeom prst="rect">
             <a:avLst/>
@@ -6589,6 +6072,142 @@
           <a:lstStyle/>
           <a:p>
             <a:r>
+              <a:rPr sz="1700" b="0">
+                <a:solidFill>
+                  <a:srgbClr val="F4F1EC"/>
+                </a:solidFill>
+                <a:latin typeface="Montserrat"/>
+              </a:rPr>
+              <a:t>•  Смысл байта флагов не установлен: в корпусе он постоянен</a:t>
+            </a:r>
+          </a:p>
+        </p:txBody>
+      </p:sp>
+      <p:sp>
+        <p:nvSpPr>
+          <p:cNvPr id="6" name="TextBox 5"/>
+          <p:cNvSpPr txBox="1"/>
+          <p:nvPr/>
+        </p:nvSpPr>
+        <p:spPr>
+          <a:xfrm>
+            <a:off x="822960" y="2788920"/>
+            <a:ext cx="5044287" cy="914400"/>
+          </a:xfrm>
+          <a:prstGeom prst="rect">
+            <a:avLst/>
+          </a:prstGeom>
+          <a:noFill/>
+        </p:spPr>
+        <p:txBody>
+          <a:bodyPr wrap="square" anchor="t">
+            <a:spAutoFit/>
+          </a:bodyPr>
+          <a:lstStyle/>
+          <a:p>
+            <a:r>
+              <a:rPr sz="1700" b="0">
+                <a:solidFill>
+                  <a:srgbClr val="F4F1EC"/>
+                </a:solidFill>
+                <a:latin typeface="Montserrat"/>
+              </a:rPr>
+              <a:t>•  Поле значения остаётся гипотезой, а не фактом</a:t>
+            </a:r>
+          </a:p>
+        </p:txBody>
+      </p:sp>
+      <p:sp>
+        <p:nvSpPr>
+          <p:cNvPr id="7" name="TextBox 6"/>
+          <p:cNvSpPr txBox="1"/>
+          <p:nvPr/>
+        </p:nvSpPr>
+        <p:spPr>
+          <a:xfrm>
+            <a:off x="6324447" y="1874520"/>
+            <a:ext cx="5044287" cy="914400"/>
+          </a:xfrm>
+          <a:prstGeom prst="rect">
+            <a:avLst/>
+          </a:prstGeom>
+          <a:noFill/>
+        </p:spPr>
+        <p:txBody>
+          <a:bodyPr wrap="square" anchor="t">
+            <a:spAutoFit/>
+          </a:bodyPr>
+          <a:lstStyle/>
+          <a:p>
+            <a:r>
+              <a:rPr sz="1700" b="0">
+                <a:solidFill>
+                  <a:srgbClr val="F4F1EC"/>
+                </a:solidFill>
+                <a:latin typeface="Montserrat"/>
+              </a:rPr>
+              <a:t>•  Альтернативные чтения берутся из заданного набора</a:t>
+            </a:r>
+          </a:p>
+        </p:txBody>
+      </p:sp>
+      <p:sp>
+        <p:nvSpPr>
+          <p:cNvPr id="8" name="TextBox 7"/>
+          <p:cNvSpPr txBox="1"/>
+          <p:nvPr/>
+        </p:nvSpPr>
+        <p:spPr>
+          <a:xfrm>
+            <a:off x="6324447" y="2788920"/>
+            <a:ext cx="5044287" cy="914400"/>
+          </a:xfrm>
+          <a:prstGeom prst="rect">
+            <a:avLst/>
+          </a:prstGeom>
+          <a:noFill/>
+        </p:spPr>
+        <p:txBody>
+          <a:bodyPr wrap="square" anchor="t">
+            <a:spAutoFit/>
+          </a:bodyPr>
+          <a:lstStyle/>
+          <a:p>
+            <a:r>
+              <a:rPr sz="1700" b="0">
+                <a:solidFill>
+                  <a:srgbClr val="F4F1EC"/>
+                </a:solidFill>
+                <a:latin typeface="Montserrat"/>
+              </a:rPr>
+              <a:t>•  Интерпретация верна для проверенных захватов и молчит вне них</a:t>
+            </a:r>
+          </a:p>
+        </p:txBody>
+      </p:sp>
+      <p:sp>
+        <p:nvSpPr>
+          <p:cNvPr id="9" name="TextBox 8"/>
+          <p:cNvSpPr txBox="1"/>
+          <p:nvPr/>
+        </p:nvSpPr>
+        <p:spPr>
+          <a:xfrm>
+            <a:off x="822960" y="6446520"/>
+            <a:ext cx="3840480" cy="274320"/>
+          </a:xfrm>
+          <a:prstGeom prst="rect">
+            <a:avLst/>
+          </a:prstGeom>
+          <a:noFill/>
+        </p:spPr>
+        <p:txBody>
+          <a:bodyPr wrap="square" anchor="t">
+            <a:spAutoFit/>
+          </a:bodyPr>
+          <a:lstStyle/>
+          <a:p>
+            <a:r>
               <a:rPr sz="1000" b="0">
                 <a:solidFill>
                   <a:srgbClr val="A8A29E"/>
@@ -6602,7 +6221,7 @@
       </p:sp>
       <p:sp>
         <p:nvSpPr>
-          <p:cNvPr id="9" name="TextBox 8"/>
+          <p:cNvPr id="10" name="TextBox 9"/>
           <p:cNvSpPr txBox="1"/>
           <p:nvPr/>
         </p:nvSpPr>
@@ -6630,14 +6249,14 @@
                 </a:solidFill>
                 <a:latin typeface="Montserrat"/>
               </a:rPr>
-              <a:t>Демонстрация</a:t>
-            </a:r>
-          </a:p>
-        </p:txBody>
-      </p:sp>
-      <p:sp>
-        <p:nvSpPr>
-          <p:cNvPr id="10" name="TextBox 9"/>
+              <a:t>Границы и итог</a:t>
+            </a:r>
+          </a:p>
+        </p:txBody>
+      </p:sp>
+      <p:sp>
+        <p:nvSpPr>
+          <p:cNvPr id="11" name="TextBox 10"/>
           <p:cNvSpPr txBox="1"/>
           <p:nvPr/>
         </p:nvSpPr>
@@ -6665,7 +6284,7 @@
                 </a:solidFill>
                 <a:latin typeface="Montserrat"/>
               </a:rPr>
-              <a:t>14 / 19</a:t>
+              <a:t>13 / 14</a:t>
             </a:r>
           </a:p>
         </p:txBody>
@@ -6679,7 +6298,7 @@
 </p:sld>
 </file>
 
-<file path=ppt/slides/slide15.xml><?xml version="1.0" encoding="utf-8"?>
+<file path=ppt/slides/slide14.xml><?xml version="1.0" encoding="utf-8"?>
 <p:sld xmlns:a="http://schemas.openxmlformats.org/drawingml/2006/main" xmlns:p="http://schemas.openxmlformats.org/presentationml/2006/main" xmlns:r="http://schemas.openxmlformats.org/officeDocument/2006/relationships">
   <p:cSld>
     <p:spTree>
@@ -6796,8 +6415,8 @@
         </p:nvSpPr>
         <p:spPr>
           <a:xfrm>
-            <a:off x="822960" y="457200"/>
-            <a:ext cx="10545775" cy="1051560"/>
+            <a:off x="914400" y="1280160"/>
+            <a:ext cx="10362895" cy="1280160"/>
           </a:xfrm>
           <a:prstGeom prst="rect">
             <a:avLst/>
@@ -6810,21 +6429,22 @@
           </a:bodyPr>
           <a:lstStyle/>
           <a:p>
-            <a:r>
-              <a:rPr sz="4000" b="1">
+            <a:pPr algn="ctr"/>
+            <a:r>
+              <a:rPr sz="3400" b="1">
                 <a:solidFill>
                   <a:srgbClr val="F4F1EC"/>
                 </a:solidFill>
                 <a:latin typeface="Tektur"/>
               </a:rPr>
-              <a:t>Живое окно</a:t>
+              <a:t>Инструмент превращает байты в проверяемое знание</a:t>
             </a:r>
           </a:p>
         </p:txBody>
       </p:sp>
       <p:pic>
         <p:nvPicPr>
-          <p:cNvPr id="5" name="Picture 4" descr="screenshot-main.png"/>
+          <p:cNvPr id="5" name="Picture 4" descr="qr_repo.png"/>
           <p:cNvPicPr>
             <a:picLocks noChangeAspect="1"/>
           </p:cNvPicPr>
@@ -6838,1530 +6458,6 @@
         </p:blipFill>
         <p:spPr>
           <a:xfrm>
-            <a:off x="822960" y="1691640"/>
-            <a:ext cx="10545775" cy="2708050"/>
-          </a:xfrm>
-          <a:prstGeom prst="rect">
-            <a:avLst/>
-          </a:prstGeom>
-        </p:spPr>
-      </p:pic>
-      <p:sp>
-        <p:nvSpPr>
-          <p:cNvPr id="6" name="TextBox 5"/>
-          <p:cNvSpPr txBox="1"/>
-          <p:nvPr/>
-        </p:nvSpPr>
-        <p:spPr>
-          <a:xfrm>
-            <a:off x="822960" y="6035040"/>
-            <a:ext cx="10545775" cy="365760"/>
-          </a:xfrm>
-          <a:prstGeom prst="rect">
-            <a:avLst/>
-          </a:prstGeom>
-          <a:noFill/>
-        </p:spPr>
-        <p:txBody>
-          <a:bodyPr wrap="square" anchor="t">
-            <a:spAutoFit/>
-          </a:bodyPr>
-          <a:lstStyle/>
-          <a:p>
-            <a:r>
-              <a:rPr sz="1400" b="0">
-                <a:solidFill>
-                  <a:srgbClr val="A8A29E"/>
-                </a:solidFill>
-                <a:latin typeface="Montserrat"/>
-              </a:rPr>
-              <a:t>Сессии, байты, интерпретация, происхождение и диагностика в одном окне</a:t>
-            </a:r>
-          </a:p>
-        </p:txBody>
-      </p:sp>
-      <p:sp>
-        <p:nvSpPr>
-          <p:cNvPr id="7" name="TextBox 6"/>
-          <p:cNvSpPr txBox="1"/>
-          <p:nvPr/>
-        </p:nvSpPr>
-        <p:spPr>
-          <a:xfrm>
-            <a:off x="822960" y="6446520"/>
-            <a:ext cx="3840480" cy="274320"/>
-          </a:xfrm>
-          <a:prstGeom prst="rect">
-            <a:avLst/>
-          </a:prstGeom>
-          <a:noFill/>
-        </p:spPr>
-        <p:txBody>
-          <a:bodyPr wrap="square" anchor="t">
-            <a:spAutoFit/>
-          </a:bodyPr>
-          <a:lstStyle/>
-          <a:p>
-            <a:r>
-              <a:rPr sz="1000" b="0">
-                <a:solidFill>
-                  <a:srgbClr val="A8A29E"/>
-                </a:solidFill>
-                <a:latin typeface="Montserrat"/>
-              </a:rPr>
-              <a:t>Команда HTTP 418 · кейс #02 · Мадригал</a:t>
-            </a:r>
-          </a:p>
-        </p:txBody>
-      </p:sp>
-      <p:sp>
-        <p:nvSpPr>
-          <p:cNvPr id="8" name="TextBox 7"/>
-          <p:cNvSpPr txBox="1"/>
-          <p:nvPr/>
-        </p:nvSpPr>
-        <p:spPr>
-          <a:xfrm>
-            <a:off x="4389120" y="6446520"/>
-            <a:ext cx="3383280" cy="274320"/>
-          </a:xfrm>
-          <a:prstGeom prst="rect">
-            <a:avLst/>
-          </a:prstGeom>
-          <a:noFill/>
-        </p:spPr>
-        <p:txBody>
-          <a:bodyPr wrap="square" anchor="t">
-            <a:spAutoFit/>
-          </a:bodyPr>
-          <a:lstStyle/>
-          <a:p>
-            <a:pPr algn="ctr"/>
-            <a:r>
-              <a:rPr sz="1000" b="0">
-                <a:solidFill>
-                  <a:srgbClr val="A8A29E"/>
-                </a:solidFill>
-                <a:latin typeface="Montserrat"/>
-              </a:rPr>
-              <a:t>Демонстрация</a:t>
-            </a:r>
-          </a:p>
-        </p:txBody>
-      </p:sp>
-      <p:sp>
-        <p:nvSpPr>
-          <p:cNvPr id="9" name="TextBox 8"/>
-          <p:cNvSpPr txBox="1"/>
-          <p:nvPr/>
-        </p:nvSpPr>
-        <p:spPr>
-          <a:xfrm>
-            <a:off x="8138160" y="6446520"/>
-            <a:ext cx="3200400" cy="274320"/>
-          </a:xfrm>
-          <a:prstGeom prst="rect">
-            <a:avLst/>
-          </a:prstGeom>
-          <a:noFill/>
-        </p:spPr>
-        <p:txBody>
-          <a:bodyPr wrap="square" anchor="t">
-            <a:spAutoFit/>
-          </a:bodyPr>
-          <a:lstStyle/>
-          <a:p>
-            <a:pPr algn="r"/>
-            <a:r>
-              <a:rPr sz="1000" b="0">
-                <a:solidFill>
-                  <a:srgbClr val="A8A29E"/>
-                </a:solidFill>
-                <a:latin typeface="Montserrat"/>
-              </a:rPr>
-              <a:t>15 / 19</a:t>
-            </a:r>
-          </a:p>
-        </p:txBody>
-      </p:sp>
-    </p:spTree>
-  </p:cSld>
-  <p:clrMapOvr>
-    <a:masterClrMapping/>
-  </p:clrMapOvr>
-  <p:transition spd="med" fade="1"/>
-</p:sld>
-</file>
-
-<file path=ppt/slides/slide16.xml><?xml version="1.0" encoding="utf-8"?>
-<p:sld xmlns:a="http://schemas.openxmlformats.org/drawingml/2006/main" xmlns:p="http://schemas.openxmlformats.org/presentationml/2006/main" xmlns:r="http://schemas.openxmlformats.org/officeDocument/2006/relationships">
-  <p:cSld>
-    <p:spTree>
-      <p:nvGrpSpPr>
-        <p:cNvPr id="1" name=""/>
-        <p:cNvGrpSpPr/>
-        <p:nvPr/>
-      </p:nvGrpSpPr>
-      <p:grpSpPr/>
-      <p:sp>
-        <p:nvSpPr>
-          <p:cNvPr id="2" name="Rectangle 1"/>
-          <p:cNvSpPr/>
-          <p:nvPr/>
-        </p:nvSpPr>
-        <p:spPr>
-          <a:xfrm>
-            <a:off x="0" y="0"/>
-            <a:ext cx="12191695" cy="6858000"/>
-          </a:xfrm>
-          <a:prstGeom prst="rect">
-            <a:avLst/>
-          </a:prstGeom>
-          <a:solidFill>
-            <a:srgbClr val="0E1011"/>
-          </a:solidFill>
-          <a:ln>
-            <a:noFill/>
-          </a:ln>
-          <a:effectLst/>
-        </p:spPr>
-        <p:style>
-          <a:lnRef idx="1">
-            <a:schemeClr val="accent1"/>
-          </a:lnRef>
-          <a:fillRef idx="3">
-            <a:schemeClr val="accent1"/>
-          </a:fillRef>
-          <a:effectRef idx="2">
-            <a:schemeClr val="accent1"/>
-          </a:effectRef>
-          <a:fontRef idx="minor">
-            <a:schemeClr val="lt1"/>
-          </a:fontRef>
-        </p:style>
-        <p:txBody>
-          <a:bodyPr rtlCol="0" anchor="ctr"/>
-          <a:lstStyle/>
-          <a:p>
-            <a:pPr algn="ctr"/>
-          </a:p>
-        </p:txBody>
-      </p:sp>
-      <p:sp>
-        <p:nvSpPr>
-          <p:cNvPr id="3" name="Rectangle 2"/>
-          <p:cNvSpPr/>
-          <p:nvPr/>
-        </p:nvSpPr>
-        <p:spPr>
-          <a:xfrm>
-            <a:off x="0" y="0"/>
-            <a:ext cx="73152" cy="6858000"/>
-          </a:xfrm>
-          <a:prstGeom prst="rect">
-            <a:avLst/>
-          </a:prstGeom>
-          <a:ln>
-            <a:noFill/>
-          </a:ln>
-          <a:effectLst/>
-          <a:gradFill rotWithShape="1">
-            <a:gsLst>
-              <a:gs pos="0">
-                <a:srgbClr val="410913"/>
-              </a:gs>
-              <a:gs pos="50000">
-                <a:srgbClr val="610D1C"/>
-              </a:gs>
-              <a:gs pos="100000">
-                <a:srgbClr val="A2391D"/>
-              </a:gs>
-            </a:gsLst>
-            <a:lin ang="2700000"/>
-          </a:gradFill>
-        </p:spPr>
-        <p:style>
-          <a:lnRef idx="1">
-            <a:schemeClr val="accent1"/>
-          </a:lnRef>
-          <a:fillRef idx="3">
-            <a:schemeClr val="accent1"/>
-          </a:fillRef>
-          <a:effectRef idx="2">
-            <a:schemeClr val="accent1"/>
-          </a:effectRef>
-          <a:fontRef idx="minor">
-            <a:schemeClr val="lt1"/>
-          </a:fontRef>
-        </p:style>
-        <p:txBody>
-          <a:bodyPr rtlCol="0" anchor="ctr"/>
-          <a:lstStyle/>
-          <a:p>
-            <a:pPr algn="ctr"/>
-          </a:p>
-        </p:txBody>
-      </p:sp>
-      <p:sp>
-        <p:nvSpPr>
-          <p:cNvPr id="4" name="TextBox 3"/>
-          <p:cNvSpPr txBox="1"/>
-          <p:nvPr/>
-        </p:nvSpPr>
-        <p:spPr>
-          <a:xfrm>
-            <a:off x="822960" y="457200"/>
-            <a:ext cx="10545775" cy="1051560"/>
-          </a:xfrm>
-          <a:prstGeom prst="rect">
-            <a:avLst/>
-          </a:prstGeom>
-          <a:noFill/>
-        </p:spPr>
-        <p:txBody>
-          <a:bodyPr wrap="square" anchor="t">
-            <a:spAutoFit/>
-          </a:bodyPr>
-          <a:lstStyle/>
-          <a:p>
-            <a:r>
-              <a:rPr sz="4000" b="1">
-                <a:solidFill>
-                  <a:srgbClr val="F4F1EC"/>
-                </a:solidFill>
-                <a:latin typeface="Tektur"/>
-              </a:rPr>
-              <a:t>Резерв: запись прогона</a:t>
-            </a:r>
-          </a:p>
-        </p:txBody>
-      </p:sp>
-      <p:pic>
-        <p:nvPicPr>
-          <p:cNvPr id="5" name="Picture 4" descr="screencast-poster.png"/>
-          <p:cNvPicPr>
-            <a:picLocks noChangeAspect="1"/>
-          </p:cNvPicPr>
-          <p:nvPr/>
-        </p:nvPicPr>
-        <p:blipFill>
-          <a:blip r:embed="rId2"/>
-          <a:stretch>
-            <a:fillRect/>
-          </a:stretch>
-        </p:blipFill>
-        <p:spPr>
-          <a:xfrm>
-            <a:off x="822960" y="1691640"/>
-            <a:ext cx="5852160" cy="3291840"/>
-          </a:xfrm>
-          <a:prstGeom prst="rect">
-            <a:avLst/>
-          </a:prstGeom>
-        </p:spPr>
-      </p:pic>
-      <p:sp>
-        <p:nvSpPr>
-          <p:cNvPr id="6" name="Oval 5"/>
-          <p:cNvSpPr/>
-          <p:nvPr/>
-        </p:nvSpPr>
-        <p:spPr>
-          <a:xfrm>
-            <a:off x="6080760" y="4389120"/>
-            <a:ext cx="365760" cy="365760"/>
-          </a:xfrm>
-          <a:prstGeom prst="ellipse">
-            <a:avLst/>
-          </a:prstGeom>
-          <a:solidFill>
-            <a:srgbClr val="0E1011"/>
-          </a:solidFill>
-          <a:ln w="12700">
-            <a:solidFill>
-              <a:srgbClr val="D0603A"/>
-            </a:solidFill>
-          </a:ln>
-          <a:effectLst/>
-        </p:spPr>
-        <p:style>
-          <a:lnRef idx="1">
-            <a:schemeClr val="accent1"/>
-          </a:lnRef>
-          <a:fillRef idx="3">
-            <a:schemeClr val="accent1"/>
-          </a:fillRef>
-          <a:effectRef idx="2">
-            <a:schemeClr val="accent1"/>
-          </a:effectRef>
-          <a:fontRef idx="minor">
-            <a:schemeClr val="lt1"/>
-          </a:fontRef>
-        </p:style>
-        <p:txBody>
-          <a:bodyPr rtlCol="0" anchor="ctr"/>
-          <a:lstStyle/>
-          <a:p>
-            <a:pPr algn="ctr"/>
-          </a:p>
-        </p:txBody>
-      </p:sp>
-      <p:sp>
-        <p:nvSpPr>
-          <p:cNvPr id="7" name="Isosceles Triangle 6"/>
-          <p:cNvSpPr/>
-          <p:nvPr/>
-        </p:nvSpPr>
-        <p:spPr>
-          <a:xfrm rot="5400000">
-            <a:off x="6199632" y="4462272"/>
-            <a:ext cx="128016" cy="219456"/>
-          </a:xfrm>
-          <a:prstGeom prst="triangle">
-            <a:avLst/>
-          </a:prstGeom>
-          <a:solidFill>
-            <a:srgbClr val="D0603A"/>
-          </a:solidFill>
-          <a:ln>
-            <a:noFill/>
-          </a:ln>
-          <a:effectLst/>
-        </p:spPr>
-        <p:style>
-          <a:lnRef idx="1">
-            <a:schemeClr val="accent1"/>
-          </a:lnRef>
-          <a:fillRef idx="3">
-            <a:schemeClr val="accent1"/>
-          </a:fillRef>
-          <a:effectRef idx="2">
-            <a:schemeClr val="accent1"/>
-          </a:effectRef>
-          <a:fontRef idx="minor">
-            <a:schemeClr val="lt1"/>
-          </a:fontRef>
-        </p:style>
-        <p:txBody>
-          <a:bodyPr rtlCol="0" anchor="ctr"/>
-          <a:lstStyle/>
-          <a:p>
-            <a:pPr algn="ctr"/>
-          </a:p>
-        </p:txBody>
-      </p:sp>
-      <p:sp>
-        <p:nvSpPr>
-          <p:cNvPr id="8" name="TextBox 7"/>
-          <p:cNvSpPr txBox="1"/>
-          <p:nvPr/>
-        </p:nvSpPr>
-        <p:spPr>
-          <a:xfrm>
-            <a:off x="822960" y="5394960"/>
-            <a:ext cx="10545775" cy="365760"/>
-          </a:xfrm>
-          <a:prstGeom prst="rect">
-            <a:avLst/>
-          </a:prstGeom>
-          <a:noFill/>
-        </p:spPr>
-        <p:txBody>
-          <a:bodyPr wrap="square" anchor="t">
-            <a:spAutoFit/>
-          </a:bodyPr>
-          <a:lstStyle/>
-          <a:p>
-            <a:r>
-              <a:rPr sz="1400" b="0">
-                <a:solidFill>
-                  <a:srgbClr val="A8A29E"/>
-                </a:solidFill>
-                <a:latin typeface="JetBrains Mono"/>
-              </a:rPr>
-              <a:t>Полный прогон референсного исследования · 2:22 · без звука</a:t>
-            </a:r>
-          </a:p>
-        </p:txBody>
-      </p:sp>
-      <p:sp>
-        <p:nvSpPr>
-          <p:cNvPr id="9" name="TextBox 8"/>
-          <p:cNvSpPr txBox="1"/>
-          <p:nvPr/>
-        </p:nvSpPr>
-        <p:spPr>
-          <a:xfrm>
-            <a:off x="822960" y="6035040"/>
-            <a:ext cx="10545775" cy="365760"/>
-          </a:xfrm>
-          <a:prstGeom prst="rect">
-            <a:avLst/>
-          </a:prstGeom>
-          <a:noFill/>
-        </p:spPr>
-        <p:txBody>
-          <a:bodyPr wrap="square" anchor="t">
-            <a:spAutoFit/>
-          </a:bodyPr>
-          <a:lstStyle/>
-          <a:p>
-            <a:r>
-              <a:rPr sz="1400" b="0">
-                <a:solidFill>
-                  <a:srgbClr val="A8A29E"/>
-                </a:solidFill>
-                <a:latin typeface="Montserrat"/>
-              </a:rPr>
-              <a:t>Играется, если живое окно не поднимется на защите</a:t>
-            </a:r>
-          </a:p>
-        </p:txBody>
-      </p:sp>
-      <p:sp>
-        <p:nvSpPr>
-          <p:cNvPr id="10" name="TextBox 9"/>
-          <p:cNvSpPr txBox="1"/>
-          <p:nvPr/>
-        </p:nvSpPr>
-        <p:spPr>
-          <a:xfrm>
-            <a:off x="822960" y="6446520"/>
-            <a:ext cx="3840480" cy="274320"/>
-          </a:xfrm>
-          <a:prstGeom prst="rect">
-            <a:avLst/>
-          </a:prstGeom>
-          <a:noFill/>
-        </p:spPr>
-        <p:txBody>
-          <a:bodyPr wrap="square" anchor="t">
-            <a:spAutoFit/>
-          </a:bodyPr>
-          <a:lstStyle/>
-          <a:p>
-            <a:r>
-              <a:rPr sz="1000" b="0">
-                <a:solidFill>
-                  <a:srgbClr val="A8A29E"/>
-                </a:solidFill>
-                <a:latin typeface="Montserrat"/>
-              </a:rPr>
-              <a:t>Команда HTTP 418 · кейс #02 · Мадригал</a:t>
-            </a:r>
-          </a:p>
-        </p:txBody>
-      </p:sp>
-      <p:sp>
-        <p:nvSpPr>
-          <p:cNvPr id="11" name="TextBox 10"/>
-          <p:cNvSpPr txBox="1"/>
-          <p:nvPr/>
-        </p:nvSpPr>
-        <p:spPr>
-          <a:xfrm>
-            <a:off x="4389120" y="6446520"/>
-            <a:ext cx="3383280" cy="274320"/>
-          </a:xfrm>
-          <a:prstGeom prst="rect">
-            <a:avLst/>
-          </a:prstGeom>
-          <a:noFill/>
-        </p:spPr>
-        <p:txBody>
-          <a:bodyPr wrap="square" anchor="t">
-            <a:spAutoFit/>
-          </a:bodyPr>
-          <a:lstStyle/>
-          <a:p>
-            <a:pPr algn="ctr"/>
-            <a:r>
-              <a:rPr sz="1000" b="0">
-                <a:solidFill>
-                  <a:srgbClr val="A8A29E"/>
-                </a:solidFill>
-                <a:latin typeface="Montserrat"/>
-              </a:rPr>
-              <a:t>Демонстрация</a:t>
-            </a:r>
-          </a:p>
-        </p:txBody>
-      </p:sp>
-      <p:sp>
-        <p:nvSpPr>
-          <p:cNvPr id="12" name="TextBox 11"/>
-          <p:cNvSpPr txBox="1"/>
-          <p:nvPr/>
-        </p:nvSpPr>
-        <p:spPr>
-          <a:xfrm>
-            <a:off x="8138160" y="6446520"/>
-            <a:ext cx="3200400" cy="274320"/>
-          </a:xfrm>
-          <a:prstGeom prst="rect">
-            <a:avLst/>
-          </a:prstGeom>
-          <a:noFill/>
-        </p:spPr>
-        <p:txBody>
-          <a:bodyPr wrap="square" anchor="t">
-            <a:spAutoFit/>
-          </a:bodyPr>
-          <a:lstStyle/>
-          <a:p>
-            <a:pPr algn="r"/>
-            <a:r>
-              <a:rPr sz="1000" b="0">
-                <a:solidFill>
-                  <a:srgbClr val="A8A29E"/>
-                </a:solidFill>
-                <a:latin typeface="Montserrat"/>
-              </a:rPr>
-              <a:t>16 / 19</a:t>
-            </a:r>
-          </a:p>
-        </p:txBody>
-      </p:sp>
-    </p:spTree>
-  </p:cSld>
-  <p:clrMapOvr>
-    <a:masterClrMapping/>
-  </p:clrMapOvr>
-  <p:transition spd="med" fade="1"/>
-</p:sld>
-</file>
-
-<file path=ppt/slides/slide17.xml><?xml version="1.0" encoding="utf-8"?>
-<p:sld xmlns:a="http://schemas.openxmlformats.org/drawingml/2006/main" xmlns:p="http://schemas.openxmlformats.org/presentationml/2006/main" xmlns:r="http://schemas.openxmlformats.org/officeDocument/2006/relationships">
-  <p:cSld>
-    <p:spTree>
-      <p:nvGrpSpPr>
-        <p:cNvPr id="1" name=""/>
-        <p:cNvGrpSpPr/>
-        <p:nvPr/>
-      </p:nvGrpSpPr>
-      <p:grpSpPr/>
-      <p:sp>
-        <p:nvSpPr>
-          <p:cNvPr id="2" name="Rectangle 1"/>
-          <p:cNvSpPr/>
-          <p:nvPr/>
-        </p:nvSpPr>
-        <p:spPr>
-          <a:xfrm>
-            <a:off x="0" y="0"/>
-            <a:ext cx="12191695" cy="6858000"/>
-          </a:xfrm>
-          <a:prstGeom prst="rect">
-            <a:avLst/>
-          </a:prstGeom>
-          <a:solidFill>
-            <a:srgbClr val="0E1011"/>
-          </a:solidFill>
-          <a:ln>
-            <a:noFill/>
-          </a:ln>
-          <a:effectLst/>
-        </p:spPr>
-        <p:style>
-          <a:lnRef idx="1">
-            <a:schemeClr val="accent1"/>
-          </a:lnRef>
-          <a:fillRef idx="3">
-            <a:schemeClr val="accent1"/>
-          </a:fillRef>
-          <a:effectRef idx="2">
-            <a:schemeClr val="accent1"/>
-          </a:effectRef>
-          <a:fontRef idx="minor">
-            <a:schemeClr val="lt1"/>
-          </a:fontRef>
-        </p:style>
-        <p:txBody>
-          <a:bodyPr rtlCol="0" anchor="ctr"/>
-          <a:lstStyle/>
-          <a:p>
-            <a:pPr algn="ctr"/>
-          </a:p>
-        </p:txBody>
-      </p:sp>
-      <p:sp>
-        <p:nvSpPr>
-          <p:cNvPr id="3" name="Rectangle 2"/>
-          <p:cNvSpPr/>
-          <p:nvPr/>
-        </p:nvSpPr>
-        <p:spPr>
-          <a:xfrm>
-            <a:off x="0" y="0"/>
-            <a:ext cx="73152" cy="6858000"/>
-          </a:xfrm>
-          <a:prstGeom prst="rect">
-            <a:avLst/>
-          </a:prstGeom>
-          <a:ln>
-            <a:noFill/>
-          </a:ln>
-          <a:effectLst/>
-          <a:gradFill rotWithShape="1">
-            <a:gsLst>
-              <a:gs pos="0">
-                <a:srgbClr val="410913"/>
-              </a:gs>
-              <a:gs pos="50000">
-                <a:srgbClr val="610D1C"/>
-              </a:gs>
-              <a:gs pos="100000">
-                <a:srgbClr val="A2391D"/>
-              </a:gs>
-            </a:gsLst>
-            <a:lin ang="2700000"/>
-          </a:gradFill>
-        </p:spPr>
-        <p:style>
-          <a:lnRef idx="1">
-            <a:schemeClr val="accent1"/>
-          </a:lnRef>
-          <a:fillRef idx="3">
-            <a:schemeClr val="accent1"/>
-          </a:fillRef>
-          <a:effectRef idx="2">
-            <a:schemeClr val="accent1"/>
-          </a:effectRef>
-          <a:fontRef idx="minor">
-            <a:schemeClr val="lt1"/>
-          </a:fontRef>
-        </p:style>
-        <p:txBody>
-          <a:bodyPr rtlCol="0" anchor="ctr"/>
-          <a:lstStyle/>
-          <a:p>
-            <a:pPr algn="ctr"/>
-          </a:p>
-        </p:txBody>
-      </p:sp>
-      <p:sp>
-        <p:nvSpPr>
-          <p:cNvPr id="4" name="TextBox 3"/>
-          <p:cNvSpPr txBox="1"/>
-          <p:nvPr/>
-        </p:nvSpPr>
-        <p:spPr>
-          <a:xfrm>
-            <a:off x="822960" y="2011680"/>
-            <a:ext cx="10545775" cy="1280160"/>
-          </a:xfrm>
-          <a:prstGeom prst="rect">
-            <a:avLst/>
-          </a:prstGeom>
-          <a:noFill/>
-        </p:spPr>
-        <p:txBody>
-          <a:bodyPr wrap="square" anchor="t">
-            <a:spAutoFit/>
-          </a:bodyPr>
-          <a:lstStyle/>
-          <a:p>
-            <a:r>
-              <a:rPr sz="7200" b="1">
-                <a:solidFill>
-                  <a:srgbClr val="D0603A"/>
-                </a:solidFill>
-                <a:latin typeface="Tektur"/>
-              </a:rPr>
-              <a:t>03</a:t>
-            </a:r>
-          </a:p>
-        </p:txBody>
-      </p:sp>
-      <p:sp>
-        <p:nvSpPr>
-          <p:cNvPr id="5" name="TextBox 4"/>
-          <p:cNvSpPr txBox="1"/>
-          <p:nvPr/>
-        </p:nvSpPr>
-        <p:spPr>
-          <a:xfrm>
-            <a:off x="822960" y="3200400"/>
-            <a:ext cx="10545775" cy="914400"/>
-          </a:xfrm>
-          <a:prstGeom prst="rect">
-            <a:avLst/>
-          </a:prstGeom>
-          <a:noFill/>
-        </p:spPr>
-        <p:txBody>
-          <a:bodyPr wrap="square" anchor="t">
-            <a:spAutoFit/>
-          </a:bodyPr>
-          <a:lstStyle/>
-          <a:p>
-            <a:r>
-              <a:rPr sz="4000" b="1">
-                <a:solidFill>
-                  <a:srgbClr val="F4F1EC"/>
-                </a:solidFill>
-                <a:latin typeface="Tektur"/>
-              </a:rPr>
-              <a:t>Границы и итог</a:t>
-            </a:r>
-          </a:p>
-        </p:txBody>
-      </p:sp>
-      <p:sp>
-        <p:nvSpPr>
-          <p:cNvPr id="6" name="Rectangle 5"/>
-          <p:cNvSpPr/>
-          <p:nvPr/>
-        </p:nvSpPr>
-        <p:spPr>
-          <a:xfrm>
-            <a:off x="822960" y="4206240"/>
-            <a:ext cx="3108960" cy="82296"/>
-          </a:xfrm>
-          <a:prstGeom prst="rect">
-            <a:avLst/>
-          </a:prstGeom>
-          <a:ln>
-            <a:noFill/>
-          </a:ln>
-          <a:effectLst/>
-          <a:gradFill rotWithShape="1">
-            <a:gsLst>
-              <a:gs pos="0">
-                <a:srgbClr val="410913"/>
-              </a:gs>
-              <a:gs pos="50000">
-                <a:srgbClr val="610D1C"/>
-              </a:gs>
-              <a:gs pos="100000">
-                <a:srgbClr val="A2391D"/>
-              </a:gs>
-            </a:gsLst>
-            <a:lin ang="2700000"/>
-          </a:gradFill>
-        </p:spPr>
-        <p:style>
-          <a:lnRef idx="1">
-            <a:schemeClr val="accent1"/>
-          </a:lnRef>
-          <a:fillRef idx="3">
-            <a:schemeClr val="accent1"/>
-          </a:fillRef>
-          <a:effectRef idx="2">
-            <a:schemeClr val="accent1"/>
-          </a:effectRef>
-          <a:fontRef idx="minor">
-            <a:schemeClr val="lt1"/>
-          </a:fontRef>
-        </p:style>
-        <p:txBody>
-          <a:bodyPr rtlCol="0" anchor="ctr"/>
-          <a:lstStyle/>
-          <a:p>
-            <a:pPr algn="ctr"/>
-          </a:p>
-        </p:txBody>
-      </p:sp>
-      <p:sp>
-        <p:nvSpPr>
-          <p:cNvPr id="7" name="TextBox 6"/>
-          <p:cNvSpPr txBox="1"/>
-          <p:nvPr/>
-        </p:nvSpPr>
-        <p:spPr>
-          <a:xfrm>
-            <a:off x="822960" y="4480560"/>
-            <a:ext cx="10545775" cy="457200"/>
-          </a:xfrm>
-          <a:prstGeom prst="rect">
-            <a:avLst/>
-          </a:prstGeom>
-          <a:noFill/>
-        </p:spPr>
-        <p:txBody>
-          <a:bodyPr wrap="square" anchor="t">
-            <a:spAutoFit/>
-          </a:bodyPr>
-          <a:lstStyle/>
-          <a:p>
-            <a:r>
-              <a:rPr sz="1600" b="0">
-                <a:solidFill>
-                  <a:srgbClr val="A8A29E"/>
-                </a:solidFill>
-                <a:latin typeface="Montserrat"/>
-              </a:rPr>
-              <a:t>Что мы не утверждаем и что осталось за рамками</a:t>
-            </a:r>
-          </a:p>
-        </p:txBody>
-      </p:sp>
-      <p:sp>
-        <p:nvSpPr>
-          <p:cNvPr id="8" name="TextBox 7"/>
-          <p:cNvSpPr txBox="1"/>
-          <p:nvPr/>
-        </p:nvSpPr>
-        <p:spPr>
-          <a:xfrm>
-            <a:off x="822960" y="6446520"/>
-            <a:ext cx="3840480" cy="274320"/>
-          </a:xfrm>
-          <a:prstGeom prst="rect">
-            <a:avLst/>
-          </a:prstGeom>
-          <a:noFill/>
-        </p:spPr>
-        <p:txBody>
-          <a:bodyPr wrap="square" anchor="t">
-            <a:spAutoFit/>
-          </a:bodyPr>
-          <a:lstStyle/>
-          <a:p>
-            <a:r>
-              <a:rPr sz="1000" b="0">
-                <a:solidFill>
-                  <a:srgbClr val="A8A29E"/>
-                </a:solidFill>
-                <a:latin typeface="Montserrat"/>
-              </a:rPr>
-              <a:t>Команда HTTP 418 · кейс #02 · Мадригал</a:t>
-            </a:r>
-          </a:p>
-        </p:txBody>
-      </p:sp>
-      <p:sp>
-        <p:nvSpPr>
-          <p:cNvPr id="9" name="TextBox 8"/>
-          <p:cNvSpPr txBox="1"/>
-          <p:nvPr/>
-        </p:nvSpPr>
-        <p:spPr>
-          <a:xfrm>
-            <a:off x="4389120" y="6446520"/>
-            <a:ext cx="3383280" cy="274320"/>
-          </a:xfrm>
-          <a:prstGeom prst="rect">
-            <a:avLst/>
-          </a:prstGeom>
-          <a:noFill/>
-        </p:spPr>
-        <p:txBody>
-          <a:bodyPr wrap="square" anchor="t">
-            <a:spAutoFit/>
-          </a:bodyPr>
-          <a:lstStyle/>
-          <a:p>
-            <a:pPr algn="ctr"/>
-            <a:r>
-              <a:rPr sz="1000" b="0">
-                <a:solidFill>
-                  <a:srgbClr val="A8A29E"/>
-                </a:solidFill>
-                <a:latin typeface="Montserrat"/>
-              </a:rPr>
-              <a:t>Границы и итог</a:t>
-            </a:r>
-          </a:p>
-        </p:txBody>
-      </p:sp>
-      <p:sp>
-        <p:nvSpPr>
-          <p:cNvPr id="10" name="TextBox 9"/>
-          <p:cNvSpPr txBox="1"/>
-          <p:nvPr/>
-        </p:nvSpPr>
-        <p:spPr>
-          <a:xfrm>
-            <a:off x="8138160" y="6446520"/>
-            <a:ext cx="3200400" cy="274320"/>
-          </a:xfrm>
-          <a:prstGeom prst="rect">
-            <a:avLst/>
-          </a:prstGeom>
-          <a:noFill/>
-        </p:spPr>
-        <p:txBody>
-          <a:bodyPr wrap="square" anchor="t">
-            <a:spAutoFit/>
-          </a:bodyPr>
-          <a:lstStyle/>
-          <a:p>
-            <a:pPr algn="r"/>
-            <a:r>
-              <a:rPr sz="1000" b="0">
-                <a:solidFill>
-                  <a:srgbClr val="A8A29E"/>
-                </a:solidFill>
-                <a:latin typeface="Montserrat"/>
-              </a:rPr>
-              <a:t>17 / 19</a:t>
-            </a:r>
-          </a:p>
-        </p:txBody>
-      </p:sp>
-    </p:spTree>
-  </p:cSld>
-  <p:clrMapOvr>
-    <a:masterClrMapping/>
-  </p:clrMapOvr>
-  <p:transition spd="med" fade="1"/>
-</p:sld>
-</file>
-
-<file path=ppt/slides/slide18.xml><?xml version="1.0" encoding="utf-8"?>
-<p:sld xmlns:a="http://schemas.openxmlformats.org/drawingml/2006/main" xmlns:p="http://schemas.openxmlformats.org/presentationml/2006/main" xmlns:r="http://schemas.openxmlformats.org/officeDocument/2006/relationships">
-  <p:cSld>
-    <p:spTree>
-      <p:nvGrpSpPr>
-        <p:cNvPr id="1" name=""/>
-        <p:cNvGrpSpPr/>
-        <p:nvPr/>
-      </p:nvGrpSpPr>
-      <p:grpSpPr/>
-      <p:sp>
-        <p:nvSpPr>
-          <p:cNvPr id="2" name="Rectangle 1"/>
-          <p:cNvSpPr/>
-          <p:nvPr/>
-        </p:nvSpPr>
-        <p:spPr>
-          <a:xfrm>
-            <a:off x="0" y="0"/>
-            <a:ext cx="12191695" cy="6858000"/>
-          </a:xfrm>
-          <a:prstGeom prst="rect">
-            <a:avLst/>
-          </a:prstGeom>
-          <a:solidFill>
-            <a:srgbClr val="0E1011"/>
-          </a:solidFill>
-          <a:ln>
-            <a:noFill/>
-          </a:ln>
-          <a:effectLst/>
-        </p:spPr>
-        <p:style>
-          <a:lnRef idx="1">
-            <a:schemeClr val="accent1"/>
-          </a:lnRef>
-          <a:fillRef idx="3">
-            <a:schemeClr val="accent1"/>
-          </a:fillRef>
-          <a:effectRef idx="2">
-            <a:schemeClr val="accent1"/>
-          </a:effectRef>
-          <a:fontRef idx="minor">
-            <a:schemeClr val="lt1"/>
-          </a:fontRef>
-        </p:style>
-        <p:txBody>
-          <a:bodyPr rtlCol="0" anchor="ctr"/>
-          <a:lstStyle/>
-          <a:p>
-            <a:pPr algn="ctr"/>
-          </a:p>
-        </p:txBody>
-      </p:sp>
-      <p:sp>
-        <p:nvSpPr>
-          <p:cNvPr id="3" name="Rectangle 2"/>
-          <p:cNvSpPr/>
-          <p:nvPr/>
-        </p:nvSpPr>
-        <p:spPr>
-          <a:xfrm>
-            <a:off x="0" y="0"/>
-            <a:ext cx="73152" cy="6858000"/>
-          </a:xfrm>
-          <a:prstGeom prst="rect">
-            <a:avLst/>
-          </a:prstGeom>
-          <a:ln>
-            <a:noFill/>
-          </a:ln>
-          <a:effectLst/>
-          <a:gradFill rotWithShape="1">
-            <a:gsLst>
-              <a:gs pos="0">
-                <a:srgbClr val="410913"/>
-              </a:gs>
-              <a:gs pos="50000">
-                <a:srgbClr val="610D1C"/>
-              </a:gs>
-              <a:gs pos="100000">
-                <a:srgbClr val="A2391D"/>
-              </a:gs>
-            </a:gsLst>
-            <a:lin ang="2700000"/>
-          </a:gradFill>
-        </p:spPr>
-        <p:style>
-          <a:lnRef idx="1">
-            <a:schemeClr val="accent1"/>
-          </a:lnRef>
-          <a:fillRef idx="3">
-            <a:schemeClr val="accent1"/>
-          </a:fillRef>
-          <a:effectRef idx="2">
-            <a:schemeClr val="accent1"/>
-          </a:effectRef>
-          <a:fontRef idx="minor">
-            <a:schemeClr val="lt1"/>
-          </a:fontRef>
-        </p:style>
-        <p:txBody>
-          <a:bodyPr rtlCol="0" anchor="ctr"/>
-          <a:lstStyle/>
-          <a:p>
-            <a:pPr algn="ctr"/>
-          </a:p>
-        </p:txBody>
-      </p:sp>
-      <p:sp>
-        <p:nvSpPr>
-          <p:cNvPr id="4" name="TextBox 3"/>
-          <p:cNvSpPr txBox="1"/>
-          <p:nvPr/>
-        </p:nvSpPr>
-        <p:spPr>
-          <a:xfrm>
-            <a:off x="822960" y="457200"/>
-            <a:ext cx="10545775" cy="1051560"/>
-          </a:xfrm>
-          <a:prstGeom prst="rect">
-            <a:avLst/>
-          </a:prstGeom>
-          <a:noFill/>
-        </p:spPr>
-        <p:txBody>
-          <a:bodyPr wrap="square" anchor="t">
-            <a:spAutoFit/>
-          </a:bodyPr>
-          <a:lstStyle/>
-          <a:p>
-            <a:r>
-              <a:rPr sz="4000" b="1">
-                <a:solidFill>
-                  <a:srgbClr val="F4F1EC"/>
-                </a:solidFill>
-                <a:latin typeface="Tektur"/>
-              </a:rPr>
-              <a:t>Что мы не утверждаем</a:t>
-            </a:r>
-          </a:p>
-        </p:txBody>
-      </p:sp>
-      <p:sp>
-        <p:nvSpPr>
-          <p:cNvPr id="5" name="TextBox 4"/>
-          <p:cNvSpPr txBox="1"/>
-          <p:nvPr/>
-        </p:nvSpPr>
-        <p:spPr>
-          <a:xfrm>
-            <a:off x="822960" y="1874520"/>
-            <a:ext cx="5044287" cy="914400"/>
-          </a:xfrm>
-          <a:prstGeom prst="rect">
-            <a:avLst/>
-          </a:prstGeom>
-          <a:noFill/>
-        </p:spPr>
-        <p:txBody>
-          <a:bodyPr wrap="square" anchor="t">
-            <a:spAutoFit/>
-          </a:bodyPr>
-          <a:lstStyle/>
-          <a:p>
-            <a:r>
-              <a:rPr sz="1700" b="0">
-                <a:solidFill>
-                  <a:srgbClr val="F4F1EC"/>
-                </a:solidFill>
-                <a:latin typeface="Montserrat"/>
-              </a:rPr>
-              <a:t>•  Смысл байта флагов не установлен: в корпусе он постоянен</a:t>
-            </a:r>
-          </a:p>
-        </p:txBody>
-      </p:sp>
-      <p:sp>
-        <p:nvSpPr>
-          <p:cNvPr id="6" name="TextBox 5"/>
-          <p:cNvSpPr txBox="1"/>
-          <p:nvPr/>
-        </p:nvSpPr>
-        <p:spPr>
-          <a:xfrm>
-            <a:off x="822960" y="2788920"/>
-            <a:ext cx="5044287" cy="914400"/>
-          </a:xfrm>
-          <a:prstGeom prst="rect">
-            <a:avLst/>
-          </a:prstGeom>
-          <a:noFill/>
-        </p:spPr>
-        <p:txBody>
-          <a:bodyPr wrap="square" anchor="t">
-            <a:spAutoFit/>
-          </a:bodyPr>
-          <a:lstStyle/>
-          <a:p>
-            <a:r>
-              <a:rPr sz="1700" b="0">
-                <a:solidFill>
-                  <a:srgbClr val="F4F1EC"/>
-                </a:solidFill>
-                <a:latin typeface="Montserrat"/>
-              </a:rPr>
-              <a:t>•  Поле значения остаётся гипотезой, а не фактом</a:t>
-            </a:r>
-          </a:p>
-        </p:txBody>
-      </p:sp>
-      <p:sp>
-        <p:nvSpPr>
-          <p:cNvPr id="7" name="TextBox 6"/>
-          <p:cNvSpPr txBox="1"/>
-          <p:nvPr/>
-        </p:nvSpPr>
-        <p:spPr>
-          <a:xfrm>
-            <a:off x="6324447" y="1874520"/>
-            <a:ext cx="5044287" cy="914400"/>
-          </a:xfrm>
-          <a:prstGeom prst="rect">
-            <a:avLst/>
-          </a:prstGeom>
-          <a:noFill/>
-        </p:spPr>
-        <p:txBody>
-          <a:bodyPr wrap="square" anchor="t">
-            <a:spAutoFit/>
-          </a:bodyPr>
-          <a:lstStyle/>
-          <a:p>
-            <a:r>
-              <a:rPr sz="1700" b="0">
-                <a:solidFill>
-                  <a:srgbClr val="F4F1EC"/>
-                </a:solidFill>
-                <a:latin typeface="Montserrat"/>
-              </a:rPr>
-              <a:t>•  Альтернативные чтения берутся из заданного набора</a:t>
-            </a:r>
-          </a:p>
-        </p:txBody>
-      </p:sp>
-      <p:sp>
-        <p:nvSpPr>
-          <p:cNvPr id="8" name="TextBox 7"/>
-          <p:cNvSpPr txBox="1"/>
-          <p:nvPr/>
-        </p:nvSpPr>
-        <p:spPr>
-          <a:xfrm>
-            <a:off x="6324447" y="2788920"/>
-            <a:ext cx="5044287" cy="914400"/>
-          </a:xfrm>
-          <a:prstGeom prst="rect">
-            <a:avLst/>
-          </a:prstGeom>
-          <a:noFill/>
-        </p:spPr>
-        <p:txBody>
-          <a:bodyPr wrap="square" anchor="t">
-            <a:spAutoFit/>
-          </a:bodyPr>
-          <a:lstStyle/>
-          <a:p>
-            <a:r>
-              <a:rPr sz="1700" b="0">
-                <a:solidFill>
-                  <a:srgbClr val="F4F1EC"/>
-                </a:solidFill>
-                <a:latin typeface="Montserrat"/>
-              </a:rPr>
-              <a:t>•  Интерпретация верна для проверенных захватов и молчит вне них</a:t>
-            </a:r>
-          </a:p>
-        </p:txBody>
-      </p:sp>
-      <p:sp>
-        <p:nvSpPr>
-          <p:cNvPr id="9" name="TextBox 8"/>
-          <p:cNvSpPr txBox="1"/>
-          <p:nvPr/>
-        </p:nvSpPr>
-        <p:spPr>
-          <a:xfrm>
-            <a:off x="822960" y="6446520"/>
-            <a:ext cx="3840480" cy="274320"/>
-          </a:xfrm>
-          <a:prstGeom prst="rect">
-            <a:avLst/>
-          </a:prstGeom>
-          <a:noFill/>
-        </p:spPr>
-        <p:txBody>
-          <a:bodyPr wrap="square" anchor="t">
-            <a:spAutoFit/>
-          </a:bodyPr>
-          <a:lstStyle/>
-          <a:p>
-            <a:r>
-              <a:rPr sz="1000" b="0">
-                <a:solidFill>
-                  <a:srgbClr val="A8A29E"/>
-                </a:solidFill>
-                <a:latin typeface="Montserrat"/>
-              </a:rPr>
-              <a:t>Команда HTTP 418 · кейс #02 · Мадригал</a:t>
-            </a:r>
-          </a:p>
-        </p:txBody>
-      </p:sp>
-      <p:sp>
-        <p:nvSpPr>
-          <p:cNvPr id="10" name="TextBox 9"/>
-          <p:cNvSpPr txBox="1"/>
-          <p:nvPr/>
-        </p:nvSpPr>
-        <p:spPr>
-          <a:xfrm>
-            <a:off x="4389120" y="6446520"/>
-            <a:ext cx="3383280" cy="274320"/>
-          </a:xfrm>
-          <a:prstGeom prst="rect">
-            <a:avLst/>
-          </a:prstGeom>
-          <a:noFill/>
-        </p:spPr>
-        <p:txBody>
-          <a:bodyPr wrap="square" anchor="t">
-            <a:spAutoFit/>
-          </a:bodyPr>
-          <a:lstStyle/>
-          <a:p>
-            <a:pPr algn="ctr"/>
-            <a:r>
-              <a:rPr sz="1000" b="0">
-                <a:solidFill>
-                  <a:srgbClr val="A8A29E"/>
-                </a:solidFill>
-                <a:latin typeface="Montserrat"/>
-              </a:rPr>
-              <a:t>Границы и итог</a:t>
-            </a:r>
-          </a:p>
-        </p:txBody>
-      </p:sp>
-      <p:sp>
-        <p:nvSpPr>
-          <p:cNvPr id="11" name="TextBox 10"/>
-          <p:cNvSpPr txBox="1"/>
-          <p:nvPr/>
-        </p:nvSpPr>
-        <p:spPr>
-          <a:xfrm>
-            <a:off x="8138160" y="6446520"/>
-            <a:ext cx="3200400" cy="274320"/>
-          </a:xfrm>
-          <a:prstGeom prst="rect">
-            <a:avLst/>
-          </a:prstGeom>
-          <a:noFill/>
-        </p:spPr>
-        <p:txBody>
-          <a:bodyPr wrap="square" anchor="t">
-            <a:spAutoFit/>
-          </a:bodyPr>
-          <a:lstStyle/>
-          <a:p>
-            <a:pPr algn="r"/>
-            <a:r>
-              <a:rPr sz="1000" b="0">
-                <a:solidFill>
-                  <a:srgbClr val="A8A29E"/>
-                </a:solidFill>
-                <a:latin typeface="Montserrat"/>
-              </a:rPr>
-              <a:t>18 / 19</a:t>
-            </a:r>
-          </a:p>
-        </p:txBody>
-      </p:sp>
-    </p:spTree>
-  </p:cSld>
-  <p:clrMapOvr>
-    <a:masterClrMapping/>
-  </p:clrMapOvr>
-  <p:transition spd="med" fade="1"/>
-</p:sld>
-</file>
-
-<file path=ppt/slides/slide19.xml><?xml version="1.0" encoding="utf-8"?>
-<p:sld xmlns:a="http://schemas.openxmlformats.org/drawingml/2006/main" xmlns:p="http://schemas.openxmlformats.org/presentationml/2006/main" xmlns:r="http://schemas.openxmlformats.org/officeDocument/2006/relationships">
-  <p:cSld>
-    <p:spTree>
-      <p:nvGrpSpPr>
-        <p:cNvPr id="1" name=""/>
-        <p:cNvGrpSpPr/>
-        <p:nvPr/>
-      </p:nvGrpSpPr>
-      <p:grpSpPr/>
-      <p:sp>
-        <p:nvSpPr>
-          <p:cNvPr id="2" name="Rectangle 1"/>
-          <p:cNvSpPr/>
-          <p:nvPr/>
-        </p:nvSpPr>
-        <p:spPr>
-          <a:xfrm>
-            <a:off x="0" y="0"/>
-            <a:ext cx="12191695" cy="6858000"/>
-          </a:xfrm>
-          <a:prstGeom prst="rect">
-            <a:avLst/>
-          </a:prstGeom>
-          <a:solidFill>
-            <a:srgbClr val="0E1011"/>
-          </a:solidFill>
-          <a:ln>
-            <a:noFill/>
-          </a:ln>
-          <a:effectLst/>
-        </p:spPr>
-        <p:style>
-          <a:lnRef idx="1">
-            <a:schemeClr val="accent1"/>
-          </a:lnRef>
-          <a:fillRef idx="3">
-            <a:schemeClr val="accent1"/>
-          </a:fillRef>
-          <a:effectRef idx="2">
-            <a:schemeClr val="accent1"/>
-          </a:effectRef>
-          <a:fontRef idx="minor">
-            <a:schemeClr val="lt1"/>
-          </a:fontRef>
-        </p:style>
-        <p:txBody>
-          <a:bodyPr rtlCol="0" anchor="ctr"/>
-          <a:lstStyle/>
-          <a:p>
-            <a:pPr algn="ctr"/>
-          </a:p>
-        </p:txBody>
-      </p:sp>
-      <p:sp>
-        <p:nvSpPr>
-          <p:cNvPr id="3" name="Rectangle 2"/>
-          <p:cNvSpPr/>
-          <p:nvPr/>
-        </p:nvSpPr>
-        <p:spPr>
-          <a:xfrm>
-            <a:off x="0" y="0"/>
-            <a:ext cx="73152" cy="6858000"/>
-          </a:xfrm>
-          <a:prstGeom prst="rect">
-            <a:avLst/>
-          </a:prstGeom>
-          <a:ln>
-            <a:noFill/>
-          </a:ln>
-          <a:effectLst/>
-          <a:gradFill rotWithShape="1">
-            <a:gsLst>
-              <a:gs pos="0">
-                <a:srgbClr val="410913"/>
-              </a:gs>
-              <a:gs pos="50000">
-                <a:srgbClr val="610D1C"/>
-              </a:gs>
-              <a:gs pos="100000">
-                <a:srgbClr val="A2391D"/>
-              </a:gs>
-            </a:gsLst>
-            <a:lin ang="2700000"/>
-          </a:gradFill>
-        </p:spPr>
-        <p:style>
-          <a:lnRef idx="1">
-            <a:schemeClr val="accent1"/>
-          </a:lnRef>
-          <a:fillRef idx="3">
-            <a:schemeClr val="accent1"/>
-          </a:fillRef>
-          <a:effectRef idx="2">
-            <a:schemeClr val="accent1"/>
-          </a:effectRef>
-          <a:fontRef idx="minor">
-            <a:schemeClr val="lt1"/>
-          </a:fontRef>
-        </p:style>
-        <p:txBody>
-          <a:bodyPr rtlCol="0" anchor="ctr"/>
-          <a:lstStyle/>
-          <a:p>
-            <a:pPr algn="ctr"/>
-          </a:p>
-        </p:txBody>
-      </p:sp>
-      <p:sp>
-        <p:nvSpPr>
-          <p:cNvPr id="4" name="TextBox 3"/>
-          <p:cNvSpPr txBox="1"/>
-          <p:nvPr/>
-        </p:nvSpPr>
-        <p:spPr>
-          <a:xfrm>
-            <a:off x="914400" y="1280160"/>
-            <a:ext cx="10362895" cy="1280160"/>
-          </a:xfrm>
-          <a:prstGeom prst="rect">
-            <a:avLst/>
-          </a:prstGeom>
-          <a:noFill/>
-        </p:spPr>
-        <p:txBody>
-          <a:bodyPr wrap="square" anchor="t">
-            <a:spAutoFit/>
-          </a:bodyPr>
-          <a:lstStyle/>
-          <a:p>
-            <a:pPr algn="ctr"/>
-            <a:r>
-              <a:rPr sz="3400" b="1">
-                <a:solidFill>
-                  <a:srgbClr val="F4F1EC"/>
-                </a:solidFill>
-                <a:latin typeface="Tektur"/>
-              </a:rPr>
-              <a:t>Инструмент превращает байты в проверяемое знание</a:t>
-            </a:r>
-          </a:p>
-        </p:txBody>
-      </p:sp>
-      <p:pic>
-        <p:nvPicPr>
-          <p:cNvPr id="5" name="Picture 4" descr="qr_repo.png"/>
-          <p:cNvPicPr>
-            <a:picLocks noChangeAspect="1"/>
-          </p:cNvPicPr>
-          <p:nvPr/>
-        </p:nvPicPr>
-        <p:blipFill>
-          <a:blip r:embed="rId2"/>
-          <a:stretch>
-            <a:fillRect/>
-          </a:stretch>
-        </p:blipFill>
-        <p:spPr>
-          <a:xfrm>
             <a:off x="2118207" y="2834640"/>
             <a:ext cx="1371600" cy="1371600"/>
           </a:xfrm>
@@ -8618,6 +6714,30 @@
           </a:p>
         </p:txBody>
       </p:sp>
+      <p:pic>
+        <p:nvPicPr>
+          <p:cNvPr id="14" name="Picture 13" descr="madrigal-logo.png"/>
+          <p:cNvPicPr>
+            <a:picLocks noChangeAspect="1"/>
+          </p:cNvPicPr>
+          <p:nvPr/>
+        </p:nvPicPr>
+        <p:blipFill>
+          <a:blip r:embed="rId7"/>
+          <a:stretch>
+            <a:fillRect/>
+          </a:stretch>
+        </p:blipFill>
+        <p:spPr>
+          <a:xfrm>
+            <a:off x="5410047" y="5532120"/>
+            <a:ext cx="1371600" cy="566928"/>
+          </a:xfrm>
+          <a:prstGeom prst="rect">
+            <a:avLst/>
+          </a:prstGeom>
+        </p:spPr>
+      </p:pic>
     </p:spTree>
   </p:cSld>
   <p:clrMapOvr>
@@ -9257,7 +7377,7 @@
                 </a:solidFill>
                 <a:latin typeface="Montserrat"/>
               </a:rPr>
-              <a:t>2 / 19</a:t>
+              <a:t>2 / 14</a:t>
             </a:r>
           </a:p>
         </p:txBody>
@@ -9721,7 +7841,7 @@
                 </a:solidFill>
                 <a:latin typeface="Montserrat"/>
               </a:rPr>
-              <a:t>3 / 19</a:t>
+              <a:t>3 / 14</a:t>
             </a:r>
           </a:p>
         </p:txBody>
@@ -10509,7 +8629,7 @@
                 </a:solidFill>
                 <a:latin typeface="Montserrat"/>
               </a:rPr>
-              <a:t>4 / 19</a:t>
+              <a:t>4 / 14</a:t>
             </a:r>
           </a:p>
         </p:txBody>
@@ -11447,7 +9567,7 @@
                 </a:solidFill>
                 <a:latin typeface="Montserrat"/>
               </a:rPr>
-              <a:t>5 / 19</a:t>
+              <a:t>5 / 14</a:t>
             </a:r>
           </a:p>
         </p:txBody>
@@ -12424,7 +10544,7 @@
                 </a:solidFill>
                 <a:latin typeface="Montserrat"/>
               </a:rPr>
-              <a:t>6 / 19</a:t>
+              <a:t>6 / 14</a:t>
             </a:r>
           </a:p>
         </p:txBody>
@@ -12722,7 +10842,7 @@
         <p:spPr>
           <a:xfrm>
             <a:off x="822960" y="457200"/>
-            <a:ext cx="10545775" cy="731520"/>
+            <a:ext cx="10545775" cy="1051560"/>
           </a:xfrm>
           <a:prstGeom prst="rect">
             <a:avLst/>
@@ -12764,7 +10884,7 @@
         <p:spPr>
           <a:xfrm>
             <a:off x="822960" y="1691640"/>
-            <a:ext cx="6766560" cy="2751950"/>
+            <a:ext cx="8993392" cy="3657600"/>
           </a:xfrm>
           <a:prstGeom prst="rect">
             <a:avLst/>
@@ -12773,102 +10893,14 @@
       </p:pic>
       <p:sp>
         <p:nvSpPr>
-          <p:cNvPr id="6" name="Rectangle 5"/>
-          <p:cNvSpPr/>
-          <p:nvPr/>
-        </p:nvSpPr>
-        <p:spPr>
-          <a:xfrm>
-            <a:off x="8046720" y="1691640"/>
-            <a:ext cx="3322015" cy="1234440"/>
-          </a:xfrm>
-          <a:prstGeom prst="rect">
-            <a:avLst/>
-          </a:prstGeom>
-          <a:solidFill>
-            <a:srgbClr val="1F2124"/>
-          </a:solidFill>
-          <a:ln>
-            <a:noFill/>
-          </a:ln>
-          <a:effectLst/>
-        </p:spPr>
-        <p:style>
-          <a:lnRef idx="1">
-            <a:schemeClr val="accent1"/>
-          </a:lnRef>
-          <a:fillRef idx="3">
-            <a:schemeClr val="accent1"/>
-          </a:fillRef>
-          <a:effectRef idx="2">
-            <a:schemeClr val="accent1"/>
-          </a:effectRef>
-          <a:fontRef idx="minor">
-            <a:schemeClr val="lt1"/>
-          </a:fontRef>
-        </p:style>
-        <p:txBody>
-          <a:bodyPr rtlCol="0" anchor="ctr"/>
-          <a:lstStyle/>
-          <a:p>
-            <a:pPr algn="ctr"/>
-          </a:p>
-        </p:txBody>
-      </p:sp>
-      <p:sp>
-        <p:nvSpPr>
-          <p:cNvPr id="7" name="Rectangle 6"/>
-          <p:cNvSpPr/>
-          <p:nvPr/>
-        </p:nvSpPr>
-        <p:spPr>
-          <a:xfrm>
-            <a:off x="8046720" y="1691640"/>
-            <a:ext cx="45720" cy="1234440"/>
-          </a:xfrm>
-          <a:prstGeom prst="rect">
-            <a:avLst/>
-          </a:prstGeom>
-          <a:solidFill>
-            <a:srgbClr val="D0603A"/>
-          </a:solidFill>
-          <a:ln>
-            <a:noFill/>
-          </a:ln>
-          <a:effectLst/>
-        </p:spPr>
-        <p:style>
-          <a:lnRef idx="1">
-            <a:schemeClr val="accent1"/>
-          </a:lnRef>
-          <a:fillRef idx="3">
-            <a:schemeClr val="accent1"/>
-          </a:fillRef>
-          <a:effectRef idx="2">
-            <a:schemeClr val="accent1"/>
-          </a:effectRef>
-          <a:fontRef idx="minor">
-            <a:schemeClr val="lt1"/>
-          </a:fontRef>
-        </p:style>
-        <p:txBody>
-          <a:bodyPr rtlCol="0" anchor="ctr"/>
-          <a:lstStyle/>
-          <a:p>
-            <a:pPr algn="ctr"/>
-          </a:p>
-        </p:txBody>
-      </p:sp>
-      <p:sp>
-        <p:nvSpPr>
-          <p:cNvPr id="8" name="TextBox 7"/>
+          <p:cNvPr id="6" name="TextBox 5"/>
           <p:cNvSpPr txBox="1"/>
           <p:nvPr/>
         </p:nvSpPr>
         <p:spPr>
           <a:xfrm>
-            <a:off x="8275320" y="1920240"/>
-            <a:ext cx="2864815" cy="822960"/>
+            <a:off x="822960" y="6035040"/>
+            <a:ext cx="10545775" cy="365760"/>
           </a:xfrm>
           <a:prstGeom prst="rect">
             <a:avLst/>
@@ -12884,18 +10916,18 @@
             <a:r>
               <a:rPr sz="1400" b="0">
                 <a:solidFill>
-                  <a:srgbClr val="F4F1EC"/>
+                  <a:srgbClr val="A8A29E"/>
                 </a:solidFill>
                 <a:latin typeface="Montserrat"/>
               </a:rPr>
-              <a:t>packet 3 · seq 1001 · ts 1700000000.004 · сессия s1</a:t>
-            </a:r>
-          </a:p>
-        </p:txBody>
-      </p:sp>
-      <p:sp>
-        <p:nvSpPr>
-          <p:cNvPr id="9" name="TextBox 8"/>
+              <a:t>packet 3 · seq 1001 · сессия s1</a:t>
+            </a:r>
+          </a:p>
+        </p:txBody>
+      </p:sp>
+      <p:sp>
+        <p:nvSpPr>
+          <p:cNvPr id="7" name="TextBox 6"/>
           <p:cNvSpPr txBox="1"/>
           <p:nvPr/>
         </p:nvSpPr>
@@ -12929,7 +10961,7 @@
       </p:sp>
       <p:sp>
         <p:nvSpPr>
-          <p:cNvPr id="10" name="TextBox 9"/>
+          <p:cNvPr id="8" name="TextBox 7"/>
           <p:cNvSpPr txBox="1"/>
           <p:nvPr/>
         </p:nvSpPr>
@@ -12964,7 +10996,7 @@
       </p:sp>
       <p:sp>
         <p:nvSpPr>
-          <p:cNvPr id="11" name="TextBox 10"/>
+          <p:cNvPr id="9" name="TextBox 8"/>
           <p:cNvSpPr txBox="1"/>
           <p:nvPr/>
         </p:nvSpPr>
@@ -12992,7 +11024,7 @@
                 </a:solidFill>
                 <a:latin typeface="Montserrat"/>
               </a:rPr>
-              <a:t>7 / 19</a:t>
+              <a:t>7 / 14</a:t>
             </a:r>
           </a:p>
         </p:txBody>
@@ -13002,72 +11034,6 @@
   <p:clrMapOvr>
     <a:masterClrMapping/>
   </p:clrMapOvr>
-  <p:timing>
-    <p:tnLst>
-      <p:par>
-        <p:cTn id="1" dur="indefinite" restart="never" nodeType="tmRoot">
-          <p:childTnLst>
-            <p:seq concurrent="1" nextAc="seek">
-              <p:cTn id="2" dur="indefinite" nodeType="mainSeq">
-                <p:childTnLst>
-                  <p:par>
-                    <p:cTn id="3" presetID="10" presetClass="entr" presetSubtype="0" fill="hold" grpId="0" nodeType="clickEffect">
-                      <p:stCondLst>
-                        <p:cond delay="0"/>
-                      </p:stCondLst>
-                      <p:childTnLst>
-                        <p:set>
-                          <p:cBhvr>
-                            <p:cTn id="4" dur="1" fill="hold">
-                              <p:stCondLst>
-                                <p:cond delay="0"/>
-                              </p:stCondLst>
-                            </p:cTn>
-                            <p:tgtEl>
-                              <p:spTgt spid="5"/>
-                            </p:tgtEl>
-                            <p:attrNameLst>
-                              <p:attrName>style.visibility</p:attrName>
-                            </p:attrNameLst>
-                          </p:cBhvr>
-                          <p:to>
-                            <p:strVal val="visible"/>
-                          </p:to>
-                        </p:set>
-                        <p:anim calcmode="lin" valueType="num">
-                          <p:cBhvr additive="base">
-                            <p:cTn id="5" dur="300" fill="hold"/>
-                            <p:tgtEl>
-                              <p:spTgt spid="5"/>
-                            </p:tgtEl>
-                            <p:attrNameLst>
-                              <p:attrName>style.opacity</p:attrName>
-                            </p:attrNameLst>
-                          </p:cBhvr>
-                          <p:tavLst>
-                            <p:tav tm="0">
-                              <p:val>
-                                <p:fltVal val="0"/>
-                              </p:val>
-                            </p:tav>
-                            <p:tav tm="100000">
-                              <p:val>
-                                <p:fltVal val="1"/>
-                              </p:val>
-                            </p:tav>
-                          </p:tavLst>
-                        </p:anim>
-                      </p:childTnLst>
-                    </p:cTn>
-                  </p:par>
-                </p:childTnLst>
-              </p:cTn>
-            </p:seq>
-          </p:childTnLst>
-        </p:cTn>
-      </p:par>
-    </p:tnLst>
-  </p:timing>
   <p:transition spd="med" fade="1"/>
 </p:sld>
 </file>
@@ -13362,7 +11328,7 @@
                 </a:solidFill>
                 <a:latin typeface="Montserrat"/>
               </a:rPr>
-              <a:t>8 / 19</a:t>
+              <a:t>8 / 14</a:t>
             </a:r>
           </a:p>
         </p:txBody>
@@ -13944,7 +11910,7 @@
                 </a:solidFill>
                 <a:latin typeface="Montserrat"/>
               </a:rPr>
-              <a:t>9 / 19</a:t>
+              <a:t>9 / 14</a:t>
             </a:r>
           </a:p>
         </p:txBody>

</xml_diff>

<commit_message>
presentation: rebrand for «Мадригал» and fix slide composition
The deck carried a third-party «Волга» wordmark; the case owner is
«Мадригал». Replace it with a generated neutral mark and tighten the
layout so no slide reaches the footer band.

- add presentation/make_brand.py (wordmark + monogram), drop fstek.png
- cover/closing carry the new «Мадригал» mark; PPTX white plate removed
- style.css: rebranded gradient tokens, line-height 1.58, soft card
  shadow, faint «М» watermark in the empty corner
- slide 13 wrapped in .limits-page; trims on slides 6/7/12
- check_layout.py: 0 problems on both PDFs; 839 tests pass
</commit_message>
<xml_diff>
--- a/presentation/slides.pptx
+++ b/presentation/slides.pptx
@@ -3939,53 +3939,9 @@
           </a:p>
         </p:txBody>
       </p:sp>
-      <p:sp>
-        <p:nvSpPr>
-          <p:cNvPr id="7" name="Rectangle 6"/>
-          <p:cNvSpPr/>
-          <p:nvPr/>
-        </p:nvSpPr>
-        <p:spPr>
-          <a:xfrm>
-            <a:off x="8826703" y="1280160"/>
-            <a:ext cx="2706624" cy="804672"/>
-          </a:xfrm>
-          <a:prstGeom prst="rect">
-            <a:avLst/>
-          </a:prstGeom>
-          <a:solidFill>
-            <a:srgbClr val="FFFFFF"/>
-          </a:solidFill>
-          <a:ln>
-            <a:noFill/>
-          </a:ln>
-          <a:effectLst/>
-        </p:spPr>
-        <p:style>
-          <a:lnRef idx="1">
-            <a:schemeClr val="accent1"/>
-          </a:lnRef>
-          <a:fillRef idx="3">
-            <a:schemeClr val="accent1"/>
-          </a:fillRef>
-          <a:effectRef idx="2">
-            <a:schemeClr val="accent1"/>
-          </a:effectRef>
-          <a:fontRef idx="minor">
-            <a:schemeClr val="lt1"/>
-          </a:fontRef>
-        </p:style>
-        <p:txBody>
-          <a:bodyPr rtlCol="0" anchor="ctr"/>
-          <a:lstStyle/>
-          <a:p>
-            <a:pPr algn="ctr"/>
-          </a:p>
-        </p:txBody>
-      </p:sp>
       <p:pic>
         <p:nvPicPr>
-          <p:cNvPr id="8" name="Picture 7" descr="madrigal-logo.png"/>
+          <p:cNvPr id="7" name="Picture 6" descr="madrigal-logo.png"/>
           <p:cNvPicPr>
             <a:picLocks noChangeAspect="1"/>
           </p:cNvPicPr>
@@ -3999,14 +3955,49 @@
         </p:blipFill>
         <p:spPr>
           <a:xfrm>
-            <a:off x="8991295" y="1426464"/>
-            <a:ext cx="2377440" cy="497677"/>
+            <a:off x="8991295" y="1298448"/>
+            <a:ext cx="2377440" cy="576072"/>
           </a:xfrm>
           <a:prstGeom prst="rect">
             <a:avLst/>
           </a:prstGeom>
         </p:spPr>
       </p:pic>
+      <p:sp>
+        <p:nvSpPr>
+          <p:cNvPr id="8" name="TextBox 7"/>
+          <p:cNvSpPr txBox="1"/>
+          <p:nvPr/>
+        </p:nvSpPr>
+        <p:spPr>
+          <a:xfrm>
+            <a:off x="8991295" y="1975104"/>
+            <a:ext cx="2377440" cy="274320"/>
+          </a:xfrm>
+          <a:prstGeom prst="rect">
+            <a:avLst/>
+          </a:prstGeom>
+          <a:noFill/>
+        </p:spPr>
+        <p:txBody>
+          <a:bodyPr wrap="square" anchor="t">
+            <a:spAutoFit/>
+          </a:bodyPr>
+          <a:lstStyle/>
+          <a:p>
+            <a:pPr algn="r"/>
+            <a:r>
+              <a:rPr sz="1000" b="0">
+                <a:solidFill>
+                  <a:srgbClr val="A8A29E"/>
+                </a:solidFill>
+                <a:latin typeface="JetBrains Mono"/>
+              </a:rPr>
+              <a:t>кейс #02 · UMIRHack 2026</a:t>
+            </a:r>
+          </a:p>
+        </p:txBody>
+      </p:sp>
       <p:sp>
         <p:nvSpPr>
           <p:cNvPr id="9" name="TextBox 8"/>
@@ -7085,53 +7076,9 @@
           </a:p>
         </p:txBody>
       </p:sp>
-      <p:sp>
-        <p:nvSpPr>
-          <p:cNvPr id="14" name="Rectangle 13"/>
-          <p:cNvSpPr/>
-          <p:nvPr/>
-        </p:nvSpPr>
-        <p:spPr>
-          <a:xfrm>
-            <a:off x="4727448" y="5532120"/>
-            <a:ext cx="2743200" cy="658368"/>
-          </a:xfrm>
-          <a:prstGeom prst="rect">
-            <a:avLst/>
-          </a:prstGeom>
-          <a:solidFill>
-            <a:srgbClr val="FFFFFF"/>
-          </a:solidFill>
-          <a:ln>
-            <a:noFill/>
-          </a:ln>
-          <a:effectLst/>
-        </p:spPr>
-        <p:style>
-          <a:lnRef idx="1">
-            <a:schemeClr val="accent1"/>
-          </a:lnRef>
-          <a:fillRef idx="3">
-            <a:schemeClr val="accent1"/>
-          </a:fillRef>
-          <a:effectRef idx="2">
-            <a:schemeClr val="accent1"/>
-          </a:effectRef>
-          <a:fontRef idx="minor">
-            <a:schemeClr val="lt1"/>
-          </a:fontRef>
-        </p:style>
-        <p:txBody>
-          <a:bodyPr rtlCol="0" anchor="ctr"/>
-          <a:lstStyle/>
-          <a:p>
-            <a:pPr algn="ctr"/>
-          </a:p>
-        </p:txBody>
-      </p:sp>
       <p:pic>
         <p:nvPicPr>
-          <p:cNvPr id="15" name="Picture 14" descr="madrigal-logo.png"/>
+          <p:cNvPr id="14" name="Picture 13" descr="madrigal-logo.png"/>
           <p:cNvPicPr>
             <a:picLocks noChangeAspect="1"/>
           </p:cNvPicPr>
@@ -7146,7 +7093,7 @@
         <p:spPr>
           <a:xfrm>
             <a:off x="4910328" y="5660136"/>
-            <a:ext cx="2377440" cy="497677"/>
+            <a:ext cx="2377440" cy="576072"/>
           </a:xfrm>
           <a:prstGeom prst="rect">
             <a:avLst/>
@@ -7155,7 +7102,7 @@
       </p:pic>
       <p:sp>
         <p:nvSpPr>
-          <p:cNvPr id="16" name="TextBox 15"/>
+          <p:cNvPr id="15" name="TextBox 14"/>
           <p:cNvSpPr txBox="1"/>
           <p:nvPr/>
         </p:nvSpPr>

</xml_diff>